<commit_message>
fix(brand): lock designer logo masters
</commit_message>
<xml_diff>
--- a/artifacts/blind-build/maslow-workflow-brief.pptx
+++ b/artifacts/blind-build/maslow-workflow-brief.pptx
@@ -2,19 +2,19 @@
 <file path=ppt/presentation.xml><?xml version="1.0" encoding="utf-8"?>
 <p:presentation xmlns:p="http://schemas.openxmlformats.org/presentationml/2006/main">
   <p:sldMasterIdLst>
-    <p:sldMasterId xmlns:r="http://schemas.openxmlformats.org/officeDocument/2006/relationships" id="2147483648" r:id="R788d85f4dfe044f5"/>
-    <p:sldMasterId xmlns:r="http://schemas.openxmlformats.org/officeDocument/2006/relationships" id="2147483650" r:id="R8da1ba84408a4106"/>
+    <p:sldMasterId xmlns:r="http://schemas.openxmlformats.org/officeDocument/2006/relationships" id="2147483648" r:id="R35ccb7f1c5c04797"/>
+    <p:sldMasterId xmlns:r="http://schemas.openxmlformats.org/officeDocument/2006/relationships" id="2147483650" r:id="R3405abf9ec864894"/>
   </p:sldMasterIdLst>
   <p:notesMasterIdLst>
-    <p:notesMasterId xmlns:r="http://schemas.openxmlformats.org/officeDocument/2006/relationships" r:id="Ra80f3a1956a14533"/>
+    <p:notesMasterId xmlns:r="http://schemas.openxmlformats.org/officeDocument/2006/relationships" r:id="Raac2d6408df2486c"/>
   </p:notesMasterIdLst>
   <p:sldIdLst>
-    <p:sldId xmlns:r="http://schemas.openxmlformats.org/officeDocument/2006/relationships" id="256" r:id="R35878c1873244602"/>
-    <p:sldId xmlns:r="http://schemas.openxmlformats.org/officeDocument/2006/relationships" id="257" r:id="R7e2cc19567e54976"/>
-    <p:sldId xmlns:r="http://schemas.openxmlformats.org/officeDocument/2006/relationships" id="258" r:id="R2c852c213f604e26"/>
-    <p:sldId xmlns:r="http://schemas.openxmlformats.org/officeDocument/2006/relationships" id="259" r:id="R11e54e18193040d7"/>
-    <p:sldId xmlns:r="http://schemas.openxmlformats.org/officeDocument/2006/relationships" id="260" r:id="R5e9d56c59804492a"/>
-    <p:sldId xmlns:r="http://schemas.openxmlformats.org/officeDocument/2006/relationships" id="261" r:id="Rd84d692b94c74559"/>
+    <p:sldId xmlns:r="http://schemas.openxmlformats.org/officeDocument/2006/relationships" id="256" r:id="R162735c413a7490c"/>
+    <p:sldId xmlns:r="http://schemas.openxmlformats.org/officeDocument/2006/relationships" id="257" r:id="R6de605be2ae94f84"/>
+    <p:sldId xmlns:r="http://schemas.openxmlformats.org/officeDocument/2006/relationships" id="258" r:id="R2dc7dae63a0c4af9"/>
+    <p:sldId xmlns:r="http://schemas.openxmlformats.org/officeDocument/2006/relationships" id="259" r:id="Rf8d3255d1eb34319"/>
+    <p:sldId xmlns:r="http://schemas.openxmlformats.org/officeDocument/2006/relationships" id="260" r:id="R7e80372ace8f4c71"/>
+    <p:sldId xmlns:r="http://schemas.openxmlformats.org/officeDocument/2006/relationships" id="261" r:id="Re2900bc4cb9c4d8a"/>
   </p:sldIdLst>
   <p:sldSz cx="12192000" cy="6858000"/>
   <p:notesSz cx="6858000" cy="9144000"/>
@@ -166,7 +166,7 @@
 <file path=ppt/notesMasters/theme/theme4.xml><?xml version="1.0" encoding="utf-8"?>
 <a:theme xmlns:a="http://schemas.openxmlformats.org/drawingml/2006/main" name="ChatGPT">
   <a:themeElements>
-    <a:clrScheme name="Maslow Brand OS 1.0.0">
+    <a:clrScheme name="Maslow Brand OS 1.0.1">
       <a:dk1>
         <a:srgbClr val="333333"/>
       </a:dk1>
@@ -216,7 +216,7 @@
         <a:cs typeface="Calibri"/>
       </a:minorFont>
     </a:fontScheme>
-    <a:fmtScheme name="Maslow Brand OS 1.0.0">
+    <a:fmtScheme name="Maslow Brand OS 1.0.1">
       <a:fillStyleLst>
         <a:solidFill>
           <a:schemeClr val="phClr"/>
@@ -862,7 +862,7 @@
           <p:cNvPr id="2" name="01 Title background">
             <a:extLst xmlns:a="http://schemas.openxmlformats.org/drawingml/2006/main">
               <a:ext uri="{FF2B5EF4-FFF2-40B4-BE49-F238E27FC236}">
-                <a16:creationId xmlns:a16="http://schemas.microsoft.com/office/drawing/2014/main" id="{05A37D30-40E0-4E3B-99CE-B5FD04BB4046}"/>
+                <a16:creationId xmlns:a16="http://schemas.microsoft.com/office/drawing/2014/main" id="{D702B158-52AC-4D30-B0A7-E932F40A50DC}"/>
               </a:ext>
             </a:extLst>
           </p:cNvPr>
@@ -893,7 +893,7 @@
           <p:cNvPr id="3" name="01 Title title 0">
             <a:extLst xmlns:a="http://schemas.openxmlformats.org/drawingml/2006/main">
               <a:ext uri="{FF2B5EF4-FFF2-40B4-BE49-F238E27FC236}">
-                <a16:creationId xmlns:a16="http://schemas.microsoft.com/office/drawing/2014/main" id="{E7A3547E-76EC-400F-8959-D701E6DB83A2}"/>
+                <a16:creationId xmlns:a16="http://schemas.microsoft.com/office/drawing/2014/main" id="{B8BB96A8-059E-4416-90BF-009DE48E5837}"/>
               </a:ext>
             </a:extLst>
           </p:cNvPr>
@@ -925,7 +925,7 @@
           <p:cNvPr id="4" name="01 Title subtitle 0">
             <a:extLst xmlns:a="http://schemas.openxmlformats.org/drawingml/2006/main">
               <a:ext uri="{FF2B5EF4-FFF2-40B4-BE49-F238E27FC236}">
-                <a16:creationId xmlns:a16="http://schemas.microsoft.com/office/drawing/2014/main" id="{793A63C9-DB6B-4362-B5E1-A4B9BD658E32}"/>
+                <a16:creationId xmlns:a16="http://schemas.microsoft.com/office/drawing/2014/main" id="{4F25BACC-3EB6-4AC6-B58A-AC29B6F3D9FF}"/>
               </a:ext>
             </a:extLst>
           </p:cNvPr>
@@ -974,7 +974,7 @@
           <p:cNvPr id="2" name="02 Section background">
             <a:extLst xmlns:a="http://schemas.openxmlformats.org/drawingml/2006/main">
               <a:ext uri="{FF2B5EF4-FFF2-40B4-BE49-F238E27FC236}">
-                <a16:creationId xmlns:a16="http://schemas.microsoft.com/office/drawing/2014/main" id="{3D16892E-551C-4D31-9A74-003F96BBB840}"/>
+                <a16:creationId xmlns:a16="http://schemas.microsoft.com/office/drawing/2014/main" id="{95947083-640E-4EDB-ABDF-D55DE2CFABAC}"/>
               </a:ext>
             </a:extLst>
           </p:cNvPr>
@@ -1005,7 +1005,7 @@
           <p:cNvPr id="3" name="02 Section title 0">
             <a:extLst xmlns:a="http://schemas.openxmlformats.org/drawingml/2006/main">
               <a:ext uri="{FF2B5EF4-FFF2-40B4-BE49-F238E27FC236}">
-                <a16:creationId xmlns:a16="http://schemas.microsoft.com/office/drawing/2014/main" id="{7CC34B9B-0C69-47E8-B7E9-F91433DB8FFB}"/>
+                <a16:creationId xmlns:a16="http://schemas.microsoft.com/office/drawing/2014/main" id="{AB19F1C3-07F1-4E0C-9164-229C7834A215}"/>
               </a:ext>
             </a:extLst>
           </p:cNvPr>
@@ -1037,7 +1037,7 @@
           <p:cNvPr id="4" name="02 Section subtitle 0">
             <a:extLst xmlns:a="http://schemas.openxmlformats.org/drawingml/2006/main">
               <a:ext uri="{FF2B5EF4-FFF2-40B4-BE49-F238E27FC236}">
-                <a16:creationId xmlns:a16="http://schemas.microsoft.com/office/drawing/2014/main" id="{FB514B1D-F4B8-4847-8F1A-CA42E347F5B5}"/>
+                <a16:creationId xmlns:a16="http://schemas.microsoft.com/office/drawing/2014/main" id="{02E804B0-193E-43A4-BA26-421C4FC540C6}"/>
               </a:ext>
             </a:extLst>
           </p:cNvPr>
@@ -1086,7 +1086,7 @@
           <p:cNvPr id="2" name="03 Content background">
             <a:extLst xmlns:a="http://schemas.openxmlformats.org/drawingml/2006/main">
               <a:ext uri="{FF2B5EF4-FFF2-40B4-BE49-F238E27FC236}">
-                <a16:creationId xmlns:a16="http://schemas.microsoft.com/office/drawing/2014/main" id="{7ED3B95D-8FE7-4968-B712-FE708CDD0BF6}"/>
+                <a16:creationId xmlns:a16="http://schemas.microsoft.com/office/drawing/2014/main" id="{A6DFE8EA-19D0-4740-B3D7-0EAE771CE01B}"/>
               </a:ext>
             </a:extLst>
           </p:cNvPr>
@@ -1117,7 +1117,7 @@
           <p:cNvPr id="3" name="03 Content title 0">
             <a:extLst xmlns:a="http://schemas.openxmlformats.org/drawingml/2006/main">
               <a:ext uri="{FF2B5EF4-FFF2-40B4-BE49-F238E27FC236}">
-                <a16:creationId xmlns:a16="http://schemas.microsoft.com/office/drawing/2014/main" id="{72BC0AA3-4ED9-4D71-985F-71B9BDC08780}"/>
+                <a16:creationId xmlns:a16="http://schemas.microsoft.com/office/drawing/2014/main" id="{DEFD708E-F439-441C-94E1-7976BB9B4C79}"/>
               </a:ext>
             </a:extLst>
           </p:cNvPr>
@@ -1149,7 +1149,7 @@
           <p:cNvPr id="4" name="03 Content body 0">
             <a:extLst xmlns:a="http://schemas.openxmlformats.org/drawingml/2006/main">
               <a:ext uri="{FF2B5EF4-FFF2-40B4-BE49-F238E27FC236}">
-                <a16:creationId xmlns:a16="http://schemas.microsoft.com/office/drawing/2014/main" id="{A7324F3D-274C-41C9-B338-854BE6816875}"/>
+                <a16:creationId xmlns:a16="http://schemas.microsoft.com/office/drawing/2014/main" id="{86F3E465-27D8-49FD-9738-9BD392ADA16E}"/>
               </a:ext>
             </a:extLst>
           </p:cNvPr>
@@ -1198,7 +1198,7 @@
           <p:cNvPr id="2" name="04 Evidence background">
             <a:extLst xmlns:a="http://schemas.openxmlformats.org/drawingml/2006/main">
               <a:ext uri="{FF2B5EF4-FFF2-40B4-BE49-F238E27FC236}">
-                <a16:creationId xmlns:a16="http://schemas.microsoft.com/office/drawing/2014/main" id="{E9C31031-3E0C-4130-8043-984E7903AC95}"/>
+                <a16:creationId xmlns:a16="http://schemas.microsoft.com/office/drawing/2014/main" id="{BAC341F8-92EE-4A89-B5ED-F92B20722A12}"/>
               </a:ext>
             </a:extLst>
           </p:cNvPr>
@@ -1229,7 +1229,7 @@
           <p:cNvPr id="3" name="04 Evidence title 0">
             <a:extLst xmlns:a="http://schemas.openxmlformats.org/drawingml/2006/main">
               <a:ext uri="{FF2B5EF4-FFF2-40B4-BE49-F238E27FC236}">
-                <a16:creationId xmlns:a16="http://schemas.microsoft.com/office/drawing/2014/main" id="{C146698E-ACAA-4943-A3E5-1315D955BE34}"/>
+                <a16:creationId xmlns:a16="http://schemas.microsoft.com/office/drawing/2014/main" id="{C620546F-644C-42F7-9165-E0AA386EBAF4}"/>
               </a:ext>
             </a:extLst>
           </p:cNvPr>
@@ -1261,7 +1261,7 @@
           <p:cNvPr id="4" name="04 Evidence body 0">
             <a:extLst xmlns:a="http://schemas.openxmlformats.org/drawingml/2006/main">
               <a:ext uri="{FF2B5EF4-FFF2-40B4-BE49-F238E27FC236}">
-                <a16:creationId xmlns:a16="http://schemas.microsoft.com/office/drawing/2014/main" id="{E0005D27-DB61-4F49-9C44-234E5D423383}"/>
+                <a16:creationId xmlns:a16="http://schemas.microsoft.com/office/drawing/2014/main" id="{F78C5313-FE68-4478-9B06-15C07554F88D}"/>
               </a:ext>
             </a:extLst>
           </p:cNvPr>
@@ -1310,7 +1310,7 @@
           <p:cNvPr id="2" name="05 Quote background">
             <a:extLst xmlns:a="http://schemas.openxmlformats.org/drawingml/2006/main">
               <a:ext uri="{FF2B5EF4-FFF2-40B4-BE49-F238E27FC236}">
-                <a16:creationId xmlns:a16="http://schemas.microsoft.com/office/drawing/2014/main" id="{19DCFB01-1575-4792-A813-E72F8E0C3B98}"/>
+                <a16:creationId xmlns:a16="http://schemas.microsoft.com/office/drawing/2014/main" id="{1993B0DE-E6FE-49A3-AAEF-B485D297A6A5}"/>
               </a:ext>
             </a:extLst>
           </p:cNvPr>
@@ -1341,7 +1341,7 @@
           <p:cNvPr id="3" name="05 Quote title 0">
             <a:extLst xmlns:a="http://schemas.openxmlformats.org/drawingml/2006/main">
               <a:ext uri="{FF2B5EF4-FFF2-40B4-BE49-F238E27FC236}">
-                <a16:creationId xmlns:a16="http://schemas.microsoft.com/office/drawing/2014/main" id="{85D59962-CE85-42B3-9C4B-EFDD25E041F8}"/>
+                <a16:creationId xmlns:a16="http://schemas.microsoft.com/office/drawing/2014/main" id="{368BB7F9-2DCE-4B04-8314-6B9EEC017414}"/>
               </a:ext>
             </a:extLst>
           </p:cNvPr>
@@ -1373,7 +1373,7 @@
           <p:cNvPr id="4" name="05 Quote subtitle 0">
             <a:extLst xmlns:a="http://schemas.openxmlformats.org/drawingml/2006/main">
               <a:ext uri="{FF2B5EF4-FFF2-40B4-BE49-F238E27FC236}">
-                <a16:creationId xmlns:a16="http://schemas.microsoft.com/office/drawing/2014/main" id="{29222345-0504-4777-878F-9FB257E05007}"/>
+                <a16:creationId xmlns:a16="http://schemas.microsoft.com/office/drawing/2014/main" id="{91D4A009-03FA-4A60-ADB5-7937CABD8EBF}"/>
               </a:ext>
             </a:extLst>
           </p:cNvPr>
@@ -1422,7 +1422,7 @@
           <p:cNvPr id="2" name="06 Closing background">
             <a:extLst xmlns:a="http://schemas.openxmlformats.org/drawingml/2006/main">
               <a:ext uri="{FF2B5EF4-FFF2-40B4-BE49-F238E27FC236}">
-                <a16:creationId xmlns:a16="http://schemas.microsoft.com/office/drawing/2014/main" id="{F181ABC6-0040-4A0E-9A70-A660456DEC79}"/>
+                <a16:creationId xmlns:a16="http://schemas.microsoft.com/office/drawing/2014/main" id="{10DF850C-B4B5-4F52-8765-2280CEF553F1}"/>
               </a:ext>
             </a:extLst>
           </p:cNvPr>
@@ -1453,7 +1453,7 @@
           <p:cNvPr id="3" name="06 Closing title 0">
             <a:extLst xmlns:a="http://schemas.openxmlformats.org/drawingml/2006/main">
               <a:ext uri="{FF2B5EF4-FFF2-40B4-BE49-F238E27FC236}">
-                <a16:creationId xmlns:a16="http://schemas.microsoft.com/office/drawing/2014/main" id="{4ACD1FD7-AB90-41A3-9A70-827F7F65E693}"/>
+                <a16:creationId xmlns:a16="http://schemas.microsoft.com/office/drawing/2014/main" id="{BA9464A6-E5F9-4CDB-B0A2-A6C6169FFF42}"/>
               </a:ext>
             </a:extLst>
           </p:cNvPr>
@@ -1485,7 +1485,7 @@
           <p:cNvPr id="4" name="06 Closing subtitle 0">
             <a:extLst xmlns:a="http://schemas.openxmlformats.org/drawingml/2006/main">
               <a:ext uri="{FF2B5EF4-FFF2-40B4-BE49-F238E27FC236}">
-                <a16:creationId xmlns:a16="http://schemas.microsoft.com/office/drawing/2014/main" id="{749EEF43-EA17-4A9B-9CBB-247833D4FCB3}"/>
+                <a16:creationId xmlns:a16="http://schemas.microsoft.com/office/drawing/2014/main" id="{10519C24-4980-43C5-BF3C-B7329C978A07}"/>
               </a:ext>
             </a:extLst>
           </p:cNvPr>
@@ -1538,7 +1538,7 @@
   </p:cSld>
   <p:clrMap bg1="lt1" tx1="dk1" bg2="lt2" tx2="dk2" accent1="accent1" accent2="accent2" accent3="accent3" accent4="accent4" accent5="accent5" accent6="accent6" hlink="hlink" folHlink="folHlink"/>
   <p:sldLayoutIdLst>
-    <p:sldLayoutId xmlns:r="http://schemas.openxmlformats.org/officeDocument/2006/relationships" id="2147483649" r:id="R73bab002624943bf"/>
+    <p:sldLayoutId xmlns:r="http://schemas.openxmlformats.org/officeDocument/2006/relationships" id="2147483649" r:id="R69a44bc0e1d34c3c"/>
   </p:sldLayoutIdLst>
   <p:txStyles>
     <p:titleStyle>
@@ -1836,12 +1836,12 @@
   </p:cSld>
   <p:clrMap bg1="lt1" tx1="dk1" bg2="lt2" tx2="dk2" accent1="accent1" accent2="accent2" accent3="accent3" accent4="accent4" accent5="accent5" accent6="accent6" hlink="hlink" folHlink="folHlink"/>
   <p:sldLayoutIdLst>
-    <p:sldLayoutId xmlns:r="http://schemas.openxmlformats.org/officeDocument/2006/relationships" id="2147483651" r:id="R7c5c4fe2533940cc"/>
-    <p:sldLayoutId xmlns:r="http://schemas.openxmlformats.org/officeDocument/2006/relationships" id="2147483652" r:id="R63a7d4fef0854b33"/>
-    <p:sldLayoutId xmlns:r="http://schemas.openxmlformats.org/officeDocument/2006/relationships" id="2147483653" r:id="Rb37fa3a30cf048fa"/>
-    <p:sldLayoutId xmlns:r="http://schemas.openxmlformats.org/officeDocument/2006/relationships" id="2147483654" r:id="R281aa6c221bd4334"/>
-    <p:sldLayoutId xmlns:r="http://schemas.openxmlformats.org/officeDocument/2006/relationships" id="2147483655" r:id="Rf103ff121b5e4b69"/>
-    <p:sldLayoutId xmlns:r="http://schemas.openxmlformats.org/officeDocument/2006/relationships" id="2147483656" r:id="Rd1a5a2b0305248ab"/>
+    <p:sldLayoutId xmlns:r="http://schemas.openxmlformats.org/officeDocument/2006/relationships" id="2147483651" r:id="Rbc7c7c61e1324b42"/>
+    <p:sldLayoutId xmlns:r="http://schemas.openxmlformats.org/officeDocument/2006/relationships" id="2147483652" r:id="Rc6fb26f8716f4114"/>
+    <p:sldLayoutId xmlns:r="http://schemas.openxmlformats.org/officeDocument/2006/relationships" id="2147483653" r:id="Re92218f111e6401b"/>
+    <p:sldLayoutId xmlns:r="http://schemas.openxmlformats.org/officeDocument/2006/relationships" id="2147483654" r:id="Ra97a34abc1c94db6"/>
+    <p:sldLayoutId xmlns:r="http://schemas.openxmlformats.org/officeDocument/2006/relationships" id="2147483655" r:id="R2df8ca33ac894bde"/>
+    <p:sldLayoutId xmlns:r="http://schemas.openxmlformats.org/officeDocument/2006/relationships" id="2147483656" r:id="Rb903e2b5985c40c2"/>
   </p:sldLayoutIdLst>
 </p:sldMaster>
 </file>
@@ -1849,7 +1849,7 @@
 <file path=ppt/slideMasters/theme/theme2.xml><?xml version="1.0" encoding="utf-8"?>
 <a:theme xmlns:a="http://schemas.openxmlformats.org/drawingml/2006/main" name="ChatGPT">
   <a:themeElements>
-    <a:clrScheme name="Maslow Brand OS 1.0.0">
+    <a:clrScheme name="Maslow Brand OS 1.0.1">
       <a:dk1>
         <a:srgbClr val="333333"/>
       </a:dk1>
@@ -1899,7 +1899,7 @@
         <a:cs typeface="Calibri"/>
       </a:minorFont>
     </a:fontScheme>
-    <a:fmtScheme name="Maslow Brand OS 1.0.0">
+    <a:fmtScheme name="Maslow Brand OS 1.0.1">
       <a:fillStyleLst>
         <a:solidFill>
           <a:schemeClr val="phClr"/>
@@ -2094,7 +2094,7 @@
 <file path=ppt/slideMasters/theme/theme3.xml><?xml version="1.0" encoding="utf-8"?>
 <a:theme xmlns:a="http://schemas.openxmlformats.org/drawingml/2006/main" name="ChatGPT">
   <a:themeElements>
-    <a:clrScheme name="Maslow Brand OS 1.0.0">
+    <a:clrScheme name="Maslow Brand OS 1.0.1">
       <a:dk1>
         <a:srgbClr val="333333"/>
       </a:dk1>
@@ -2144,7 +2144,7 @@
         <a:cs typeface="Calibri"/>
       </a:minorFont>
     </a:fontScheme>
-    <a:fmtScheme name="Maslow Brand OS 1.0.0">
+    <a:fmtScheme name="Maslow Brand OS 1.0.1">
       <a:fillStyleLst>
         <a:solidFill>
           <a:schemeClr val="phClr"/>
@@ -2357,20 +2357,20 @@
       </p:grpSpPr>
       <p:pic>
         <p:nvPicPr>
-          <p:cNvPr id="6" name="Maslow AI mark" title="Maslow AI mark in white" descr="Maslow AI mark in white"/>
+          <p:cNvPr id="5" name="Maslow AI mark" title="Maslow AI mark in white" descr="Maslow AI mark in white"/>
           <p:cNvPicPr>
             <a:picLocks xmlns:a="http://schemas.openxmlformats.org/drawingml/2006/main" noChangeAspect="1"/>
           </p:cNvPicPr>
           <p:nvPr/>
         </p:nvPicPr>
         <p:blipFill>
-          <a:blip xmlns:r="http://schemas.openxmlformats.org/officeDocument/2006/relationships" xmlns:a="http://schemas.openxmlformats.org/drawingml/2006/main" r:embed="R1a2b23f0e6744639"/>
+          <a:blip xmlns:r="http://schemas.openxmlformats.org/officeDocument/2006/relationships" xmlns:a="http://schemas.openxmlformats.org/drawingml/2006/main" r:embed="R033c5816ae3e4507"/>
           <a:stretch xmlns:a="http://schemas.openxmlformats.org/drawingml/2006/main"/>
         </p:blipFill>
         <p:spPr>
           <a:xfrm xmlns:a="http://schemas.openxmlformats.org/drawingml/2006/main">
-            <a:off x="876300" y="556016"/>
-            <a:ext cx="876300" cy="583419"/>
+            <a:off x="876300" y="593071"/>
+            <a:ext cx="2667000" cy="423582"/>
           </a:xfrm>
           <a:prstGeom xmlns:a="http://schemas.openxmlformats.org/drawingml/2006/main" prst="rect">
             <a:avLst/>
@@ -2379,22 +2379,22 @@
       </p:pic>
       <p:sp>
         <p:nvSpPr>
-          <p:cNvPr id="2" name="logo-label-dark">
-            <a:extLst xmlns:a="http://schemas.openxmlformats.org/drawingml/2006/main">
-              <a:ext uri="{FF2B5EF4-FFF2-40B4-BE49-F238E27FC236}">
-                <a16:creationId xmlns:a16="http://schemas.microsoft.com/office/drawing/2014/main" id="{E44AE119-EDAE-467A-AA66-39106CCBFE0D}"/>
-              </a:ext>
-            </a:extLst>
-          </p:cNvPr>
-          <p:cNvSpPr>
-            <a:spLocks xmlns:a="http://schemas.openxmlformats.org/drawingml/2006/main" noGrp="1"/>
-          </p:cNvSpPr>
-          <p:nvPr/>
-        </p:nvSpPr>
-        <p:spPr>
-          <a:xfrm xmlns:a="http://schemas.openxmlformats.org/drawingml/2006/main">
-            <a:off x="1885950" y="704850"/>
-            <a:ext cx="1619250" cy="247650"/>
+          <p:cNvPr id="2" name="title-eyebrow">
+            <a:extLst xmlns:a="http://schemas.openxmlformats.org/drawingml/2006/main">
+              <a:ext uri="{FF2B5EF4-FFF2-40B4-BE49-F238E27FC236}">
+                <a16:creationId xmlns:a16="http://schemas.microsoft.com/office/drawing/2014/main" id="{CFC289D3-3ED1-44E8-AA90-20D82D50830F}"/>
+              </a:ext>
+            </a:extLst>
+          </p:cNvPr>
+          <p:cNvSpPr>
+            <a:spLocks xmlns:a="http://schemas.openxmlformats.org/drawingml/2006/main" noGrp="1"/>
+          </p:cNvSpPr>
+          <p:nvPr/>
+        </p:nvSpPr>
+        <p:spPr>
+          <a:xfrm xmlns:a="http://schemas.openxmlformats.org/drawingml/2006/main">
+            <a:off x="876300" y="2266950"/>
+            <a:ext cx="6667500" cy="285750"/>
           </a:xfrm>
           <a:prstGeom xmlns:a="http://schemas.openxmlformats.org/drawingml/2006/main" prst="rect">
             <a:avLst/>
@@ -2410,66 +2410,14 @@
           <a:lstStyle xmlns:a="http://schemas.openxmlformats.org/drawingml/2006/main"/>
           <a:p xmlns:a="http://schemas.openxmlformats.org/drawingml/2006/main">
             <a:pPr>
-              <a:defRPr sz="900" b="1">
-                <a:solidFill>
-                  <a:srgbClr val="FFFFFF"/>
+              <a:defRPr sz="1125" b="1">
+                <a:solidFill>
+                  <a:srgbClr val="73C1AE"/>
                 </a:solidFill>
                 <a:latin typeface="IBM Plex Mono"/>
               </a:defRPr>
             </a:pPr>
             <a:r>
-              <a:rPr sz="900" b="1">
-                <a:solidFill>
-                  <a:srgbClr val="FFFFFF"/>
-                </a:solidFill>
-                <a:latin typeface="IBM Plex Mono"/>
-              </a:rPr>
-              <a:t>MASLOW AI</a:t>
-            </a:r>
-          </a:p>
-        </p:txBody>
-      </p:sp>
-      <p:sp>
-        <p:nvSpPr>
-          <p:cNvPr id="3" name="title-eyebrow">
-            <a:extLst xmlns:a="http://schemas.openxmlformats.org/drawingml/2006/main">
-              <a:ext uri="{FF2B5EF4-FFF2-40B4-BE49-F238E27FC236}">
-                <a16:creationId xmlns:a16="http://schemas.microsoft.com/office/drawing/2014/main" id="{A7CD996C-8D26-4B57-9CFA-205E29284904}"/>
-              </a:ext>
-            </a:extLst>
-          </p:cNvPr>
-          <p:cNvSpPr>
-            <a:spLocks xmlns:a="http://schemas.openxmlformats.org/drawingml/2006/main" noGrp="1"/>
-          </p:cNvSpPr>
-          <p:nvPr/>
-        </p:nvSpPr>
-        <p:spPr>
-          <a:xfrm xmlns:a="http://schemas.openxmlformats.org/drawingml/2006/main">
-            <a:off x="876300" y="2266950"/>
-            <a:ext cx="6667500" cy="285750"/>
-          </a:xfrm>
-          <a:prstGeom xmlns:a="http://schemas.openxmlformats.org/drawingml/2006/main" prst="rect">
-            <a:avLst/>
-          </a:prstGeom>
-          <a:noFill xmlns:a="http://schemas.openxmlformats.org/drawingml/2006/main"/>
-          <a:ln xmlns:a="http://schemas.openxmlformats.org/drawingml/2006/main" w="0">
-            <a:noFill/>
-            <a:prstDash val="solid"/>
-          </a:ln>
-        </p:spPr>
-        <p:txBody>
-          <a:bodyPr xmlns:a="http://schemas.openxmlformats.org/drawingml/2006/main"/>
-          <a:lstStyle xmlns:a="http://schemas.openxmlformats.org/drawingml/2006/main"/>
-          <a:p xmlns:a="http://schemas.openxmlformats.org/drawingml/2006/main">
-            <a:pPr>
-              <a:defRPr sz="1125" b="1">
-                <a:solidFill>
-                  <a:srgbClr val="73C1AE"/>
-                </a:solidFill>
-                <a:latin typeface="IBM Plex Mono"/>
-              </a:defRPr>
-            </a:pPr>
-            <a:r>
               <a:rPr sz="1125" b="1">
                 <a:solidFill>
                   <a:srgbClr val="73C1AE"/>
@@ -2483,10 +2431,10 @@
       </p:sp>
       <p:sp>
         <p:nvSpPr>
-          <p:cNvPr id="4" name="title-heading">
-            <a:extLst xmlns:a="http://schemas.openxmlformats.org/drawingml/2006/main">
-              <a:ext uri="{FF2B5EF4-FFF2-40B4-BE49-F238E27FC236}">
-                <a16:creationId xmlns:a16="http://schemas.microsoft.com/office/drawing/2014/main" id="{480E5C9D-FE82-4F2C-8063-D5A5B9022ED3}"/>
+          <p:cNvPr id="3" name="title-heading">
+            <a:extLst xmlns:a="http://schemas.openxmlformats.org/drawingml/2006/main">
+              <a:ext uri="{FF2B5EF4-FFF2-40B4-BE49-F238E27FC236}">
+                <a16:creationId xmlns:a16="http://schemas.microsoft.com/office/drawing/2014/main" id="{37AB4F34-7B17-4842-BBA1-6F8AB1CD067E}"/>
               </a:ext>
             </a:extLst>
           </p:cNvPr>
@@ -2535,10 +2483,10 @@
       </p:sp>
       <p:sp>
         <p:nvSpPr>
-          <p:cNvPr id="5" name="title-subtitle">
-            <a:extLst xmlns:a="http://schemas.openxmlformats.org/drawingml/2006/main">
-              <a:ext uri="{FF2B5EF4-FFF2-40B4-BE49-F238E27FC236}">
-                <a16:creationId xmlns:a16="http://schemas.microsoft.com/office/drawing/2014/main" id="{62BFC0EC-30DE-4C9F-950F-8827A3A44B8C}"/>
+          <p:cNvPr id="4" name="title-subtitle">
+            <a:extLst xmlns:a="http://schemas.openxmlformats.org/drawingml/2006/main">
+              <a:ext uri="{FF2B5EF4-FFF2-40B4-BE49-F238E27FC236}">
+                <a16:creationId xmlns:a16="http://schemas.microsoft.com/office/drawing/2014/main" id="{1EA011CF-2633-4C25-808E-19E43E2D4CA4}"/>
               </a:ext>
             </a:extLst>
           </p:cNvPr>
@@ -2588,7 +2536,7 @@
     </p:spTree>
     <p:extLst>
       <p:ext uri="{BB962C8B-B14F-4D97-AF65-F5344CB8AC3E}">
-        <p14:creationId xmlns:p14="http://schemas.microsoft.com/office/powerpoint/2010/main" val="1022351060"/>
+        <p14:creationId xmlns:p14="http://schemas.microsoft.com/office/powerpoint/2010/main" val="821233293"/>
       </p:ext>
     </p:extLst>
   </p:cSld>
@@ -2619,7 +2567,7 @@
           <p:cNvPr id="5" name="section-step-marker">
             <a:extLst xmlns:a="http://schemas.openxmlformats.org/drawingml/2006/main">
               <a:ext uri="{FF2B5EF4-FFF2-40B4-BE49-F238E27FC236}">
-                <a16:creationId xmlns:a16="http://schemas.microsoft.com/office/drawing/2014/main" id="{28710129-1C75-473A-ACC4-5D4239197E9E}"/>
+                <a16:creationId xmlns:a16="http://schemas.microsoft.com/office/drawing/2014/main" id="{81F6ACCC-80D8-4EDB-8A39-A87C1D47A6C2}"/>
               </a:ext>
             </a:extLst>
           </p:cNvPr>
@@ -2671,7 +2619,7 @@
           <p:cNvPr id="2" name="section-eyebrow">
             <a:extLst xmlns:a="http://schemas.openxmlformats.org/drawingml/2006/main">
               <a:ext uri="{FF2B5EF4-FFF2-40B4-BE49-F238E27FC236}">
-                <a16:creationId xmlns:a16="http://schemas.microsoft.com/office/drawing/2014/main" id="{1AA277C5-A3B5-495A-BDF4-444E9B7BFDE0}"/>
+                <a16:creationId xmlns:a16="http://schemas.microsoft.com/office/drawing/2014/main" id="{B1E5D27B-7BCA-4376-8ECC-E06EDBADFDC4}"/>
               </a:ext>
             </a:extLst>
           </p:cNvPr>
@@ -2723,7 +2671,7 @@
           <p:cNvPr id="3" name="section-heading">
             <a:extLst xmlns:a="http://schemas.openxmlformats.org/drawingml/2006/main">
               <a:ext uri="{FF2B5EF4-FFF2-40B4-BE49-F238E27FC236}">
-                <a16:creationId xmlns:a16="http://schemas.microsoft.com/office/drawing/2014/main" id="{BC192E49-7DB2-4B36-B698-08D01FD2E052}"/>
+                <a16:creationId xmlns:a16="http://schemas.microsoft.com/office/drawing/2014/main" id="{8AA09E8C-9411-41FD-B706-119BB0B8DAFE}"/>
               </a:ext>
             </a:extLst>
           </p:cNvPr>
@@ -2775,7 +2723,7 @@
           <p:cNvPr id="4" name="section-signal">
             <a:extLst xmlns:a="http://schemas.openxmlformats.org/drawingml/2006/main">
               <a:ext uri="{FF2B5EF4-FFF2-40B4-BE49-F238E27FC236}">
-                <a16:creationId xmlns:a16="http://schemas.microsoft.com/office/drawing/2014/main" id="{7744FDB6-D569-4EC6-8D51-4345DC0E7C0A}"/>
+                <a16:creationId xmlns:a16="http://schemas.microsoft.com/office/drawing/2014/main" id="{CAF6613E-CD03-46EA-8D68-C022EB273E09}"/>
               </a:ext>
             </a:extLst>
           </p:cNvPr>
@@ -2804,7 +2752,7 @@
     </p:spTree>
     <p:extLst>
       <p:ext uri="{BB962C8B-B14F-4D97-AF65-F5344CB8AC3E}">
-        <p14:creationId xmlns:p14="http://schemas.microsoft.com/office/powerpoint/2010/main" val="1206178680"/>
+        <p14:creationId xmlns:p14="http://schemas.microsoft.com/office/powerpoint/2010/main" val="309402631"/>
       </p:ext>
     </p:extLst>
   </p:cSld>
@@ -2835,7 +2783,7 @@
           <p:cNvPr id="18" name="content-eyebrow">
             <a:extLst xmlns:a="http://schemas.openxmlformats.org/drawingml/2006/main">
               <a:ext uri="{FF2B5EF4-FFF2-40B4-BE49-F238E27FC236}">
-                <a16:creationId xmlns:a16="http://schemas.microsoft.com/office/drawing/2014/main" id="{6B79EFDE-E178-4057-B4F6-240D34E993CF}"/>
+                <a16:creationId xmlns:a16="http://schemas.microsoft.com/office/drawing/2014/main" id="{AD6C429E-C5D6-4316-862D-0D513AF70580}"/>
               </a:ext>
             </a:extLst>
           </p:cNvPr>
@@ -2887,7 +2835,7 @@
           <p:cNvPr id="2" name="content-heading">
             <a:extLst xmlns:a="http://schemas.openxmlformats.org/drawingml/2006/main">
               <a:ext uri="{FF2B5EF4-FFF2-40B4-BE49-F238E27FC236}">
-                <a16:creationId xmlns:a16="http://schemas.microsoft.com/office/drawing/2014/main" id="{6142708F-7DE2-487E-B670-CF782C3BB6D8}"/>
+                <a16:creationId xmlns:a16="http://schemas.microsoft.com/office/drawing/2014/main" id="{66324927-EC27-4F16-BEE2-429FB48CD5BC}"/>
               </a:ext>
             </a:extLst>
           </p:cNvPr>
@@ -2939,7 +2887,7 @@
           <p:cNvPr id="3" name="content-top-rule">
             <a:extLst xmlns:a="http://schemas.openxmlformats.org/drawingml/2006/main">
               <a:ext uri="{FF2B5EF4-FFF2-40B4-BE49-F238E27FC236}">
-                <a16:creationId xmlns:a16="http://schemas.microsoft.com/office/drawing/2014/main" id="{204BF55C-FDD5-4DB0-9F53-25CAC5D03A42}"/>
+                <a16:creationId xmlns:a16="http://schemas.microsoft.com/office/drawing/2014/main" id="{1A6FE772-C55B-4517-A7F3-AE3614308D8F}"/>
               </a:ext>
             </a:extLst>
           </p:cNvPr>
@@ -2970,7 +2918,7 @@
           <p:cNvPr id="4" name="content-row-01-number">
             <a:extLst xmlns:a="http://schemas.openxmlformats.org/drawingml/2006/main">
               <a:ext uri="{FF2B5EF4-FFF2-40B4-BE49-F238E27FC236}">
-                <a16:creationId xmlns:a16="http://schemas.microsoft.com/office/drawing/2014/main" id="{A8285E33-054B-4578-A22E-258C3A9DA523}"/>
+                <a16:creationId xmlns:a16="http://schemas.microsoft.com/office/drawing/2014/main" id="{2408E710-0F66-480A-B1A3-3FFB11F7D611}"/>
               </a:ext>
             </a:extLst>
           </p:cNvPr>
@@ -3022,7 +2970,7 @@
           <p:cNvPr id="5" name="content-row-01-heading">
             <a:extLst xmlns:a="http://schemas.openxmlformats.org/drawingml/2006/main">
               <a:ext uri="{FF2B5EF4-FFF2-40B4-BE49-F238E27FC236}">
-                <a16:creationId xmlns:a16="http://schemas.microsoft.com/office/drawing/2014/main" id="{2D0EFA7B-9F63-41C6-BAF5-E2AF160B173C}"/>
+                <a16:creationId xmlns:a16="http://schemas.microsoft.com/office/drawing/2014/main" id="{9BF22B8D-8E43-44D3-BCA5-44165CB55B2A}"/>
               </a:ext>
             </a:extLst>
           </p:cNvPr>
@@ -3074,7 +3022,7 @@
           <p:cNvPr id="6" name="content-row-01-body">
             <a:extLst xmlns:a="http://schemas.openxmlformats.org/drawingml/2006/main">
               <a:ext uri="{FF2B5EF4-FFF2-40B4-BE49-F238E27FC236}">
-                <a16:creationId xmlns:a16="http://schemas.microsoft.com/office/drawing/2014/main" id="{74B7F650-D3EE-4B94-AD85-7B99795EA59F}"/>
+                <a16:creationId xmlns:a16="http://schemas.microsoft.com/office/drawing/2014/main" id="{21F5BEBF-2C65-4D74-A6C6-3AE9CBC2F0EB}"/>
               </a:ext>
             </a:extLst>
           </p:cNvPr>
@@ -3126,7 +3074,7 @@
           <p:cNvPr id="7" name="content-row-01-rule">
             <a:extLst xmlns:a="http://schemas.openxmlformats.org/drawingml/2006/main">
               <a:ext uri="{FF2B5EF4-FFF2-40B4-BE49-F238E27FC236}">
-                <a16:creationId xmlns:a16="http://schemas.microsoft.com/office/drawing/2014/main" id="{D6C9F527-233E-40A5-A897-8DD580D2CE9A}"/>
+                <a16:creationId xmlns:a16="http://schemas.microsoft.com/office/drawing/2014/main" id="{CC45BA1C-67C8-442A-A305-4A4E0A956E28}"/>
               </a:ext>
             </a:extLst>
           </p:cNvPr>
@@ -3157,7 +3105,7 @@
           <p:cNvPr id="8" name="content-row-02-number">
             <a:extLst xmlns:a="http://schemas.openxmlformats.org/drawingml/2006/main">
               <a:ext uri="{FF2B5EF4-FFF2-40B4-BE49-F238E27FC236}">
-                <a16:creationId xmlns:a16="http://schemas.microsoft.com/office/drawing/2014/main" id="{9B8FFBBA-8233-4F4A-A4DA-A7605EF07C76}"/>
+                <a16:creationId xmlns:a16="http://schemas.microsoft.com/office/drawing/2014/main" id="{3BCCDE36-4096-4460-806E-D55B902C08FD}"/>
               </a:ext>
             </a:extLst>
           </p:cNvPr>
@@ -3209,7 +3157,7 @@
           <p:cNvPr id="9" name="content-row-02-heading">
             <a:extLst xmlns:a="http://schemas.openxmlformats.org/drawingml/2006/main">
               <a:ext uri="{FF2B5EF4-FFF2-40B4-BE49-F238E27FC236}">
-                <a16:creationId xmlns:a16="http://schemas.microsoft.com/office/drawing/2014/main" id="{E823F300-4772-4900-B5CF-2BE2EDD49709}"/>
+                <a16:creationId xmlns:a16="http://schemas.microsoft.com/office/drawing/2014/main" id="{67F7C9B9-3895-41FA-9DCE-2114223872FC}"/>
               </a:ext>
             </a:extLst>
           </p:cNvPr>
@@ -3261,7 +3209,7 @@
           <p:cNvPr id="10" name="content-row-02-body">
             <a:extLst xmlns:a="http://schemas.openxmlformats.org/drawingml/2006/main">
               <a:ext uri="{FF2B5EF4-FFF2-40B4-BE49-F238E27FC236}">
-                <a16:creationId xmlns:a16="http://schemas.microsoft.com/office/drawing/2014/main" id="{0C04CCBF-6C4F-4F95-BB71-C920A45B6153}"/>
+                <a16:creationId xmlns:a16="http://schemas.microsoft.com/office/drawing/2014/main" id="{0C952083-D9DF-4F47-B246-D8CAD745723B}"/>
               </a:ext>
             </a:extLst>
           </p:cNvPr>
@@ -3313,7 +3261,7 @@
           <p:cNvPr id="11" name="content-row-02-rule">
             <a:extLst xmlns:a="http://schemas.openxmlformats.org/drawingml/2006/main">
               <a:ext uri="{FF2B5EF4-FFF2-40B4-BE49-F238E27FC236}">
-                <a16:creationId xmlns:a16="http://schemas.microsoft.com/office/drawing/2014/main" id="{80CD5A9A-F3CA-49D8-8E14-E45721BA90C5}"/>
+                <a16:creationId xmlns:a16="http://schemas.microsoft.com/office/drawing/2014/main" id="{559BD11F-7742-4B93-A036-7FF7443FA283}"/>
               </a:ext>
             </a:extLst>
           </p:cNvPr>
@@ -3344,7 +3292,7 @@
           <p:cNvPr id="12" name="content-row-03-number">
             <a:extLst xmlns:a="http://schemas.openxmlformats.org/drawingml/2006/main">
               <a:ext uri="{FF2B5EF4-FFF2-40B4-BE49-F238E27FC236}">
-                <a16:creationId xmlns:a16="http://schemas.microsoft.com/office/drawing/2014/main" id="{7E85409F-724E-42FC-9A7F-8D94AA69768B}"/>
+                <a16:creationId xmlns:a16="http://schemas.microsoft.com/office/drawing/2014/main" id="{265B4B8D-A6EC-40E3-B581-3DD5C59A84D7}"/>
               </a:ext>
             </a:extLst>
           </p:cNvPr>
@@ -3396,7 +3344,7 @@
           <p:cNvPr id="13" name="content-row-03-heading">
             <a:extLst xmlns:a="http://schemas.openxmlformats.org/drawingml/2006/main">
               <a:ext uri="{FF2B5EF4-FFF2-40B4-BE49-F238E27FC236}">
-                <a16:creationId xmlns:a16="http://schemas.microsoft.com/office/drawing/2014/main" id="{1189077E-4296-4A0C-BA27-54A79EC265F9}"/>
+                <a16:creationId xmlns:a16="http://schemas.microsoft.com/office/drawing/2014/main" id="{20C1AB1B-E28F-465B-A8E5-C636CE13C9C2}"/>
               </a:ext>
             </a:extLst>
           </p:cNvPr>
@@ -3448,7 +3396,7 @@
           <p:cNvPr id="14" name="content-row-03-body">
             <a:extLst xmlns:a="http://schemas.openxmlformats.org/drawingml/2006/main">
               <a:ext uri="{FF2B5EF4-FFF2-40B4-BE49-F238E27FC236}">
-                <a16:creationId xmlns:a16="http://schemas.microsoft.com/office/drawing/2014/main" id="{86EC748B-6D54-458C-AF53-4672C23891CE}"/>
+                <a16:creationId xmlns:a16="http://schemas.microsoft.com/office/drawing/2014/main" id="{C0735FD1-EF9E-4478-BF53-C1E3E6F085F3}"/>
               </a:ext>
             </a:extLst>
           </p:cNvPr>
@@ -3500,7 +3448,7 @@
           <p:cNvPr id="15" name="content-row-03-rule">
             <a:extLst xmlns:a="http://schemas.openxmlformats.org/drawingml/2006/main">
               <a:ext uri="{FF2B5EF4-FFF2-40B4-BE49-F238E27FC236}">
-                <a16:creationId xmlns:a16="http://schemas.microsoft.com/office/drawing/2014/main" id="{E27D72FA-74BD-4191-9FF1-F4F758C2A6AE}"/>
+                <a16:creationId xmlns:a16="http://schemas.microsoft.com/office/drawing/2014/main" id="{CEF9CACA-F9A4-4C83-B652-1D40B679B428}"/>
               </a:ext>
             </a:extLst>
           </p:cNvPr>
@@ -3528,10 +3476,10 @@
       </p:sp>
       <p:sp>
         <p:nvSpPr>
-          <p:cNvPr id="16" name="footer-wordmark-1.0.0">
-            <a:extLst xmlns:a="http://schemas.openxmlformats.org/drawingml/2006/main">
-              <a:ext uri="{FF2B5EF4-FFF2-40B4-BE49-F238E27FC236}">
-                <a16:creationId xmlns:a16="http://schemas.microsoft.com/office/drawing/2014/main" id="{DD195CB1-2344-4B00-BD30-E1FA65DF7C08}"/>
+          <p:cNvPr id="16" name="footer-wordmark-1.0.1">
+            <a:extLst xmlns:a="http://schemas.openxmlformats.org/drawingml/2006/main">
+              <a:ext uri="{FF2B5EF4-FFF2-40B4-BE49-F238E27FC236}">
+                <a16:creationId xmlns:a16="http://schemas.microsoft.com/office/drawing/2014/main" id="{4582EBF9-DE2C-48B2-9FA6-74F12AB1F64E}"/>
               </a:ext>
             </a:extLst>
           </p:cNvPr>
@@ -3580,10 +3528,10 @@
       </p:sp>
       <p:sp>
         <p:nvSpPr>
-          <p:cNvPr id="17" name="footer-folio-1.0.0">
-            <a:extLst xmlns:a="http://schemas.openxmlformats.org/drawingml/2006/main">
-              <a:ext uri="{FF2B5EF4-FFF2-40B4-BE49-F238E27FC236}">
-                <a16:creationId xmlns:a16="http://schemas.microsoft.com/office/drawing/2014/main" id="{BF1D997F-8C0D-4E79-B56E-F2045C6AB8DB}"/>
+          <p:cNvPr id="17" name="footer-folio-1.0.1">
+            <a:extLst xmlns:a="http://schemas.openxmlformats.org/drawingml/2006/main">
+              <a:ext uri="{FF2B5EF4-FFF2-40B4-BE49-F238E27FC236}">
+                <a16:creationId xmlns:a16="http://schemas.microsoft.com/office/drawing/2014/main" id="{0AAC4ADF-6D57-4F6A-9F9E-A28173D8E26C}"/>
               </a:ext>
             </a:extLst>
           </p:cNvPr>
@@ -3625,7 +3573,7 @@
                 </a:solidFill>
                 <a:latin typeface="IBM Plex Mono"/>
               </a:rPr>
-              <a:t>MASLOW AI · 1.0.0</a:t>
+              <a:t>MASLOW AI · 1.0.1</a:t>
             </a:r>
           </a:p>
         </p:txBody>
@@ -3633,7 +3581,7 @@
     </p:spTree>
     <p:extLst>
       <p:ext uri="{BB962C8B-B14F-4D97-AF65-F5344CB8AC3E}">
-        <p14:creationId xmlns:p14="http://schemas.microsoft.com/office/powerpoint/2010/main" val="2047765761"/>
+        <p14:creationId xmlns:p14="http://schemas.microsoft.com/office/powerpoint/2010/main" val="1653264255"/>
       </p:ext>
     </p:extLst>
   </p:cSld>
@@ -3664,7 +3612,7 @@
           <p:cNvPr id="17" name="evidence-eyebrow">
             <a:extLst xmlns:a="http://schemas.openxmlformats.org/drawingml/2006/main">
               <a:ext uri="{FF2B5EF4-FFF2-40B4-BE49-F238E27FC236}">
-                <a16:creationId xmlns:a16="http://schemas.microsoft.com/office/drawing/2014/main" id="{8857A4A1-84C0-4AEC-8CD7-FEBF72BE7C79}"/>
+                <a16:creationId xmlns:a16="http://schemas.microsoft.com/office/drawing/2014/main" id="{80778A15-7D45-4B36-9A55-3BC167815297}"/>
               </a:ext>
             </a:extLst>
           </p:cNvPr>
@@ -3716,7 +3664,7 @@
           <p:cNvPr id="2" name="evidence-heading">
             <a:extLst xmlns:a="http://schemas.openxmlformats.org/drawingml/2006/main">
               <a:ext uri="{FF2B5EF4-FFF2-40B4-BE49-F238E27FC236}">
-                <a16:creationId xmlns:a16="http://schemas.microsoft.com/office/drawing/2014/main" id="{AB224822-78A4-4710-87D1-BC8E1EB4F5C4}"/>
+                <a16:creationId xmlns:a16="http://schemas.microsoft.com/office/drawing/2014/main" id="{D5C06998-BC54-4F09-A480-9ABD29B513C9}"/>
               </a:ext>
             </a:extLst>
           </p:cNvPr>
@@ -3768,7 +3716,7 @@
           <p:cNvPr id="3" name="evidence-ONE-rule">
             <a:extLst xmlns:a="http://schemas.openxmlformats.org/drawingml/2006/main">
               <a:ext uri="{FF2B5EF4-FFF2-40B4-BE49-F238E27FC236}">
-                <a16:creationId xmlns:a16="http://schemas.microsoft.com/office/drawing/2014/main" id="{EE592CC6-D40B-4B24-A2AD-E0026668AFFF}"/>
+                <a16:creationId xmlns:a16="http://schemas.microsoft.com/office/drawing/2014/main" id="{1295D459-603B-4901-9A5B-91E5BD851B0A}"/>
               </a:ext>
             </a:extLst>
           </p:cNvPr>
@@ -3799,7 +3747,7 @@
           <p:cNvPr id="4" name="evidence-ONE-value">
             <a:extLst xmlns:a="http://schemas.openxmlformats.org/drawingml/2006/main">
               <a:ext uri="{FF2B5EF4-FFF2-40B4-BE49-F238E27FC236}">
-                <a16:creationId xmlns:a16="http://schemas.microsoft.com/office/drawing/2014/main" id="{0A9BF385-69BA-4709-AA9D-9F072BFCD07E}"/>
+                <a16:creationId xmlns:a16="http://schemas.microsoft.com/office/drawing/2014/main" id="{547C305B-5406-4823-92A0-41AD2D5DFFFB}"/>
               </a:ext>
             </a:extLst>
           </p:cNvPr>
@@ -3851,7 +3799,7 @@
           <p:cNvPr id="5" name="evidence-ONE-claim">
             <a:extLst xmlns:a="http://schemas.openxmlformats.org/drawingml/2006/main">
               <a:ext uri="{FF2B5EF4-FFF2-40B4-BE49-F238E27FC236}">
-                <a16:creationId xmlns:a16="http://schemas.microsoft.com/office/drawing/2014/main" id="{DC645109-A478-4F08-B321-097C9C20DBEE}"/>
+                <a16:creationId xmlns:a16="http://schemas.microsoft.com/office/drawing/2014/main" id="{1BE49025-D389-4BB4-A618-E2BE2D4E9D27}"/>
               </a:ext>
             </a:extLst>
           </p:cNvPr>
@@ -3903,7 +3851,7 @@
           <p:cNvPr id="6" name="evidence-ONE-source">
             <a:extLst xmlns:a="http://schemas.openxmlformats.org/drawingml/2006/main">
               <a:ext uri="{FF2B5EF4-FFF2-40B4-BE49-F238E27FC236}">
-                <a16:creationId xmlns:a16="http://schemas.microsoft.com/office/drawing/2014/main" id="{400A246A-ACF1-43FE-8E74-72F7D1B01FD5}"/>
+                <a16:creationId xmlns:a16="http://schemas.microsoft.com/office/drawing/2014/main" id="{CEC2ABBB-FAEA-4744-AF08-2D5DDB95F0B7}"/>
               </a:ext>
             </a:extLst>
           </p:cNvPr>
@@ -3955,7 +3903,7 @@
           <p:cNvPr id="7" name="evidence-TWO-rule">
             <a:extLst xmlns:a="http://schemas.openxmlformats.org/drawingml/2006/main">
               <a:ext uri="{FF2B5EF4-FFF2-40B4-BE49-F238E27FC236}">
-                <a16:creationId xmlns:a16="http://schemas.microsoft.com/office/drawing/2014/main" id="{BEF70166-0672-4C49-B763-4BAD078507AD}"/>
+                <a16:creationId xmlns:a16="http://schemas.microsoft.com/office/drawing/2014/main" id="{62E123A0-9753-451D-8158-6581F4383E29}"/>
               </a:ext>
             </a:extLst>
           </p:cNvPr>
@@ -3986,7 +3934,7 @@
           <p:cNvPr id="8" name="evidence-TWO-value">
             <a:extLst xmlns:a="http://schemas.openxmlformats.org/drawingml/2006/main">
               <a:ext uri="{FF2B5EF4-FFF2-40B4-BE49-F238E27FC236}">
-                <a16:creationId xmlns:a16="http://schemas.microsoft.com/office/drawing/2014/main" id="{8ED04079-9CCB-4F18-8174-5ECF01EDE479}"/>
+                <a16:creationId xmlns:a16="http://schemas.microsoft.com/office/drawing/2014/main" id="{D512309F-A091-4B51-A2C4-75DFDF0FF1D9}"/>
               </a:ext>
             </a:extLst>
           </p:cNvPr>
@@ -4038,7 +3986,7 @@
           <p:cNvPr id="9" name="evidence-TWO-claim">
             <a:extLst xmlns:a="http://schemas.openxmlformats.org/drawingml/2006/main">
               <a:ext uri="{FF2B5EF4-FFF2-40B4-BE49-F238E27FC236}">
-                <a16:creationId xmlns:a16="http://schemas.microsoft.com/office/drawing/2014/main" id="{A7403A84-1DC7-4264-96DF-ED236AAA6977}"/>
+                <a16:creationId xmlns:a16="http://schemas.microsoft.com/office/drawing/2014/main" id="{A1D4B564-07E9-4D62-92D3-5A873C7857FC}"/>
               </a:ext>
             </a:extLst>
           </p:cNvPr>
@@ -4090,7 +4038,7 @@
           <p:cNvPr id="10" name="evidence-TWO-source">
             <a:extLst xmlns:a="http://schemas.openxmlformats.org/drawingml/2006/main">
               <a:ext uri="{FF2B5EF4-FFF2-40B4-BE49-F238E27FC236}">
-                <a16:creationId xmlns:a16="http://schemas.microsoft.com/office/drawing/2014/main" id="{C34F0BB8-10E5-47CF-B33D-4FC0C122013B}"/>
+                <a16:creationId xmlns:a16="http://schemas.microsoft.com/office/drawing/2014/main" id="{197EDFFC-CAB2-4E85-BAE2-7535DC039D81}"/>
               </a:ext>
             </a:extLst>
           </p:cNvPr>
@@ -4142,7 +4090,7 @@
           <p:cNvPr id="11" name="evidence-THREE-rule">
             <a:extLst xmlns:a="http://schemas.openxmlformats.org/drawingml/2006/main">
               <a:ext uri="{FF2B5EF4-FFF2-40B4-BE49-F238E27FC236}">
-                <a16:creationId xmlns:a16="http://schemas.microsoft.com/office/drawing/2014/main" id="{092E61A8-29E8-423B-8187-339F49D8BB99}"/>
+                <a16:creationId xmlns:a16="http://schemas.microsoft.com/office/drawing/2014/main" id="{62EB428C-CFCD-4E6E-AF93-B17B819605E5}"/>
               </a:ext>
             </a:extLst>
           </p:cNvPr>
@@ -4173,7 +4121,7 @@
           <p:cNvPr id="12" name="evidence-THREE-value">
             <a:extLst xmlns:a="http://schemas.openxmlformats.org/drawingml/2006/main">
               <a:ext uri="{FF2B5EF4-FFF2-40B4-BE49-F238E27FC236}">
-                <a16:creationId xmlns:a16="http://schemas.microsoft.com/office/drawing/2014/main" id="{E9B17FAB-A230-4C25-9630-A1A02A847371}"/>
+                <a16:creationId xmlns:a16="http://schemas.microsoft.com/office/drawing/2014/main" id="{C7A62892-6B09-49AA-8B90-6537BF29BC94}"/>
               </a:ext>
             </a:extLst>
           </p:cNvPr>
@@ -4225,7 +4173,7 @@
           <p:cNvPr id="13" name="evidence-THREE-claim">
             <a:extLst xmlns:a="http://schemas.openxmlformats.org/drawingml/2006/main">
               <a:ext uri="{FF2B5EF4-FFF2-40B4-BE49-F238E27FC236}">
-                <a16:creationId xmlns:a16="http://schemas.microsoft.com/office/drawing/2014/main" id="{64A232A6-3C64-4D45-BA85-E41ECD2B131E}"/>
+                <a16:creationId xmlns:a16="http://schemas.microsoft.com/office/drawing/2014/main" id="{8C9CE24E-FD19-4D4A-B1B6-F9767E00D71F}"/>
               </a:ext>
             </a:extLst>
           </p:cNvPr>
@@ -4277,7 +4225,7 @@
           <p:cNvPr id="14" name="evidence-THREE-source">
             <a:extLst xmlns:a="http://schemas.openxmlformats.org/drawingml/2006/main">
               <a:ext uri="{FF2B5EF4-FFF2-40B4-BE49-F238E27FC236}">
-                <a16:creationId xmlns:a16="http://schemas.microsoft.com/office/drawing/2014/main" id="{AFDC3DCD-ACF0-40E7-85C9-84C23AF6EC34}"/>
+                <a16:creationId xmlns:a16="http://schemas.microsoft.com/office/drawing/2014/main" id="{68857F4C-9A62-4E6C-BD5A-9B00DE820360}"/>
               </a:ext>
             </a:extLst>
           </p:cNvPr>
@@ -4326,10 +4274,10 @@
       </p:sp>
       <p:sp>
         <p:nvSpPr>
-          <p:cNvPr id="15" name="footer-wordmark-1.0.0">
-            <a:extLst xmlns:a="http://schemas.openxmlformats.org/drawingml/2006/main">
-              <a:ext uri="{FF2B5EF4-FFF2-40B4-BE49-F238E27FC236}">
-                <a16:creationId xmlns:a16="http://schemas.microsoft.com/office/drawing/2014/main" id="{2D0EEC48-BCFF-44D2-BFA8-929AFB6B3C16}"/>
+          <p:cNvPr id="15" name="footer-wordmark-1.0.1">
+            <a:extLst xmlns:a="http://schemas.openxmlformats.org/drawingml/2006/main">
+              <a:ext uri="{FF2B5EF4-FFF2-40B4-BE49-F238E27FC236}">
+                <a16:creationId xmlns:a16="http://schemas.microsoft.com/office/drawing/2014/main" id="{BDA6E332-1AA3-4359-ADD7-0447B1A394FC}"/>
               </a:ext>
             </a:extLst>
           </p:cNvPr>
@@ -4378,10 +4326,10 @@
       </p:sp>
       <p:sp>
         <p:nvSpPr>
-          <p:cNvPr id="16" name="footer-folio-1.0.0">
-            <a:extLst xmlns:a="http://schemas.openxmlformats.org/drawingml/2006/main">
-              <a:ext uri="{FF2B5EF4-FFF2-40B4-BE49-F238E27FC236}">
-                <a16:creationId xmlns:a16="http://schemas.microsoft.com/office/drawing/2014/main" id="{C8477759-A4B8-46B1-ACD4-680534F17AE9}"/>
+          <p:cNvPr id="16" name="footer-folio-1.0.1">
+            <a:extLst xmlns:a="http://schemas.openxmlformats.org/drawingml/2006/main">
+              <a:ext uri="{FF2B5EF4-FFF2-40B4-BE49-F238E27FC236}">
+                <a16:creationId xmlns:a16="http://schemas.microsoft.com/office/drawing/2014/main" id="{2B183F8D-5F06-474A-B0AE-FAAC9CCA745B}"/>
               </a:ext>
             </a:extLst>
           </p:cNvPr>
@@ -4423,7 +4371,7 @@
                 </a:solidFill>
                 <a:latin typeface="IBM Plex Mono"/>
               </a:rPr>
-              <a:t>MASLOW AI · 1.0.0</a:t>
+              <a:t>MASLOW AI · 1.0.1</a:t>
             </a:r>
           </a:p>
         </p:txBody>
@@ -4431,7 +4379,7 @@
     </p:spTree>
     <p:extLst>
       <p:ext uri="{BB962C8B-B14F-4D97-AF65-F5344CB8AC3E}">
-        <p14:creationId xmlns:p14="http://schemas.microsoft.com/office/powerpoint/2010/main" val="60549500"/>
+        <p14:creationId xmlns:p14="http://schemas.microsoft.com/office/powerpoint/2010/main" val="339765449"/>
       </p:ext>
     </p:extLst>
   </p:cSld>
@@ -4462,7 +4410,7 @@
           <p:cNvPr id="5" name="quote-mark">
             <a:extLst xmlns:a="http://schemas.openxmlformats.org/drawingml/2006/main">
               <a:ext uri="{FF2B5EF4-FFF2-40B4-BE49-F238E27FC236}">
-                <a16:creationId xmlns:a16="http://schemas.microsoft.com/office/drawing/2014/main" id="{3E4B8393-2793-4CFD-BF39-CBAC7356107C}"/>
+                <a16:creationId xmlns:a16="http://schemas.microsoft.com/office/drawing/2014/main" id="{A9B64012-2036-4857-A0E7-A754394A599C}"/>
               </a:ext>
             </a:extLst>
           </p:cNvPr>
@@ -4514,7 +4462,7 @@
           <p:cNvPr id="2" name="quote-text">
             <a:extLst xmlns:a="http://schemas.openxmlformats.org/drawingml/2006/main">
               <a:ext uri="{FF2B5EF4-FFF2-40B4-BE49-F238E27FC236}">
-                <a16:creationId xmlns:a16="http://schemas.microsoft.com/office/drawing/2014/main" id="{680DDC9A-43A0-466B-BBB8-33C66E5360E1}"/>
+                <a16:creationId xmlns:a16="http://schemas.microsoft.com/office/drawing/2014/main" id="{B6366759-B70B-4541-86A3-DC1C95D8A341}"/>
               </a:ext>
             </a:extLst>
           </p:cNvPr>
@@ -4566,7 +4514,7 @@
           <p:cNvPr id="3" name="quote-attribution">
             <a:extLst xmlns:a="http://schemas.openxmlformats.org/drawingml/2006/main">
               <a:ext uri="{FF2B5EF4-FFF2-40B4-BE49-F238E27FC236}">
-                <a16:creationId xmlns:a16="http://schemas.microsoft.com/office/drawing/2014/main" id="{9BDF5853-0C30-43D1-91F1-A49092DC2F3E}"/>
+                <a16:creationId xmlns:a16="http://schemas.microsoft.com/office/drawing/2014/main" id="{80A3613B-9F2A-443F-B9C2-CCD831507F1E}"/>
               </a:ext>
             </a:extLst>
           </p:cNvPr>
@@ -4618,7 +4566,7 @@
           <p:cNvPr id="4" name="quote-source">
             <a:extLst xmlns:a="http://schemas.openxmlformats.org/drawingml/2006/main">
               <a:ext uri="{FF2B5EF4-FFF2-40B4-BE49-F238E27FC236}">
-                <a16:creationId xmlns:a16="http://schemas.microsoft.com/office/drawing/2014/main" id="{CDC85B93-36D7-4619-9AA4-CE5C95571CED}"/>
+                <a16:creationId xmlns:a16="http://schemas.microsoft.com/office/drawing/2014/main" id="{42299E4E-0083-4A4A-88BF-4798878E37E5}"/>
               </a:ext>
             </a:extLst>
           </p:cNvPr>
@@ -4668,7 +4616,7 @@
     </p:spTree>
     <p:extLst>
       <p:ext uri="{BB962C8B-B14F-4D97-AF65-F5344CB8AC3E}">
-        <p14:creationId xmlns:p14="http://schemas.microsoft.com/office/powerpoint/2010/main" val="1162015865"/>
+        <p14:creationId xmlns:p14="http://schemas.microsoft.com/office/powerpoint/2010/main" val="2048449560"/>
       </p:ext>
     </p:extLst>
   </p:cSld>
@@ -4696,20 +4644,20 @@
       </p:grpSpPr>
       <p:pic>
         <p:nvPicPr>
-          <p:cNvPr id="10" name="Maslow AI mark" title="Maslow AI mark in navy" descr="Maslow AI mark in navy"/>
+          <p:cNvPr id="9" name="Maslow AI mark" title="Maslow AI mark in navy" descr="Maslow AI mark in navy"/>
           <p:cNvPicPr>
             <a:picLocks xmlns:a="http://schemas.openxmlformats.org/drawingml/2006/main" noChangeAspect="1"/>
           </p:cNvPicPr>
           <p:nvPr/>
         </p:nvPicPr>
         <p:blipFill>
-          <a:blip xmlns:r="http://schemas.openxmlformats.org/officeDocument/2006/relationships" xmlns:a="http://schemas.openxmlformats.org/drawingml/2006/main" r:embed="Rb0ed114441fe4953"/>
+          <a:blip xmlns:r="http://schemas.openxmlformats.org/officeDocument/2006/relationships" xmlns:a="http://schemas.openxmlformats.org/drawingml/2006/main" r:embed="Re4d4575e7f404fe7"/>
           <a:stretch xmlns:a="http://schemas.openxmlformats.org/drawingml/2006/main"/>
         </p:blipFill>
         <p:spPr>
           <a:xfrm xmlns:a="http://schemas.openxmlformats.org/drawingml/2006/main">
-            <a:off x="876300" y="556016"/>
-            <a:ext cx="876300" cy="583419"/>
+            <a:off x="876300" y="593071"/>
+            <a:ext cx="2667000" cy="423582"/>
           </a:xfrm>
           <a:prstGeom xmlns:a="http://schemas.openxmlformats.org/drawingml/2006/main" prst="rect">
             <a:avLst/>
@@ -4718,22 +4666,22 @@
       </p:pic>
       <p:sp>
         <p:nvSpPr>
-          <p:cNvPr id="2" name="logo-label-light">
-            <a:extLst xmlns:a="http://schemas.openxmlformats.org/drawingml/2006/main">
-              <a:ext uri="{FF2B5EF4-FFF2-40B4-BE49-F238E27FC236}">
-                <a16:creationId xmlns:a16="http://schemas.microsoft.com/office/drawing/2014/main" id="{9243FCD3-4818-42B2-B733-FB61B253B3C4}"/>
-              </a:ext>
-            </a:extLst>
-          </p:cNvPr>
-          <p:cNvSpPr>
-            <a:spLocks xmlns:a="http://schemas.openxmlformats.org/drawingml/2006/main" noGrp="1"/>
-          </p:cNvSpPr>
-          <p:nvPr/>
-        </p:nvSpPr>
-        <p:spPr>
-          <a:xfrm xmlns:a="http://schemas.openxmlformats.org/drawingml/2006/main">
-            <a:off x="1885950" y="704850"/>
-            <a:ext cx="1619250" cy="247650"/>
+          <p:cNvPr id="2" name="closing-heading">
+            <a:extLst xmlns:a="http://schemas.openxmlformats.org/drawingml/2006/main">
+              <a:ext uri="{FF2B5EF4-FFF2-40B4-BE49-F238E27FC236}">
+                <a16:creationId xmlns:a16="http://schemas.microsoft.com/office/drawing/2014/main" id="{1271DD22-2DB8-4828-9525-8920C3095679}"/>
+              </a:ext>
+            </a:extLst>
+          </p:cNvPr>
+          <p:cNvSpPr>
+            <a:spLocks xmlns:a="http://schemas.openxmlformats.org/drawingml/2006/main" noGrp="1"/>
+          </p:cNvSpPr>
+          <p:nvPr/>
+        </p:nvSpPr>
+        <p:spPr>
+          <a:xfrm xmlns:a="http://schemas.openxmlformats.org/drawingml/2006/main">
+            <a:off x="876300" y="2133600"/>
+            <a:ext cx="10001250" cy="1428750"/>
           </a:xfrm>
           <a:prstGeom xmlns:a="http://schemas.openxmlformats.org/drawingml/2006/main" prst="rect">
             <a:avLst/>
@@ -4749,17 +4697,235 @@
           <a:lstStyle xmlns:a="http://schemas.openxmlformats.org/drawingml/2006/main"/>
           <a:p xmlns:a="http://schemas.openxmlformats.org/drawingml/2006/main">
             <a:pPr>
-              <a:defRPr sz="900" b="1">
+              <a:defRPr sz="3900" b="1">
                 <a:solidFill>
                   <a:srgbClr val="192332"/>
+                </a:solidFill>
+                <a:latin typeface="Manrope"/>
+              </a:defRPr>
+            </a:pPr>
+            <a:r>
+              <a:rPr sz="3900" b="1">
+                <a:solidFill>
+                  <a:srgbClr val="192332"/>
+                </a:solidFill>
+                <a:latin typeface="Manrope"/>
+              </a:rPr>
+              <a:t>Bring one waiting workflow</a:t>
+            </a:r>
+          </a:p>
+        </p:txBody>
+      </p:sp>
+      <p:sp>
+        <p:nvSpPr>
+          <p:cNvPr id="3" name="closing-action">
+            <a:extLst xmlns:a="http://schemas.openxmlformats.org/drawingml/2006/main">
+              <a:ext uri="{FF2B5EF4-FFF2-40B4-BE49-F238E27FC236}">
+                <a16:creationId xmlns:a16="http://schemas.microsoft.com/office/drawing/2014/main" id="{F76119AB-0A0F-4ECC-93AC-AEFBC4B9D310}"/>
+              </a:ext>
+            </a:extLst>
+          </p:cNvPr>
+          <p:cNvSpPr>
+            <a:spLocks xmlns:a="http://schemas.openxmlformats.org/drawingml/2006/main" noGrp="1"/>
+          </p:cNvSpPr>
+          <p:nvPr/>
+        </p:nvSpPr>
+        <p:spPr>
+          <a:xfrm xmlns:a="http://schemas.openxmlformats.org/drawingml/2006/main">
+            <a:off x="876300" y="4038600"/>
+            <a:ext cx="4000500" cy="685800"/>
+          </a:xfrm>
+          <a:prstGeom xmlns:a="http://schemas.openxmlformats.org/drawingml/2006/main" prst="rect">
+            <a:avLst/>
+          </a:prstGeom>
+          <a:solidFill xmlns:a="http://schemas.openxmlformats.org/drawingml/2006/main">
+            <a:srgbClr val="192332"/>
+          </a:solidFill>
+          <a:ln xmlns:a="http://schemas.openxmlformats.org/drawingml/2006/main" w="0">
+            <a:noFill/>
+            <a:prstDash val="solid"/>
+          </a:ln>
+        </p:spPr>
+      </p:sp>
+      <p:sp>
+        <p:nvSpPr>
+          <p:cNvPr id="4" name="closing-action-label">
+            <a:extLst xmlns:a="http://schemas.openxmlformats.org/drawingml/2006/main">
+              <a:ext uri="{FF2B5EF4-FFF2-40B4-BE49-F238E27FC236}">
+                <a16:creationId xmlns:a16="http://schemas.microsoft.com/office/drawing/2014/main" id="{F00AEAFF-D271-44EB-ABD5-5ABC58F2BAB4}"/>
+              </a:ext>
+            </a:extLst>
+          </p:cNvPr>
+          <p:cNvSpPr>
+            <a:spLocks xmlns:a="http://schemas.openxmlformats.org/drawingml/2006/main" noGrp="1"/>
+          </p:cNvSpPr>
+          <p:nvPr/>
+        </p:nvSpPr>
+        <p:spPr>
+          <a:xfrm xmlns:a="http://schemas.openxmlformats.org/drawingml/2006/main">
+            <a:off x="1143000" y="4248150"/>
+            <a:ext cx="3333750" cy="266700"/>
+          </a:xfrm>
+          <a:prstGeom xmlns:a="http://schemas.openxmlformats.org/drawingml/2006/main" prst="rect">
+            <a:avLst/>
+          </a:prstGeom>
+          <a:noFill xmlns:a="http://schemas.openxmlformats.org/drawingml/2006/main"/>
+          <a:ln xmlns:a="http://schemas.openxmlformats.org/drawingml/2006/main" w="0">
+            <a:noFill/>
+            <a:prstDash val="solid"/>
+          </a:ln>
+        </p:spPr>
+        <p:txBody>
+          <a:bodyPr xmlns:a="http://schemas.openxmlformats.org/drawingml/2006/main"/>
+          <a:lstStyle xmlns:a="http://schemas.openxmlformats.org/drawingml/2006/main"/>
+          <a:p xmlns:a="http://schemas.openxmlformats.org/drawingml/2006/main">
+            <a:pPr>
+              <a:defRPr sz="1200" b="1">
+                <a:solidFill>
+                  <a:srgbClr val="FFFFFF"/>
                 </a:solidFill>
                 <a:latin typeface="IBM Plex Mono"/>
               </a:defRPr>
             </a:pPr>
             <a:r>
+              <a:rPr sz="1200" b="1">
+                <a:solidFill>
+                  <a:srgbClr val="FFFFFF"/>
+                </a:solidFill>
+                <a:latin typeface="IBM Plex Mono"/>
+              </a:rPr>
+              <a:t>BOOK A WORKING SESSION</a:t>
+            </a:r>
+          </a:p>
+        </p:txBody>
+      </p:sp>
+      <p:sp>
+        <p:nvSpPr>
+          <p:cNvPr id="5" name="closing-action-signal">
+            <a:extLst xmlns:a="http://schemas.openxmlformats.org/drawingml/2006/main">
+              <a:ext uri="{FF2B5EF4-FFF2-40B4-BE49-F238E27FC236}">
+                <a16:creationId xmlns:a16="http://schemas.microsoft.com/office/drawing/2014/main" id="{244CEB53-52D7-4BDD-8955-302066B493E3}"/>
+              </a:ext>
+            </a:extLst>
+          </p:cNvPr>
+          <p:cNvSpPr>
+            <a:spLocks xmlns:a="http://schemas.openxmlformats.org/drawingml/2006/main" noGrp="1"/>
+          </p:cNvSpPr>
+          <p:nvPr/>
+        </p:nvSpPr>
+        <p:spPr>
+          <a:xfrm xmlns:a="http://schemas.openxmlformats.org/drawingml/2006/main">
+            <a:off x="876300" y="4686300"/>
+            <a:ext cx="457200" cy="38100"/>
+          </a:xfrm>
+          <a:prstGeom xmlns:a="http://schemas.openxmlformats.org/drawingml/2006/main" prst="rect">
+            <a:avLst/>
+          </a:prstGeom>
+          <a:solidFill xmlns:a="http://schemas.openxmlformats.org/drawingml/2006/main">
+            <a:srgbClr val="EE7BB3"/>
+          </a:solidFill>
+          <a:ln xmlns:a="http://schemas.openxmlformats.org/drawingml/2006/main" w="0">
+            <a:noFill/>
+            <a:prstDash val="solid"/>
+          </a:ln>
+        </p:spPr>
+      </p:sp>
+      <p:sp>
+        <p:nvSpPr>
+          <p:cNvPr id="6" name="closing-contact">
+            <a:extLst xmlns:a="http://schemas.openxmlformats.org/drawingml/2006/main">
+              <a:ext uri="{FF2B5EF4-FFF2-40B4-BE49-F238E27FC236}">
+                <a16:creationId xmlns:a16="http://schemas.microsoft.com/office/drawing/2014/main" id="{2FCD7C76-1067-4A41-AA64-5A3A1D9AC880}"/>
+              </a:ext>
+            </a:extLst>
+          </p:cNvPr>
+          <p:cNvSpPr>
+            <a:spLocks xmlns:a="http://schemas.openxmlformats.org/drawingml/2006/main" noGrp="1"/>
+          </p:cNvSpPr>
+          <p:nvPr/>
+        </p:nvSpPr>
+        <p:spPr>
+          <a:xfrm xmlns:a="http://schemas.openxmlformats.org/drawingml/2006/main">
+            <a:off x="876300" y="5105400"/>
+            <a:ext cx="6667500" cy="323850"/>
+          </a:xfrm>
+          <a:prstGeom xmlns:a="http://schemas.openxmlformats.org/drawingml/2006/main" prst="rect">
+            <a:avLst/>
+          </a:prstGeom>
+          <a:noFill xmlns:a="http://schemas.openxmlformats.org/drawingml/2006/main"/>
+          <a:ln xmlns:a="http://schemas.openxmlformats.org/drawingml/2006/main" w="0">
+            <a:noFill/>
+            <a:prstDash val="solid"/>
+          </a:ln>
+        </p:spPr>
+        <p:txBody>
+          <a:bodyPr xmlns:a="http://schemas.openxmlformats.org/drawingml/2006/main"/>
+          <a:lstStyle xmlns:a="http://schemas.openxmlformats.org/drawingml/2006/main"/>
+          <a:p xmlns:a="http://schemas.openxmlformats.org/drawingml/2006/main">
+            <a:pPr>
+              <a:defRPr sz="975">
+                <a:solidFill>
+                  <a:srgbClr val="666666"/>
+                </a:solidFill>
+                <a:latin typeface="IBM Plex Mono"/>
+              </a:defRPr>
+            </a:pPr>
+            <a:r>
+              <a:rPr sz="975">
+                <a:solidFill>
+                  <a:srgbClr val="666666"/>
+                </a:solidFill>
+                <a:latin typeface="IBM Plex Mono"/>
+              </a:rPr>
+              <a:t>MASLOW.AI</a:t>
+            </a:r>
+          </a:p>
+        </p:txBody>
+      </p:sp>
+      <p:sp>
+        <p:nvSpPr>
+          <p:cNvPr id="7" name="footer-wordmark-1.0.1">
+            <a:extLst xmlns:a="http://schemas.openxmlformats.org/drawingml/2006/main">
+              <a:ext uri="{FF2B5EF4-FFF2-40B4-BE49-F238E27FC236}">
+                <a16:creationId xmlns:a16="http://schemas.microsoft.com/office/drawing/2014/main" id="{F1052A9D-23A1-4F64-917E-F7FE289DEF69}"/>
+              </a:ext>
+            </a:extLst>
+          </p:cNvPr>
+          <p:cNvSpPr>
+            <a:spLocks xmlns:a="http://schemas.openxmlformats.org/drawingml/2006/main" noGrp="1"/>
+          </p:cNvSpPr>
+          <p:nvPr/>
+        </p:nvSpPr>
+        <p:spPr>
+          <a:xfrm xmlns:a="http://schemas.openxmlformats.org/drawingml/2006/main">
+            <a:off x="876300" y="6362700"/>
+            <a:ext cx="1714500" cy="228600"/>
+          </a:xfrm>
+          <a:prstGeom xmlns:a="http://schemas.openxmlformats.org/drawingml/2006/main" prst="rect">
+            <a:avLst/>
+          </a:prstGeom>
+          <a:noFill xmlns:a="http://schemas.openxmlformats.org/drawingml/2006/main"/>
+          <a:ln xmlns:a="http://schemas.openxmlformats.org/drawingml/2006/main" w="0">
+            <a:noFill/>
+            <a:prstDash val="solid"/>
+          </a:ln>
+        </p:spPr>
+        <p:txBody>
+          <a:bodyPr xmlns:a="http://schemas.openxmlformats.org/drawingml/2006/main"/>
+          <a:lstStyle xmlns:a="http://schemas.openxmlformats.org/drawingml/2006/main"/>
+          <a:p xmlns:a="http://schemas.openxmlformats.org/drawingml/2006/main">
+            <a:pPr>
+              <a:defRPr sz="900" b="1">
+                <a:solidFill>
+                  <a:srgbClr val="A5A5A5"/>
+                </a:solidFill>
+                <a:latin typeface="IBM Plex Mono"/>
+              </a:defRPr>
+            </a:pPr>
+            <a:r>
               <a:rPr sz="900" b="1">
                 <a:solidFill>
-                  <a:srgbClr val="192332"/>
+                  <a:srgbClr val="A5A5A5"/>
                 </a:solidFill>
                 <a:latin typeface="IBM Plex Mono"/>
               </a:rPr>
@@ -4770,22 +4936,22 @@
       </p:sp>
       <p:sp>
         <p:nvSpPr>
-          <p:cNvPr id="3" name="closing-heading">
-            <a:extLst xmlns:a="http://schemas.openxmlformats.org/drawingml/2006/main">
-              <a:ext uri="{FF2B5EF4-FFF2-40B4-BE49-F238E27FC236}">
-                <a16:creationId xmlns:a16="http://schemas.microsoft.com/office/drawing/2014/main" id="{BD6577BE-E055-4971-B4C1-870AD3B84435}"/>
-              </a:ext>
-            </a:extLst>
-          </p:cNvPr>
-          <p:cNvSpPr>
-            <a:spLocks xmlns:a="http://schemas.openxmlformats.org/drawingml/2006/main" noGrp="1"/>
-          </p:cNvSpPr>
-          <p:nvPr/>
-        </p:nvSpPr>
-        <p:spPr>
-          <a:xfrm xmlns:a="http://schemas.openxmlformats.org/drawingml/2006/main">
-            <a:off x="876300" y="2133600"/>
-            <a:ext cx="10001250" cy="1428750"/>
+          <p:cNvPr id="8" name="footer-folio-1.0.1">
+            <a:extLst xmlns:a="http://schemas.openxmlformats.org/drawingml/2006/main">
+              <a:ext uri="{FF2B5EF4-FFF2-40B4-BE49-F238E27FC236}">
+                <a16:creationId xmlns:a16="http://schemas.microsoft.com/office/drawing/2014/main" id="{6211CA7C-2C04-4ADF-87D7-3B77DA773A1F}"/>
+              </a:ext>
+            </a:extLst>
+          </p:cNvPr>
+          <p:cNvSpPr>
+            <a:spLocks xmlns:a="http://schemas.openxmlformats.org/drawingml/2006/main" noGrp="1"/>
+          </p:cNvSpPr>
+          <p:nvPr/>
+        </p:nvSpPr>
+        <p:spPr>
+          <a:xfrm xmlns:a="http://schemas.openxmlformats.org/drawingml/2006/main">
+            <a:off x="9601200" y="6362700"/>
+            <a:ext cx="1714500" cy="228600"/>
           </a:xfrm>
           <a:prstGeom xmlns:a="http://schemas.openxmlformats.org/drawingml/2006/main" prst="rect">
             <a:avLst/>
@@ -4800,292 +4966,22 @@
           <a:bodyPr xmlns:a="http://schemas.openxmlformats.org/drawingml/2006/main"/>
           <a:lstStyle xmlns:a="http://schemas.openxmlformats.org/drawingml/2006/main"/>
           <a:p xmlns:a="http://schemas.openxmlformats.org/drawingml/2006/main">
-            <a:pPr>
-              <a:defRPr sz="3900" b="1">
-                <a:solidFill>
-                  <a:srgbClr val="192332"/>
-                </a:solidFill>
-                <a:latin typeface="Manrope"/>
-              </a:defRPr>
-            </a:pPr>
-            <a:r>
-              <a:rPr sz="3900" b="1">
-                <a:solidFill>
-                  <a:srgbClr val="192332"/>
-                </a:solidFill>
-                <a:latin typeface="Manrope"/>
-              </a:rPr>
-              <a:t>Bring one waiting workflow</a:t>
-            </a:r>
-          </a:p>
-        </p:txBody>
-      </p:sp>
-      <p:sp>
-        <p:nvSpPr>
-          <p:cNvPr id="4" name="closing-action">
-            <a:extLst xmlns:a="http://schemas.openxmlformats.org/drawingml/2006/main">
-              <a:ext uri="{FF2B5EF4-FFF2-40B4-BE49-F238E27FC236}">
-                <a16:creationId xmlns:a16="http://schemas.microsoft.com/office/drawing/2014/main" id="{5A092CE0-7484-4904-8315-F808301C8C08}"/>
-              </a:ext>
-            </a:extLst>
-          </p:cNvPr>
-          <p:cNvSpPr>
-            <a:spLocks xmlns:a="http://schemas.openxmlformats.org/drawingml/2006/main" noGrp="1"/>
-          </p:cNvSpPr>
-          <p:nvPr/>
-        </p:nvSpPr>
-        <p:spPr>
-          <a:xfrm xmlns:a="http://schemas.openxmlformats.org/drawingml/2006/main">
-            <a:off x="876300" y="4038600"/>
-            <a:ext cx="4000500" cy="685800"/>
-          </a:xfrm>
-          <a:prstGeom xmlns:a="http://schemas.openxmlformats.org/drawingml/2006/main" prst="rect">
-            <a:avLst/>
-          </a:prstGeom>
-          <a:solidFill xmlns:a="http://schemas.openxmlformats.org/drawingml/2006/main">
-            <a:srgbClr val="192332"/>
-          </a:solidFill>
-          <a:ln xmlns:a="http://schemas.openxmlformats.org/drawingml/2006/main" w="0">
-            <a:noFill/>
-            <a:prstDash val="solid"/>
-          </a:ln>
-        </p:spPr>
-      </p:sp>
-      <p:sp>
-        <p:nvSpPr>
-          <p:cNvPr id="5" name="closing-action-label">
-            <a:extLst xmlns:a="http://schemas.openxmlformats.org/drawingml/2006/main">
-              <a:ext uri="{FF2B5EF4-FFF2-40B4-BE49-F238E27FC236}">
-                <a16:creationId xmlns:a16="http://schemas.microsoft.com/office/drawing/2014/main" id="{520606EC-CB03-46D1-9FC0-B1B85538B9BB}"/>
-              </a:ext>
-            </a:extLst>
-          </p:cNvPr>
-          <p:cNvSpPr>
-            <a:spLocks xmlns:a="http://schemas.openxmlformats.org/drawingml/2006/main" noGrp="1"/>
-          </p:cNvSpPr>
-          <p:nvPr/>
-        </p:nvSpPr>
-        <p:spPr>
-          <a:xfrm xmlns:a="http://schemas.openxmlformats.org/drawingml/2006/main">
-            <a:off x="1143000" y="4248150"/>
-            <a:ext cx="3333750" cy="266700"/>
-          </a:xfrm>
-          <a:prstGeom xmlns:a="http://schemas.openxmlformats.org/drawingml/2006/main" prst="rect">
-            <a:avLst/>
-          </a:prstGeom>
-          <a:noFill xmlns:a="http://schemas.openxmlformats.org/drawingml/2006/main"/>
-          <a:ln xmlns:a="http://schemas.openxmlformats.org/drawingml/2006/main" w="0">
-            <a:noFill/>
-            <a:prstDash val="solid"/>
-          </a:ln>
-        </p:spPr>
-        <p:txBody>
-          <a:bodyPr xmlns:a="http://schemas.openxmlformats.org/drawingml/2006/main"/>
-          <a:lstStyle xmlns:a="http://schemas.openxmlformats.org/drawingml/2006/main"/>
-          <a:p xmlns:a="http://schemas.openxmlformats.org/drawingml/2006/main">
-            <a:pPr>
-              <a:defRPr sz="1200" b="1">
-                <a:solidFill>
-                  <a:srgbClr val="FFFFFF"/>
+            <a:pPr algn="r">
+              <a:defRPr sz="825">
+                <a:solidFill>
+                  <a:srgbClr val="A5A5A5"/>
                 </a:solidFill>
                 <a:latin typeface="IBM Plex Mono"/>
               </a:defRPr>
             </a:pPr>
             <a:r>
-              <a:rPr sz="1200" b="1">
-                <a:solidFill>
-                  <a:srgbClr val="FFFFFF"/>
+              <a:rPr sz="825">
+                <a:solidFill>
+                  <a:srgbClr val="A5A5A5"/>
                 </a:solidFill>
                 <a:latin typeface="IBM Plex Mono"/>
               </a:rPr>
-              <a:t>BOOK A WORKING SESSION</a:t>
-            </a:r>
-          </a:p>
-        </p:txBody>
-      </p:sp>
-      <p:sp>
-        <p:nvSpPr>
-          <p:cNvPr id="6" name="closing-action-signal">
-            <a:extLst xmlns:a="http://schemas.openxmlformats.org/drawingml/2006/main">
-              <a:ext uri="{FF2B5EF4-FFF2-40B4-BE49-F238E27FC236}">
-                <a16:creationId xmlns:a16="http://schemas.microsoft.com/office/drawing/2014/main" id="{1E0A8806-7B5A-46AA-B4F2-29A7890E1ADD}"/>
-              </a:ext>
-            </a:extLst>
-          </p:cNvPr>
-          <p:cNvSpPr>
-            <a:spLocks xmlns:a="http://schemas.openxmlformats.org/drawingml/2006/main" noGrp="1"/>
-          </p:cNvSpPr>
-          <p:nvPr/>
-        </p:nvSpPr>
-        <p:spPr>
-          <a:xfrm xmlns:a="http://schemas.openxmlformats.org/drawingml/2006/main">
-            <a:off x="876300" y="4686300"/>
-            <a:ext cx="457200" cy="38100"/>
-          </a:xfrm>
-          <a:prstGeom xmlns:a="http://schemas.openxmlformats.org/drawingml/2006/main" prst="rect">
-            <a:avLst/>
-          </a:prstGeom>
-          <a:solidFill xmlns:a="http://schemas.openxmlformats.org/drawingml/2006/main">
-            <a:srgbClr val="EE7BB3"/>
-          </a:solidFill>
-          <a:ln xmlns:a="http://schemas.openxmlformats.org/drawingml/2006/main" w="0">
-            <a:noFill/>
-            <a:prstDash val="solid"/>
-          </a:ln>
-        </p:spPr>
-      </p:sp>
-      <p:sp>
-        <p:nvSpPr>
-          <p:cNvPr id="7" name="closing-contact">
-            <a:extLst xmlns:a="http://schemas.openxmlformats.org/drawingml/2006/main">
-              <a:ext uri="{FF2B5EF4-FFF2-40B4-BE49-F238E27FC236}">
-                <a16:creationId xmlns:a16="http://schemas.microsoft.com/office/drawing/2014/main" id="{8B7792E9-0BFE-44B1-B7CE-286051927D49}"/>
-              </a:ext>
-            </a:extLst>
-          </p:cNvPr>
-          <p:cNvSpPr>
-            <a:spLocks xmlns:a="http://schemas.openxmlformats.org/drawingml/2006/main" noGrp="1"/>
-          </p:cNvSpPr>
-          <p:nvPr/>
-        </p:nvSpPr>
-        <p:spPr>
-          <a:xfrm xmlns:a="http://schemas.openxmlformats.org/drawingml/2006/main">
-            <a:off x="876300" y="5105400"/>
-            <a:ext cx="6667500" cy="323850"/>
-          </a:xfrm>
-          <a:prstGeom xmlns:a="http://schemas.openxmlformats.org/drawingml/2006/main" prst="rect">
-            <a:avLst/>
-          </a:prstGeom>
-          <a:noFill xmlns:a="http://schemas.openxmlformats.org/drawingml/2006/main"/>
-          <a:ln xmlns:a="http://schemas.openxmlformats.org/drawingml/2006/main" w="0">
-            <a:noFill/>
-            <a:prstDash val="solid"/>
-          </a:ln>
-        </p:spPr>
-        <p:txBody>
-          <a:bodyPr xmlns:a="http://schemas.openxmlformats.org/drawingml/2006/main"/>
-          <a:lstStyle xmlns:a="http://schemas.openxmlformats.org/drawingml/2006/main"/>
-          <a:p xmlns:a="http://schemas.openxmlformats.org/drawingml/2006/main">
-            <a:pPr>
-              <a:defRPr sz="975">
-                <a:solidFill>
-                  <a:srgbClr val="666666"/>
-                </a:solidFill>
-                <a:latin typeface="IBM Plex Mono"/>
-              </a:defRPr>
-            </a:pPr>
-            <a:r>
-              <a:rPr sz="975">
-                <a:solidFill>
-                  <a:srgbClr val="666666"/>
-                </a:solidFill>
-                <a:latin typeface="IBM Plex Mono"/>
-              </a:rPr>
-              <a:t>MASLOW.AI</a:t>
-            </a:r>
-          </a:p>
-        </p:txBody>
-      </p:sp>
-      <p:sp>
-        <p:nvSpPr>
-          <p:cNvPr id="8" name="footer-wordmark-1.0.0">
-            <a:extLst xmlns:a="http://schemas.openxmlformats.org/drawingml/2006/main">
-              <a:ext uri="{FF2B5EF4-FFF2-40B4-BE49-F238E27FC236}">
-                <a16:creationId xmlns:a16="http://schemas.microsoft.com/office/drawing/2014/main" id="{ED819426-192B-452A-91F5-211F1A3DB34F}"/>
-              </a:ext>
-            </a:extLst>
-          </p:cNvPr>
-          <p:cNvSpPr>
-            <a:spLocks xmlns:a="http://schemas.openxmlformats.org/drawingml/2006/main" noGrp="1"/>
-          </p:cNvSpPr>
-          <p:nvPr/>
-        </p:nvSpPr>
-        <p:spPr>
-          <a:xfrm xmlns:a="http://schemas.openxmlformats.org/drawingml/2006/main">
-            <a:off x="876300" y="6362700"/>
-            <a:ext cx="1714500" cy="228600"/>
-          </a:xfrm>
-          <a:prstGeom xmlns:a="http://schemas.openxmlformats.org/drawingml/2006/main" prst="rect">
-            <a:avLst/>
-          </a:prstGeom>
-          <a:noFill xmlns:a="http://schemas.openxmlformats.org/drawingml/2006/main"/>
-          <a:ln xmlns:a="http://schemas.openxmlformats.org/drawingml/2006/main" w="0">
-            <a:noFill/>
-            <a:prstDash val="solid"/>
-          </a:ln>
-        </p:spPr>
-        <p:txBody>
-          <a:bodyPr xmlns:a="http://schemas.openxmlformats.org/drawingml/2006/main"/>
-          <a:lstStyle xmlns:a="http://schemas.openxmlformats.org/drawingml/2006/main"/>
-          <a:p xmlns:a="http://schemas.openxmlformats.org/drawingml/2006/main">
-            <a:pPr>
-              <a:defRPr sz="900" b="1">
-                <a:solidFill>
-                  <a:srgbClr val="A5A5A5"/>
-                </a:solidFill>
-                <a:latin typeface="IBM Plex Mono"/>
-              </a:defRPr>
-            </a:pPr>
-            <a:r>
-              <a:rPr sz="900" b="1">
-                <a:solidFill>
-                  <a:srgbClr val="A5A5A5"/>
-                </a:solidFill>
-                <a:latin typeface="IBM Plex Mono"/>
-              </a:rPr>
-              <a:t>MASLOW AI</a:t>
-            </a:r>
-          </a:p>
-        </p:txBody>
-      </p:sp>
-      <p:sp>
-        <p:nvSpPr>
-          <p:cNvPr id="9" name="footer-folio-1.0.0">
-            <a:extLst xmlns:a="http://schemas.openxmlformats.org/drawingml/2006/main">
-              <a:ext uri="{FF2B5EF4-FFF2-40B4-BE49-F238E27FC236}">
-                <a16:creationId xmlns:a16="http://schemas.microsoft.com/office/drawing/2014/main" id="{08D46F1C-4DF3-40EF-B8C9-53C5A96E708A}"/>
-              </a:ext>
-            </a:extLst>
-          </p:cNvPr>
-          <p:cNvSpPr>
-            <a:spLocks xmlns:a="http://schemas.openxmlformats.org/drawingml/2006/main" noGrp="1"/>
-          </p:cNvSpPr>
-          <p:nvPr/>
-        </p:nvSpPr>
-        <p:spPr>
-          <a:xfrm xmlns:a="http://schemas.openxmlformats.org/drawingml/2006/main">
-            <a:off x="9601200" y="6362700"/>
-            <a:ext cx="1714500" cy="228600"/>
-          </a:xfrm>
-          <a:prstGeom xmlns:a="http://schemas.openxmlformats.org/drawingml/2006/main" prst="rect">
-            <a:avLst/>
-          </a:prstGeom>
-          <a:noFill xmlns:a="http://schemas.openxmlformats.org/drawingml/2006/main"/>
-          <a:ln xmlns:a="http://schemas.openxmlformats.org/drawingml/2006/main" w="0">
-            <a:noFill/>
-            <a:prstDash val="solid"/>
-          </a:ln>
-        </p:spPr>
-        <p:txBody>
-          <a:bodyPr xmlns:a="http://schemas.openxmlformats.org/drawingml/2006/main"/>
-          <a:lstStyle xmlns:a="http://schemas.openxmlformats.org/drawingml/2006/main"/>
-          <a:p xmlns:a="http://schemas.openxmlformats.org/drawingml/2006/main">
-            <a:pPr algn="r">
-              <a:defRPr sz="825">
-                <a:solidFill>
-                  <a:srgbClr val="A5A5A5"/>
-                </a:solidFill>
-                <a:latin typeface="IBM Plex Mono"/>
-              </a:defRPr>
-            </a:pPr>
-            <a:r>
-              <a:rPr sz="825">
-                <a:solidFill>
-                  <a:srgbClr val="A5A5A5"/>
-                </a:solidFill>
-                <a:latin typeface="IBM Plex Mono"/>
-              </a:rPr>
-              <a:t>MASLOW AI · 1.0.0</a:t>
+              <a:t>MASLOW AI · 1.0.1</a:t>
             </a:r>
           </a:p>
         </p:txBody>
@@ -5093,7 +4989,7 @@
     </p:spTree>
     <p:extLst>
       <p:ext uri="{BB962C8B-B14F-4D97-AF65-F5344CB8AC3E}">
-        <p14:creationId xmlns:p14="http://schemas.microsoft.com/office/powerpoint/2010/main" val="1025825783"/>
+        <p14:creationId xmlns:p14="http://schemas.microsoft.com/office/powerpoint/2010/main" val="296133631"/>
       </p:ext>
     </p:extLst>
   </p:cSld>
@@ -5103,7 +4999,7 @@
 <file path=ppt/theme/theme1.xml><?xml version="1.0" encoding="utf-8"?>
 <a:theme xmlns:a="http://schemas.openxmlformats.org/drawingml/2006/main" name="ChatGPT">
   <a:themeElements>
-    <a:clrScheme name="Maslow Brand OS 1.0.0">
+    <a:clrScheme name="Maslow Brand OS 1.0.1">
       <a:dk1>
         <a:srgbClr val="333333"/>
       </a:dk1>
@@ -5153,7 +5049,7 @@
         <a:cs typeface="Calibri"/>
       </a:minorFont>
     </a:fontScheme>
-    <a:fmtScheme name="Maslow Brand OS 1.0.0">
+    <a:fmtScheme name="Maslow Brand OS 1.0.1">
       <a:fillStyleLst>
         <a:solidFill>
           <a:schemeClr val="phClr"/>

</xml_diff>

<commit_message>
feat(brand): package portable Brand OS 1.1
</commit_message>
<xml_diff>
--- a/artifacts/blind-build/maslow-workflow-brief.pptx
+++ b/artifacts/blind-build/maslow-workflow-brief.pptx
@@ -2,19 +2,19 @@
 <file path=ppt/presentation.xml><?xml version="1.0" encoding="utf-8"?>
 <p:presentation xmlns:p="http://schemas.openxmlformats.org/presentationml/2006/main">
   <p:sldMasterIdLst>
-    <p:sldMasterId xmlns:r="http://schemas.openxmlformats.org/officeDocument/2006/relationships" id="2147483648" r:id="R35ccb7f1c5c04797"/>
-    <p:sldMasterId xmlns:r="http://schemas.openxmlformats.org/officeDocument/2006/relationships" id="2147483650" r:id="R3405abf9ec864894"/>
+    <p:sldMasterId xmlns:r="http://schemas.openxmlformats.org/officeDocument/2006/relationships" id="2147483648" r:id="R8d702a1fd4a547b3"/>
+    <p:sldMasterId xmlns:r="http://schemas.openxmlformats.org/officeDocument/2006/relationships" id="2147483650" r:id="R523a98e814fb4622"/>
   </p:sldMasterIdLst>
   <p:notesMasterIdLst>
-    <p:notesMasterId xmlns:r="http://schemas.openxmlformats.org/officeDocument/2006/relationships" r:id="Raac2d6408df2486c"/>
+    <p:notesMasterId xmlns:r="http://schemas.openxmlformats.org/officeDocument/2006/relationships" r:id="Rd915006c725040ad"/>
   </p:notesMasterIdLst>
   <p:sldIdLst>
-    <p:sldId xmlns:r="http://schemas.openxmlformats.org/officeDocument/2006/relationships" id="256" r:id="R162735c413a7490c"/>
-    <p:sldId xmlns:r="http://schemas.openxmlformats.org/officeDocument/2006/relationships" id="257" r:id="R6de605be2ae94f84"/>
-    <p:sldId xmlns:r="http://schemas.openxmlformats.org/officeDocument/2006/relationships" id="258" r:id="R2dc7dae63a0c4af9"/>
-    <p:sldId xmlns:r="http://schemas.openxmlformats.org/officeDocument/2006/relationships" id="259" r:id="Rf8d3255d1eb34319"/>
-    <p:sldId xmlns:r="http://schemas.openxmlformats.org/officeDocument/2006/relationships" id="260" r:id="R7e80372ace8f4c71"/>
-    <p:sldId xmlns:r="http://schemas.openxmlformats.org/officeDocument/2006/relationships" id="261" r:id="Re2900bc4cb9c4d8a"/>
+    <p:sldId xmlns:r="http://schemas.openxmlformats.org/officeDocument/2006/relationships" id="256" r:id="R7dcc0a5fd1064718"/>
+    <p:sldId xmlns:r="http://schemas.openxmlformats.org/officeDocument/2006/relationships" id="257" r:id="R676bbcbffcf04c22"/>
+    <p:sldId xmlns:r="http://schemas.openxmlformats.org/officeDocument/2006/relationships" id="258" r:id="Rbd528405bff74865"/>
+    <p:sldId xmlns:r="http://schemas.openxmlformats.org/officeDocument/2006/relationships" id="259" r:id="R6ca6a983e8954cbe"/>
+    <p:sldId xmlns:r="http://schemas.openxmlformats.org/officeDocument/2006/relationships" id="260" r:id="Rddfdeabb2f804fa0"/>
+    <p:sldId xmlns:r="http://schemas.openxmlformats.org/officeDocument/2006/relationships" id="261" r:id="Rb1c0f70ee2524a3d"/>
   </p:sldIdLst>
   <p:sldSz cx="12192000" cy="6858000"/>
   <p:notesSz cx="6858000" cy="9144000"/>
@@ -166,7 +166,7 @@
 <file path=ppt/notesMasters/theme/theme4.xml><?xml version="1.0" encoding="utf-8"?>
 <a:theme xmlns:a="http://schemas.openxmlformats.org/drawingml/2006/main" name="ChatGPT">
   <a:themeElements>
-    <a:clrScheme name="Maslow Brand OS 1.0.1">
+    <a:clrScheme name="Maslow Brand OS 1.1.0">
       <a:dk1>
         <a:srgbClr val="333333"/>
       </a:dk1>
@@ -216,7 +216,7 @@
         <a:cs typeface="Calibri"/>
       </a:minorFont>
     </a:fontScheme>
-    <a:fmtScheme name="Maslow Brand OS 1.0.1">
+    <a:fmtScheme name="Maslow Brand OS 1.1.0">
       <a:fillStyleLst>
         <a:solidFill>
           <a:schemeClr val="phClr"/>
@@ -862,7 +862,7 @@
           <p:cNvPr id="2" name="01 Title background">
             <a:extLst xmlns:a="http://schemas.openxmlformats.org/drawingml/2006/main">
               <a:ext uri="{FF2B5EF4-FFF2-40B4-BE49-F238E27FC236}">
-                <a16:creationId xmlns:a16="http://schemas.microsoft.com/office/drawing/2014/main" id="{D702B158-52AC-4D30-B0A7-E932F40A50DC}"/>
+                <a16:creationId xmlns:a16="http://schemas.microsoft.com/office/drawing/2014/main" id="{20DBBF28-D20D-4828-AD77-BA2B3A35E1C3}"/>
               </a:ext>
             </a:extLst>
           </p:cNvPr>
@@ -893,7 +893,7 @@
           <p:cNvPr id="3" name="01 Title title 0">
             <a:extLst xmlns:a="http://schemas.openxmlformats.org/drawingml/2006/main">
               <a:ext uri="{FF2B5EF4-FFF2-40B4-BE49-F238E27FC236}">
-                <a16:creationId xmlns:a16="http://schemas.microsoft.com/office/drawing/2014/main" id="{B8BB96A8-059E-4416-90BF-009DE48E5837}"/>
+                <a16:creationId xmlns:a16="http://schemas.microsoft.com/office/drawing/2014/main" id="{9F8EED44-119A-4B7A-8BB9-A126E9F359AD}"/>
               </a:ext>
             </a:extLst>
           </p:cNvPr>
@@ -925,7 +925,7 @@
           <p:cNvPr id="4" name="01 Title subtitle 0">
             <a:extLst xmlns:a="http://schemas.openxmlformats.org/drawingml/2006/main">
               <a:ext uri="{FF2B5EF4-FFF2-40B4-BE49-F238E27FC236}">
-                <a16:creationId xmlns:a16="http://schemas.microsoft.com/office/drawing/2014/main" id="{4F25BACC-3EB6-4AC6-B58A-AC29B6F3D9FF}"/>
+                <a16:creationId xmlns:a16="http://schemas.microsoft.com/office/drawing/2014/main" id="{A4962A81-4D48-4EA7-AC1F-127FD6AF2FCB}"/>
               </a:ext>
             </a:extLst>
           </p:cNvPr>
@@ -974,7 +974,7 @@
           <p:cNvPr id="2" name="02 Section background">
             <a:extLst xmlns:a="http://schemas.openxmlformats.org/drawingml/2006/main">
               <a:ext uri="{FF2B5EF4-FFF2-40B4-BE49-F238E27FC236}">
-                <a16:creationId xmlns:a16="http://schemas.microsoft.com/office/drawing/2014/main" id="{95947083-640E-4EDB-ABDF-D55DE2CFABAC}"/>
+                <a16:creationId xmlns:a16="http://schemas.microsoft.com/office/drawing/2014/main" id="{AAA46565-7D66-4390-80A9-A17D86F96CFD}"/>
               </a:ext>
             </a:extLst>
           </p:cNvPr>
@@ -1005,7 +1005,7 @@
           <p:cNvPr id="3" name="02 Section title 0">
             <a:extLst xmlns:a="http://schemas.openxmlformats.org/drawingml/2006/main">
               <a:ext uri="{FF2B5EF4-FFF2-40B4-BE49-F238E27FC236}">
-                <a16:creationId xmlns:a16="http://schemas.microsoft.com/office/drawing/2014/main" id="{AB19F1C3-07F1-4E0C-9164-229C7834A215}"/>
+                <a16:creationId xmlns:a16="http://schemas.microsoft.com/office/drawing/2014/main" id="{B033E4C9-0E65-418F-842D-E1BBF1AD4638}"/>
               </a:ext>
             </a:extLst>
           </p:cNvPr>
@@ -1037,7 +1037,7 @@
           <p:cNvPr id="4" name="02 Section subtitle 0">
             <a:extLst xmlns:a="http://schemas.openxmlformats.org/drawingml/2006/main">
               <a:ext uri="{FF2B5EF4-FFF2-40B4-BE49-F238E27FC236}">
-                <a16:creationId xmlns:a16="http://schemas.microsoft.com/office/drawing/2014/main" id="{02E804B0-193E-43A4-BA26-421C4FC540C6}"/>
+                <a16:creationId xmlns:a16="http://schemas.microsoft.com/office/drawing/2014/main" id="{0FD5675B-9BD4-4CF8-9F8A-8870E32A3F03}"/>
               </a:ext>
             </a:extLst>
           </p:cNvPr>
@@ -1086,7 +1086,7 @@
           <p:cNvPr id="2" name="03 Content background">
             <a:extLst xmlns:a="http://schemas.openxmlformats.org/drawingml/2006/main">
               <a:ext uri="{FF2B5EF4-FFF2-40B4-BE49-F238E27FC236}">
-                <a16:creationId xmlns:a16="http://schemas.microsoft.com/office/drawing/2014/main" id="{A6DFE8EA-19D0-4740-B3D7-0EAE771CE01B}"/>
+                <a16:creationId xmlns:a16="http://schemas.microsoft.com/office/drawing/2014/main" id="{3FCA4B28-0A5D-4602-86A8-A3983AB5ED3A}"/>
               </a:ext>
             </a:extLst>
           </p:cNvPr>
@@ -1117,7 +1117,7 @@
           <p:cNvPr id="3" name="03 Content title 0">
             <a:extLst xmlns:a="http://schemas.openxmlformats.org/drawingml/2006/main">
               <a:ext uri="{FF2B5EF4-FFF2-40B4-BE49-F238E27FC236}">
-                <a16:creationId xmlns:a16="http://schemas.microsoft.com/office/drawing/2014/main" id="{DEFD708E-F439-441C-94E1-7976BB9B4C79}"/>
+                <a16:creationId xmlns:a16="http://schemas.microsoft.com/office/drawing/2014/main" id="{C0454D5B-E70E-48C5-A832-656ADC2B2F8F}"/>
               </a:ext>
             </a:extLst>
           </p:cNvPr>
@@ -1149,7 +1149,7 @@
           <p:cNvPr id="4" name="03 Content body 0">
             <a:extLst xmlns:a="http://schemas.openxmlformats.org/drawingml/2006/main">
               <a:ext uri="{FF2B5EF4-FFF2-40B4-BE49-F238E27FC236}">
-                <a16:creationId xmlns:a16="http://schemas.microsoft.com/office/drawing/2014/main" id="{86F3E465-27D8-49FD-9738-9BD392ADA16E}"/>
+                <a16:creationId xmlns:a16="http://schemas.microsoft.com/office/drawing/2014/main" id="{ABAA0750-67D1-4E43-A33A-0E1BA378B0B9}"/>
               </a:ext>
             </a:extLst>
           </p:cNvPr>
@@ -1198,7 +1198,7 @@
           <p:cNvPr id="2" name="04 Evidence background">
             <a:extLst xmlns:a="http://schemas.openxmlformats.org/drawingml/2006/main">
               <a:ext uri="{FF2B5EF4-FFF2-40B4-BE49-F238E27FC236}">
-                <a16:creationId xmlns:a16="http://schemas.microsoft.com/office/drawing/2014/main" id="{BAC341F8-92EE-4A89-B5ED-F92B20722A12}"/>
+                <a16:creationId xmlns:a16="http://schemas.microsoft.com/office/drawing/2014/main" id="{2AD15725-EDA9-4418-8568-C0304811D97F}"/>
               </a:ext>
             </a:extLst>
           </p:cNvPr>
@@ -1229,7 +1229,7 @@
           <p:cNvPr id="3" name="04 Evidence title 0">
             <a:extLst xmlns:a="http://schemas.openxmlformats.org/drawingml/2006/main">
               <a:ext uri="{FF2B5EF4-FFF2-40B4-BE49-F238E27FC236}">
-                <a16:creationId xmlns:a16="http://schemas.microsoft.com/office/drawing/2014/main" id="{C620546F-644C-42F7-9165-E0AA386EBAF4}"/>
+                <a16:creationId xmlns:a16="http://schemas.microsoft.com/office/drawing/2014/main" id="{4221883D-3F27-4EA7-8944-B2261151B808}"/>
               </a:ext>
             </a:extLst>
           </p:cNvPr>
@@ -1261,7 +1261,7 @@
           <p:cNvPr id="4" name="04 Evidence body 0">
             <a:extLst xmlns:a="http://schemas.openxmlformats.org/drawingml/2006/main">
               <a:ext uri="{FF2B5EF4-FFF2-40B4-BE49-F238E27FC236}">
-                <a16:creationId xmlns:a16="http://schemas.microsoft.com/office/drawing/2014/main" id="{F78C5313-FE68-4478-9B06-15C07554F88D}"/>
+                <a16:creationId xmlns:a16="http://schemas.microsoft.com/office/drawing/2014/main" id="{B9752C44-A4E9-4D40-BC67-3CF416456D86}"/>
               </a:ext>
             </a:extLst>
           </p:cNvPr>
@@ -1310,7 +1310,7 @@
           <p:cNvPr id="2" name="05 Quote background">
             <a:extLst xmlns:a="http://schemas.openxmlformats.org/drawingml/2006/main">
               <a:ext uri="{FF2B5EF4-FFF2-40B4-BE49-F238E27FC236}">
-                <a16:creationId xmlns:a16="http://schemas.microsoft.com/office/drawing/2014/main" id="{1993B0DE-E6FE-49A3-AAEF-B485D297A6A5}"/>
+                <a16:creationId xmlns:a16="http://schemas.microsoft.com/office/drawing/2014/main" id="{BF335948-3450-412D-B5EC-14415DE26E6F}"/>
               </a:ext>
             </a:extLst>
           </p:cNvPr>
@@ -1341,7 +1341,7 @@
           <p:cNvPr id="3" name="05 Quote title 0">
             <a:extLst xmlns:a="http://schemas.openxmlformats.org/drawingml/2006/main">
               <a:ext uri="{FF2B5EF4-FFF2-40B4-BE49-F238E27FC236}">
-                <a16:creationId xmlns:a16="http://schemas.microsoft.com/office/drawing/2014/main" id="{368BB7F9-2DCE-4B04-8314-6B9EEC017414}"/>
+                <a16:creationId xmlns:a16="http://schemas.microsoft.com/office/drawing/2014/main" id="{7A24F30E-C28A-4018-8226-504196E5E370}"/>
               </a:ext>
             </a:extLst>
           </p:cNvPr>
@@ -1373,7 +1373,7 @@
           <p:cNvPr id="4" name="05 Quote subtitle 0">
             <a:extLst xmlns:a="http://schemas.openxmlformats.org/drawingml/2006/main">
               <a:ext uri="{FF2B5EF4-FFF2-40B4-BE49-F238E27FC236}">
-                <a16:creationId xmlns:a16="http://schemas.microsoft.com/office/drawing/2014/main" id="{91D4A009-03FA-4A60-ADB5-7937CABD8EBF}"/>
+                <a16:creationId xmlns:a16="http://schemas.microsoft.com/office/drawing/2014/main" id="{08CF1993-1501-45B7-9DF0-E9C07F39E0FF}"/>
               </a:ext>
             </a:extLst>
           </p:cNvPr>
@@ -1422,7 +1422,7 @@
           <p:cNvPr id="2" name="06 Closing background">
             <a:extLst xmlns:a="http://schemas.openxmlformats.org/drawingml/2006/main">
               <a:ext uri="{FF2B5EF4-FFF2-40B4-BE49-F238E27FC236}">
-                <a16:creationId xmlns:a16="http://schemas.microsoft.com/office/drawing/2014/main" id="{10DF850C-B4B5-4F52-8765-2280CEF553F1}"/>
+                <a16:creationId xmlns:a16="http://schemas.microsoft.com/office/drawing/2014/main" id="{8EC585C5-D010-4C20-80BA-48BB32D89644}"/>
               </a:ext>
             </a:extLst>
           </p:cNvPr>
@@ -1453,7 +1453,7 @@
           <p:cNvPr id="3" name="06 Closing title 0">
             <a:extLst xmlns:a="http://schemas.openxmlformats.org/drawingml/2006/main">
               <a:ext uri="{FF2B5EF4-FFF2-40B4-BE49-F238E27FC236}">
-                <a16:creationId xmlns:a16="http://schemas.microsoft.com/office/drawing/2014/main" id="{BA9464A6-E5F9-4CDB-B0A2-A6C6169FFF42}"/>
+                <a16:creationId xmlns:a16="http://schemas.microsoft.com/office/drawing/2014/main" id="{8621D023-12F4-40BF-AF43-9D57242BA28C}"/>
               </a:ext>
             </a:extLst>
           </p:cNvPr>
@@ -1485,7 +1485,7 @@
           <p:cNvPr id="4" name="06 Closing subtitle 0">
             <a:extLst xmlns:a="http://schemas.openxmlformats.org/drawingml/2006/main">
               <a:ext uri="{FF2B5EF4-FFF2-40B4-BE49-F238E27FC236}">
-                <a16:creationId xmlns:a16="http://schemas.microsoft.com/office/drawing/2014/main" id="{10519C24-4980-43C5-BF3C-B7329C978A07}"/>
+                <a16:creationId xmlns:a16="http://schemas.microsoft.com/office/drawing/2014/main" id="{950B20E8-3CAD-429D-AC13-24E17CB8CC8D}"/>
               </a:ext>
             </a:extLst>
           </p:cNvPr>
@@ -1538,7 +1538,7 @@
   </p:cSld>
   <p:clrMap bg1="lt1" tx1="dk1" bg2="lt2" tx2="dk2" accent1="accent1" accent2="accent2" accent3="accent3" accent4="accent4" accent5="accent5" accent6="accent6" hlink="hlink" folHlink="folHlink"/>
   <p:sldLayoutIdLst>
-    <p:sldLayoutId xmlns:r="http://schemas.openxmlformats.org/officeDocument/2006/relationships" id="2147483649" r:id="R69a44bc0e1d34c3c"/>
+    <p:sldLayoutId xmlns:r="http://schemas.openxmlformats.org/officeDocument/2006/relationships" id="2147483649" r:id="R8d9edc4a2278453a"/>
   </p:sldLayoutIdLst>
   <p:txStyles>
     <p:titleStyle>
@@ -1836,12 +1836,12 @@
   </p:cSld>
   <p:clrMap bg1="lt1" tx1="dk1" bg2="lt2" tx2="dk2" accent1="accent1" accent2="accent2" accent3="accent3" accent4="accent4" accent5="accent5" accent6="accent6" hlink="hlink" folHlink="folHlink"/>
   <p:sldLayoutIdLst>
-    <p:sldLayoutId xmlns:r="http://schemas.openxmlformats.org/officeDocument/2006/relationships" id="2147483651" r:id="Rbc7c7c61e1324b42"/>
-    <p:sldLayoutId xmlns:r="http://schemas.openxmlformats.org/officeDocument/2006/relationships" id="2147483652" r:id="Rc6fb26f8716f4114"/>
-    <p:sldLayoutId xmlns:r="http://schemas.openxmlformats.org/officeDocument/2006/relationships" id="2147483653" r:id="Re92218f111e6401b"/>
-    <p:sldLayoutId xmlns:r="http://schemas.openxmlformats.org/officeDocument/2006/relationships" id="2147483654" r:id="Ra97a34abc1c94db6"/>
-    <p:sldLayoutId xmlns:r="http://schemas.openxmlformats.org/officeDocument/2006/relationships" id="2147483655" r:id="R2df8ca33ac894bde"/>
-    <p:sldLayoutId xmlns:r="http://schemas.openxmlformats.org/officeDocument/2006/relationships" id="2147483656" r:id="Rb903e2b5985c40c2"/>
+    <p:sldLayoutId xmlns:r="http://schemas.openxmlformats.org/officeDocument/2006/relationships" id="2147483651" r:id="R52cec01fb9e14b07"/>
+    <p:sldLayoutId xmlns:r="http://schemas.openxmlformats.org/officeDocument/2006/relationships" id="2147483652" r:id="R3e8aa733ece7470d"/>
+    <p:sldLayoutId xmlns:r="http://schemas.openxmlformats.org/officeDocument/2006/relationships" id="2147483653" r:id="R99b1d8eac67942bb"/>
+    <p:sldLayoutId xmlns:r="http://schemas.openxmlformats.org/officeDocument/2006/relationships" id="2147483654" r:id="Ra204d9c65ecc4a8e"/>
+    <p:sldLayoutId xmlns:r="http://schemas.openxmlformats.org/officeDocument/2006/relationships" id="2147483655" r:id="R1fbc9405f2144821"/>
+    <p:sldLayoutId xmlns:r="http://schemas.openxmlformats.org/officeDocument/2006/relationships" id="2147483656" r:id="R987f9a7a4f2d411d"/>
   </p:sldLayoutIdLst>
 </p:sldMaster>
 </file>
@@ -1849,7 +1849,7 @@
 <file path=ppt/slideMasters/theme/theme2.xml><?xml version="1.0" encoding="utf-8"?>
 <a:theme xmlns:a="http://schemas.openxmlformats.org/drawingml/2006/main" name="ChatGPT">
   <a:themeElements>
-    <a:clrScheme name="Maslow Brand OS 1.0.1">
+    <a:clrScheme name="Maslow Brand OS 1.1.0">
       <a:dk1>
         <a:srgbClr val="333333"/>
       </a:dk1>
@@ -1899,7 +1899,7 @@
         <a:cs typeface="Calibri"/>
       </a:minorFont>
     </a:fontScheme>
-    <a:fmtScheme name="Maslow Brand OS 1.0.1">
+    <a:fmtScheme name="Maslow Brand OS 1.1.0">
       <a:fillStyleLst>
         <a:solidFill>
           <a:schemeClr val="phClr"/>
@@ -2094,7 +2094,7 @@
 <file path=ppt/slideMasters/theme/theme3.xml><?xml version="1.0" encoding="utf-8"?>
 <a:theme xmlns:a="http://schemas.openxmlformats.org/drawingml/2006/main" name="ChatGPT">
   <a:themeElements>
-    <a:clrScheme name="Maslow Brand OS 1.0.1">
+    <a:clrScheme name="Maslow Brand OS 1.1.0">
       <a:dk1>
         <a:srgbClr val="333333"/>
       </a:dk1>
@@ -2144,7 +2144,7 @@
         <a:cs typeface="Calibri"/>
       </a:minorFont>
     </a:fontScheme>
-    <a:fmtScheme name="Maslow Brand OS 1.0.1">
+    <a:fmtScheme name="Maslow Brand OS 1.1.0">
       <a:fillStyleLst>
         <a:solidFill>
           <a:schemeClr val="phClr"/>
@@ -2364,7 +2364,7 @@
           <p:nvPr/>
         </p:nvPicPr>
         <p:blipFill>
-          <a:blip xmlns:r="http://schemas.openxmlformats.org/officeDocument/2006/relationships" xmlns:a="http://schemas.openxmlformats.org/drawingml/2006/main" r:embed="R033c5816ae3e4507"/>
+          <a:blip xmlns:r="http://schemas.openxmlformats.org/officeDocument/2006/relationships" xmlns:a="http://schemas.openxmlformats.org/drawingml/2006/main" r:embed="Rdd91a164216b40af"/>
           <a:stretch xmlns:a="http://schemas.openxmlformats.org/drawingml/2006/main"/>
         </p:blipFill>
         <p:spPr>
@@ -2382,7 +2382,7 @@
           <p:cNvPr id="2" name="title-eyebrow">
             <a:extLst xmlns:a="http://schemas.openxmlformats.org/drawingml/2006/main">
               <a:ext uri="{FF2B5EF4-FFF2-40B4-BE49-F238E27FC236}">
-                <a16:creationId xmlns:a16="http://schemas.microsoft.com/office/drawing/2014/main" id="{CFC289D3-3ED1-44E8-AA90-20D82D50830F}"/>
+                <a16:creationId xmlns:a16="http://schemas.microsoft.com/office/drawing/2014/main" id="{28C5E484-2624-49D0-A608-E16F4622B60F}"/>
               </a:ext>
             </a:extLst>
           </p:cNvPr>
@@ -2434,7 +2434,7 @@
           <p:cNvPr id="3" name="title-heading">
             <a:extLst xmlns:a="http://schemas.openxmlformats.org/drawingml/2006/main">
               <a:ext uri="{FF2B5EF4-FFF2-40B4-BE49-F238E27FC236}">
-                <a16:creationId xmlns:a16="http://schemas.microsoft.com/office/drawing/2014/main" id="{37AB4F34-7B17-4842-BBA1-6F8AB1CD067E}"/>
+                <a16:creationId xmlns:a16="http://schemas.microsoft.com/office/drawing/2014/main" id="{4267B848-ED2F-4F85-AB6B-3B0E24C3BACA}"/>
               </a:ext>
             </a:extLst>
           </p:cNvPr>
@@ -2486,7 +2486,7 @@
           <p:cNvPr id="4" name="title-subtitle">
             <a:extLst xmlns:a="http://schemas.openxmlformats.org/drawingml/2006/main">
               <a:ext uri="{FF2B5EF4-FFF2-40B4-BE49-F238E27FC236}">
-                <a16:creationId xmlns:a16="http://schemas.microsoft.com/office/drawing/2014/main" id="{1EA011CF-2633-4C25-808E-19E43E2D4CA4}"/>
+                <a16:creationId xmlns:a16="http://schemas.microsoft.com/office/drawing/2014/main" id="{A2D06F13-EBD9-485F-82C3-53827BA092E2}"/>
               </a:ext>
             </a:extLst>
           </p:cNvPr>
@@ -2536,7 +2536,7 @@
     </p:spTree>
     <p:extLst>
       <p:ext uri="{BB962C8B-B14F-4D97-AF65-F5344CB8AC3E}">
-        <p14:creationId xmlns:p14="http://schemas.microsoft.com/office/powerpoint/2010/main" val="821233293"/>
+        <p14:creationId xmlns:p14="http://schemas.microsoft.com/office/powerpoint/2010/main" val="1466740697"/>
       </p:ext>
     </p:extLst>
   </p:cSld>
@@ -2567,7 +2567,7 @@
           <p:cNvPr id="5" name="section-step-marker">
             <a:extLst xmlns:a="http://schemas.openxmlformats.org/drawingml/2006/main">
               <a:ext uri="{FF2B5EF4-FFF2-40B4-BE49-F238E27FC236}">
-                <a16:creationId xmlns:a16="http://schemas.microsoft.com/office/drawing/2014/main" id="{81F6ACCC-80D8-4EDB-8A39-A87C1D47A6C2}"/>
+                <a16:creationId xmlns:a16="http://schemas.microsoft.com/office/drawing/2014/main" id="{B97C9461-382D-41A7-856D-F2DD2E53CF32}"/>
               </a:ext>
             </a:extLst>
           </p:cNvPr>
@@ -2619,7 +2619,7 @@
           <p:cNvPr id="2" name="section-eyebrow">
             <a:extLst xmlns:a="http://schemas.openxmlformats.org/drawingml/2006/main">
               <a:ext uri="{FF2B5EF4-FFF2-40B4-BE49-F238E27FC236}">
-                <a16:creationId xmlns:a16="http://schemas.microsoft.com/office/drawing/2014/main" id="{B1E5D27B-7BCA-4376-8ECC-E06EDBADFDC4}"/>
+                <a16:creationId xmlns:a16="http://schemas.microsoft.com/office/drawing/2014/main" id="{60077336-914C-4438-873D-AFE5D91D57FB}"/>
               </a:ext>
             </a:extLst>
           </p:cNvPr>
@@ -2671,7 +2671,7 @@
           <p:cNvPr id="3" name="section-heading">
             <a:extLst xmlns:a="http://schemas.openxmlformats.org/drawingml/2006/main">
               <a:ext uri="{FF2B5EF4-FFF2-40B4-BE49-F238E27FC236}">
-                <a16:creationId xmlns:a16="http://schemas.microsoft.com/office/drawing/2014/main" id="{8AA09E8C-9411-41FD-B706-119BB0B8DAFE}"/>
+                <a16:creationId xmlns:a16="http://schemas.microsoft.com/office/drawing/2014/main" id="{8CFA4026-969F-4BC1-A485-10FC165334C5}"/>
               </a:ext>
             </a:extLst>
           </p:cNvPr>
@@ -2723,7 +2723,7 @@
           <p:cNvPr id="4" name="section-signal">
             <a:extLst xmlns:a="http://schemas.openxmlformats.org/drawingml/2006/main">
               <a:ext uri="{FF2B5EF4-FFF2-40B4-BE49-F238E27FC236}">
-                <a16:creationId xmlns:a16="http://schemas.microsoft.com/office/drawing/2014/main" id="{CAF6613E-CD03-46EA-8D68-C022EB273E09}"/>
+                <a16:creationId xmlns:a16="http://schemas.microsoft.com/office/drawing/2014/main" id="{8044DC6F-20E4-44CD-AB29-609E20C4861B}"/>
               </a:ext>
             </a:extLst>
           </p:cNvPr>
@@ -2752,7 +2752,7 @@
     </p:spTree>
     <p:extLst>
       <p:ext uri="{BB962C8B-B14F-4D97-AF65-F5344CB8AC3E}">
-        <p14:creationId xmlns:p14="http://schemas.microsoft.com/office/powerpoint/2010/main" val="309402631"/>
+        <p14:creationId xmlns:p14="http://schemas.microsoft.com/office/powerpoint/2010/main" val="1202553436"/>
       </p:ext>
     </p:extLst>
   </p:cSld>
@@ -2783,7 +2783,7 @@
           <p:cNvPr id="18" name="content-eyebrow">
             <a:extLst xmlns:a="http://schemas.openxmlformats.org/drawingml/2006/main">
               <a:ext uri="{FF2B5EF4-FFF2-40B4-BE49-F238E27FC236}">
-                <a16:creationId xmlns:a16="http://schemas.microsoft.com/office/drawing/2014/main" id="{AD6C429E-C5D6-4316-862D-0D513AF70580}"/>
+                <a16:creationId xmlns:a16="http://schemas.microsoft.com/office/drawing/2014/main" id="{5A114BE4-522C-4B04-A921-623FFB34F747}"/>
               </a:ext>
             </a:extLst>
           </p:cNvPr>
@@ -2835,7 +2835,7 @@
           <p:cNvPr id="2" name="content-heading">
             <a:extLst xmlns:a="http://schemas.openxmlformats.org/drawingml/2006/main">
               <a:ext uri="{FF2B5EF4-FFF2-40B4-BE49-F238E27FC236}">
-                <a16:creationId xmlns:a16="http://schemas.microsoft.com/office/drawing/2014/main" id="{66324927-EC27-4F16-BEE2-429FB48CD5BC}"/>
+                <a16:creationId xmlns:a16="http://schemas.microsoft.com/office/drawing/2014/main" id="{A4562018-218B-4361-BF71-96A2B94460EA}"/>
               </a:ext>
             </a:extLst>
           </p:cNvPr>
@@ -2887,7 +2887,7 @@
           <p:cNvPr id="3" name="content-top-rule">
             <a:extLst xmlns:a="http://schemas.openxmlformats.org/drawingml/2006/main">
               <a:ext uri="{FF2B5EF4-FFF2-40B4-BE49-F238E27FC236}">
-                <a16:creationId xmlns:a16="http://schemas.microsoft.com/office/drawing/2014/main" id="{1A6FE772-C55B-4517-A7F3-AE3614308D8F}"/>
+                <a16:creationId xmlns:a16="http://schemas.microsoft.com/office/drawing/2014/main" id="{80D6BD7B-6BB1-495F-A199-F00566A74882}"/>
               </a:ext>
             </a:extLst>
           </p:cNvPr>
@@ -2918,7 +2918,7 @@
           <p:cNvPr id="4" name="content-row-01-number">
             <a:extLst xmlns:a="http://schemas.openxmlformats.org/drawingml/2006/main">
               <a:ext uri="{FF2B5EF4-FFF2-40B4-BE49-F238E27FC236}">
-                <a16:creationId xmlns:a16="http://schemas.microsoft.com/office/drawing/2014/main" id="{2408E710-0F66-480A-B1A3-3FFB11F7D611}"/>
+                <a16:creationId xmlns:a16="http://schemas.microsoft.com/office/drawing/2014/main" id="{104D30CF-1A91-48F0-AE07-69032D4AC8FF}"/>
               </a:ext>
             </a:extLst>
           </p:cNvPr>
@@ -2970,7 +2970,7 @@
           <p:cNvPr id="5" name="content-row-01-heading">
             <a:extLst xmlns:a="http://schemas.openxmlformats.org/drawingml/2006/main">
               <a:ext uri="{FF2B5EF4-FFF2-40B4-BE49-F238E27FC236}">
-                <a16:creationId xmlns:a16="http://schemas.microsoft.com/office/drawing/2014/main" id="{9BF22B8D-8E43-44D3-BCA5-44165CB55B2A}"/>
+                <a16:creationId xmlns:a16="http://schemas.microsoft.com/office/drawing/2014/main" id="{00C11F03-2263-4AC5-A163-634E023F2D65}"/>
               </a:ext>
             </a:extLst>
           </p:cNvPr>
@@ -3022,7 +3022,7 @@
           <p:cNvPr id="6" name="content-row-01-body">
             <a:extLst xmlns:a="http://schemas.openxmlformats.org/drawingml/2006/main">
               <a:ext uri="{FF2B5EF4-FFF2-40B4-BE49-F238E27FC236}">
-                <a16:creationId xmlns:a16="http://schemas.microsoft.com/office/drawing/2014/main" id="{21F5BEBF-2C65-4D74-A6C6-3AE9CBC2F0EB}"/>
+                <a16:creationId xmlns:a16="http://schemas.microsoft.com/office/drawing/2014/main" id="{F3CC7234-4193-496B-842F-E8FF52286FB8}"/>
               </a:ext>
             </a:extLst>
           </p:cNvPr>
@@ -3074,7 +3074,7 @@
           <p:cNvPr id="7" name="content-row-01-rule">
             <a:extLst xmlns:a="http://schemas.openxmlformats.org/drawingml/2006/main">
               <a:ext uri="{FF2B5EF4-FFF2-40B4-BE49-F238E27FC236}">
-                <a16:creationId xmlns:a16="http://schemas.microsoft.com/office/drawing/2014/main" id="{CC45BA1C-67C8-442A-A305-4A4E0A956E28}"/>
+                <a16:creationId xmlns:a16="http://schemas.microsoft.com/office/drawing/2014/main" id="{155E0860-B333-458F-9A8D-792DEE5D051E}"/>
               </a:ext>
             </a:extLst>
           </p:cNvPr>
@@ -3105,7 +3105,7 @@
           <p:cNvPr id="8" name="content-row-02-number">
             <a:extLst xmlns:a="http://schemas.openxmlformats.org/drawingml/2006/main">
               <a:ext uri="{FF2B5EF4-FFF2-40B4-BE49-F238E27FC236}">
-                <a16:creationId xmlns:a16="http://schemas.microsoft.com/office/drawing/2014/main" id="{3BCCDE36-4096-4460-806E-D55B902C08FD}"/>
+                <a16:creationId xmlns:a16="http://schemas.microsoft.com/office/drawing/2014/main" id="{7463D89E-0195-4008-9916-79E5ACAA563E}"/>
               </a:ext>
             </a:extLst>
           </p:cNvPr>
@@ -3157,7 +3157,7 @@
           <p:cNvPr id="9" name="content-row-02-heading">
             <a:extLst xmlns:a="http://schemas.openxmlformats.org/drawingml/2006/main">
               <a:ext uri="{FF2B5EF4-FFF2-40B4-BE49-F238E27FC236}">
-                <a16:creationId xmlns:a16="http://schemas.microsoft.com/office/drawing/2014/main" id="{67F7C9B9-3895-41FA-9DCE-2114223872FC}"/>
+                <a16:creationId xmlns:a16="http://schemas.microsoft.com/office/drawing/2014/main" id="{11595770-DB9A-4A90-9C87-1C3E9401D809}"/>
               </a:ext>
             </a:extLst>
           </p:cNvPr>
@@ -3209,7 +3209,7 @@
           <p:cNvPr id="10" name="content-row-02-body">
             <a:extLst xmlns:a="http://schemas.openxmlformats.org/drawingml/2006/main">
               <a:ext uri="{FF2B5EF4-FFF2-40B4-BE49-F238E27FC236}">
-                <a16:creationId xmlns:a16="http://schemas.microsoft.com/office/drawing/2014/main" id="{0C952083-D9DF-4F47-B246-D8CAD745723B}"/>
+                <a16:creationId xmlns:a16="http://schemas.microsoft.com/office/drawing/2014/main" id="{E85C713B-E023-4787-B516-386331CC46B1}"/>
               </a:ext>
             </a:extLst>
           </p:cNvPr>
@@ -3261,7 +3261,7 @@
           <p:cNvPr id="11" name="content-row-02-rule">
             <a:extLst xmlns:a="http://schemas.openxmlformats.org/drawingml/2006/main">
               <a:ext uri="{FF2B5EF4-FFF2-40B4-BE49-F238E27FC236}">
-                <a16:creationId xmlns:a16="http://schemas.microsoft.com/office/drawing/2014/main" id="{559BD11F-7742-4B93-A036-7FF7443FA283}"/>
+                <a16:creationId xmlns:a16="http://schemas.microsoft.com/office/drawing/2014/main" id="{82E5551B-BFA7-496A-AD59-C10B00662563}"/>
               </a:ext>
             </a:extLst>
           </p:cNvPr>
@@ -3292,7 +3292,7 @@
           <p:cNvPr id="12" name="content-row-03-number">
             <a:extLst xmlns:a="http://schemas.openxmlformats.org/drawingml/2006/main">
               <a:ext uri="{FF2B5EF4-FFF2-40B4-BE49-F238E27FC236}">
-                <a16:creationId xmlns:a16="http://schemas.microsoft.com/office/drawing/2014/main" id="{265B4B8D-A6EC-40E3-B581-3DD5C59A84D7}"/>
+                <a16:creationId xmlns:a16="http://schemas.microsoft.com/office/drawing/2014/main" id="{348658CB-99BF-4797-A326-E4BCEA9EEDE4}"/>
               </a:ext>
             </a:extLst>
           </p:cNvPr>
@@ -3344,7 +3344,7 @@
           <p:cNvPr id="13" name="content-row-03-heading">
             <a:extLst xmlns:a="http://schemas.openxmlformats.org/drawingml/2006/main">
               <a:ext uri="{FF2B5EF4-FFF2-40B4-BE49-F238E27FC236}">
-                <a16:creationId xmlns:a16="http://schemas.microsoft.com/office/drawing/2014/main" id="{20C1AB1B-E28F-465B-A8E5-C636CE13C9C2}"/>
+                <a16:creationId xmlns:a16="http://schemas.microsoft.com/office/drawing/2014/main" id="{A13C7562-CE2A-4673-A488-38E2D30AE781}"/>
               </a:ext>
             </a:extLst>
           </p:cNvPr>
@@ -3396,7 +3396,7 @@
           <p:cNvPr id="14" name="content-row-03-body">
             <a:extLst xmlns:a="http://schemas.openxmlformats.org/drawingml/2006/main">
               <a:ext uri="{FF2B5EF4-FFF2-40B4-BE49-F238E27FC236}">
-                <a16:creationId xmlns:a16="http://schemas.microsoft.com/office/drawing/2014/main" id="{C0735FD1-EF9E-4478-BF53-C1E3E6F085F3}"/>
+                <a16:creationId xmlns:a16="http://schemas.microsoft.com/office/drawing/2014/main" id="{99FB5377-17E3-47E7-8D30-F86FB3480DBB}"/>
               </a:ext>
             </a:extLst>
           </p:cNvPr>
@@ -3448,7 +3448,7 @@
           <p:cNvPr id="15" name="content-row-03-rule">
             <a:extLst xmlns:a="http://schemas.openxmlformats.org/drawingml/2006/main">
               <a:ext uri="{FF2B5EF4-FFF2-40B4-BE49-F238E27FC236}">
-                <a16:creationId xmlns:a16="http://schemas.microsoft.com/office/drawing/2014/main" id="{CEF9CACA-F9A4-4C83-B652-1D40B679B428}"/>
+                <a16:creationId xmlns:a16="http://schemas.microsoft.com/office/drawing/2014/main" id="{DC1D08F1-EC15-48D4-B2AC-E900D02009D2}"/>
               </a:ext>
             </a:extLst>
           </p:cNvPr>
@@ -3476,10 +3476,10 @@
       </p:sp>
       <p:sp>
         <p:nvSpPr>
-          <p:cNvPr id="16" name="footer-wordmark-1.0.1">
-            <a:extLst xmlns:a="http://schemas.openxmlformats.org/drawingml/2006/main">
-              <a:ext uri="{FF2B5EF4-FFF2-40B4-BE49-F238E27FC236}">
-                <a16:creationId xmlns:a16="http://schemas.microsoft.com/office/drawing/2014/main" id="{4582EBF9-DE2C-48B2-9FA6-74F12AB1F64E}"/>
+          <p:cNvPr id="16" name="footer-wordmark-1.1.0">
+            <a:extLst xmlns:a="http://schemas.openxmlformats.org/drawingml/2006/main">
+              <a:ext uri="{FF2B5EF4-FFF2-40B4-BE49-F238E27FC236}">
+                <a16:creationId xmlns:a16="http://schemas.microsoft.com/office/drawing/2014/main" id="{615820CD-F39D-4ACE-8501-7E37C148F5AD}"/>
               </a:ext>
             </a:extLst>
           </p:cNvPr>
@@ -3528,10 +3528,10 @@
       </p:sp>
       <p:sp>
         <p:nvSpPr>
-          <p:cNvPr id="17" name="footer-folio-1.0.1">
-            <a:extLst xmlns:a="http://schemas.openxmlformats.org/drawingml/2006/main">
-              <a:ext uri="{FF2B5EF4-FFF2-40B4-BE49-F238E27FC236}">
-                <a16:creationId xmlns:a16="http://schemas.microsoft.com/office/drawing/2014/main" id="{0AAC4ADF-6D57-4F6A-9F9E-A28173D8E26C}"/>
+          <p:cNvPr id="17" name="footer-folio-1.1.0">
+            <a:extLst xmlns:a="http://schemas.openxmlformats.org/drawingml/2006/main">
+              <a:ext uri="{FF2B5EF4-FFF2-40B4-BE49-F238E27FC236}">
+                <a16:creationId xmlns:a16="http://schemas.microsoft.com/office/drawing/2014/main" id="{D1236267-7228-428D-8E33-7FE08570682A}"/>
               </a:ext>
             </a:extLst>
           </p:cNvPr>
@@ -3573,7 +3573,7 @@
                 </a:solidFill>
                 <a:latin typeface="IBM Plex Mono"/>
               </a:rPr>
-              <a:t>MASLOW AI · 1.0.1</a:t>
+              <a:t>MASLOW AI · 1.1.0</a:t>
             </a:r>
           </a:p>
         </p:txBody>
@@ -3581,7 +3581,7 @@
     </p:spTree>
     <p:extLst>
       <p:ext uri="{BB962C8B-B14F-4D97-AF65-F5344CB8AC3E}">
-        <p14:creationId xmlns:p14="http://schemas.microsoft.com/office/powerpoint/2010/main" val="1653264255"/>
+        <p14:creationId xmlns:p14="http://schemas.microsoft.com/office/powerpoint/2010/main" val="194358582"/>
       </p:ext>
     </p:extLst>
   </p:cSld>
@@ -3612,7 +3612,7 @@
           <p:cNvPr id="17" name="evidence-eyebrow">
             <a:extLst xmlns:a="http://schemas.openxmlformats.org/drawingml/2006/main">
               <a:ext uri="{FF2B5EF4-FFF2-40B4-BE49-F238E27FC236}">
-                <a16:creationId xmlns:a16="http://schemas.microsoft.com/office/drawing/2014/main" id="{80778A15-7D45-4B36-9A55-3BC167815297}"/>
+                <a16:creationId xmlns:a16="http://schemas.microsoft.com/office/drawing/2014/main" id="{2F2FED08-E6AB-40DE-BB29-5AC54ABDC5D2}"/>
               </a:ext>
             </a:extLst>
           </p:cNvPr>
@@ -3664,7 +3664,7 @@
           <p:cNvPr id="2" name="evidence-heading">
             <a:extLst xmlns:a="http://schemas.openxmlformats.org/drawingml/2006/main">
               <a:ext uri="{FF2B5EF4-FFF2-40B4-BE49-F238E27FC236}">
-                <a16:creationId xmlns:a16="http://schemas.microsoft.com/office/drawing/2014/main" id="{D5C06998-BC54-4F09-A480-9ABD29B513C9}"/>
+                <a16:creationId xmlns:a16="http://schemas.microsoft.com/office/drawing/2014/main" id="{08121910-777B-4BEE-9DF0-2D5BB9BAEA5B}"/>
               </a:ext>
             </a:extLst>
           </p:cNvPr>
@@ -3716,7 +3716,7 @@
           <p:cNvPr id="3" name="evidence-ONE-rule">
             <a:extLst xmlns:a="http://schemas.openxmlformats.org/drawingml/2006/main">
               <a:ext uri="{FF2B5EF4-FFF2-40B4-BE49-F238E27FC236}">
-                <a16:creationId xmlns:a16="http://schemas.microsoft.com/office/drawing/2014/main" id="{1295D459-603B-4901-9A5B-91E5BD851B0A}"/>
+                <a16:creationId xmlns:a16="http://schemas.microsoft.com/office/drawing/2014/main" id="{37AA1BC2-971B-4E9B-8C21-C42E0B4CA1EB}"/>
               </a:ext>
             </a:extLst>
           </p:cNvPr>
@@ -3747,7 +3747,7 @@
           <p:cNvPr id="4" name="evidence-ONE-value">
             <a:extLst xmlns:a="http://schemas.openxmlformats.org/drawingml/2006/main">
               <a:ext uri="{FF2B5EF4-FFF2-40B4-BE49-F238E27FC236}">
-                <a16:creationId xmlns:a16="http://schemas.microsoft.com/office/drawing/2014/main" id="{547C305B-5406-4823-92A0-41AD2D5DFFFB}"/>
+                <a16:creationId xmlns:a16="http://schemas.microsoft.com/office/drawing/2014/main" id="{462736D9-DB46-48DE-A332-1A30942002E0}"/>
               </a:ext>
             </a:extLst>
           </p:cNvPr>
@@ -3799,7 +3799,7 @@
           <p:cNvPr id="5" name="evidence-ONE-claim">
             <a:extLst xmlns:a="http://schemas.openxmlformats.org/drawingml/2006/main">
               <a:ext uri="{FF2B5EF4-FFF2-40B4-BE49-F238E27FC236}">
-                <a16:creationId xmlns:a16="http://schemas.microsoft.com/office/drawing/2014/main" id="{1BE49025-D389-4BB4-A618-E2BE2D4E9D27}"/>
+                <a16:creationId xmlns:a16="http://schemas.microsoft.com/office/drawing/2014/main" id="{AFB0F8F4-C816-4609-9613-B0C807A4CC2C}"/>
               </a:ext>
             </a:extLst>
           </p:cNvPr>
@@ -3851,7 +3851,7 @@
           <p:cNvPr id="6" name="evidence-ONE-source">
             <a:extLst xmlns:a="http://schemas.openxmlformats.org/drawingml/2006/main">
               <a:ext uri="{FF2B5EF4-FFF2-40B4-BE49-F238E27FC236}">
-                <a16:creationId xmlns:a16="http://schemas.microsoft.com/office/drawing/2014/main" id="{CEC2ABBB-FAEA-4744-AF08-2D5DDB95F0B7}"/>
+                <a16:creationId xmlns:a16="http://schemas.microsoft.com/office/drawing/2014/main" id="{4898A57A-D172-4357-A63E-5E8291925591}"/>
               </a:ext>
             </a:extLst>
           </p:cNvPr>
@@ -3903,7 +3903,7 @@
           <p:cNvPr id="7" name="evidence-TWO-rule">
             <a:extLst xmlns:a="http://schemas.openxmlformats.org/drawingml/2006/main">
               <a:ext uri="{FF2B5EF4-FFF2-40B4-BE49-F238E27FC236}">
-                <a16:creationId xmlns:a16="http://schemas.microsoft.com/office/drawing/2014/main" id="{62E123A0-9753-451D-8158-6581F4383E29}"/>
+                <a16:creationId xmlns:a16="http://schemas.microsoft.com/office/drawing/2014/main" id="{96489E28-6915-4B32-962A-E1DD0FCC1983}"/>
               </a:ext>
             </a:extLst>
           </p:cNvPr>
@@ -3934,7 +3934,7 @@
           <p:cNvPr id="8" name="evidence-TWO-value">
             <a:extLst xmlns:a="http://schemas.openxmlformats.org/drawingml/2006/main">
               <a:ext uri="{FF2B5EF4-FFF2-40B4-BE49-F238E27FC236}">
-                <a16:creationId xmlns:a16="http://schemas.microsoft.com/office/drawing/2014/main" id="{D512309F-A091-4B51-A2C4-75DFDF0FF1D9}"/>
+                <a16:creationId xmlns:a16="http://schemas.microsoft.com/office/drawing/2014/main" id="{2F4D918C-DBB2-4E20-853C-0DBE6BE31E0C}"/>
               </a:ext>
             </a:extLst>
           </p:cNvPr>
@@ -3986,7 +3986,7 @@
           <p:cNvPr id="9" name="evidence-TWO-claim">
             <a:extLst xmlns:a="http://schemas.openxmlformats.org/drawingml/2006/main">
               <a:ext uri="{FF2B5EF4-FFF2-40B4-BE49-F238E27FC236}">
-                <a16:creationId xmlns:a16="http://schemas.microsoft.com/office/drawing/2014/main" id="{A1D4B564-07E9-4D62-92D3-5A873C7857FC}"/>
+                <a16:creationId xmlns:a16="http://schemas.microsoft.com/office/drawing/2014/main" id="{2BA544E3-0D44-4730-B523-668CC4598547}"/>
               </a:ext>
             </a:extLst>
           </p:cNvPr>
@@ -4038,7 +4038,7 @@
           <p:cNvPr id="10" name="evidence-TWO-source">
             <a:extLst xmlns:a="http://schemas.openxmlformats.org/drawingml/2006/main">
               <a:ext uri="{FF2B5EF4-FFF2-40B4-BE49-F238E27FC236}">
-                <a16:creationId xmlns:a16="http://schemas.microsoft.com/office/drawing/2014/main" id="{197EDFFC-CAB2-4E85-BAE2-7535DC039D81}"/>
+                <a16:creationId xmlns:a16="http://schemas.microsoft.com/office/drawing/2014/main" id="{FB86C9E9-76F7-486D-A4DB-BE6E96E516B5}"/>
               </a:ext>
             </a:extLst>
           </p:cNvPr>
@@ -4090,7 +4090,7 @@
           <p:cNvPr id="11" name="evidence-THREE-rule">
             <a:extLst xmlns:a="http://schemas.openxmlformats.org/drawingml/2006/main">
               <a:ext uri="{FF2B5EF4-FFF2-40B4-BE49-F238E27FC236}">
-                <a16:creationId xmlns:a16="http://schemas.microsoft.com/office/drawing/2014/main" id="{62EB428C-CFCD-4E6E-AF93-B17B819605E5}"/>
+                <a16:creationId xmlns:a16="http://schemas.microsoft.com/office/drawing/2014/main" id="{8B0BA5E6-C7CD-407C-A1B9-F35CBE9A62E8}"/>
               </a:ext>
             </a:extLst>
           </p:cNvPr>
@@ -4121,7 +4121,7 @@
           <p:cNvPr id="12" name="evidence-THREE-value">
             <a:extLst xmlns:a="http://schemas.openxmlformats.org/drawingml/2006/main">
               <a:ext uri="{FF2B5EF4-FFF2-40B4-BE49-F238E27FC236}">
-                <a16:creationId xmlns:a16="http://schemas.microsoft.com/office/drawing/2014/main" id="{C7A62892-6B09-49AA-8B90-6537BF29BC94}"/>
+                <a16:creationId xmlns:a16="http://schemas.microsoft.com/office/drawing/2014/main" id="{B7C721C7-47E4-4EC5-821E-C3115FC4571D}"/>
               </a:ext>
             </a:extLst>
           </p:cNvPr>
@@ -4173,7 +4173,7 @@
           <p:cNvPr id="13" name="evidence-THREE-claim">
             <a:extLst xmlns:a="http://schemas.openxmlformats.org/drawingml/2006/main">
               <a:ext uri="{FF2B5EF4-FFF2-40B4-BE49-F238E27FC236}">
-                <a16:creationId xmlns:a16="http://schemas.microsoft.com/office/drawing/2014/main" id="{8C9CE24E-FD19-4D4A-B1B6-F9767E00D71F}"/>
+                <a16:creationId xmlns:a16="http://schemas.microsoft.com/office/drawing/2014/main" id="{B015E4A7-ECA5-4935-AD06-2683B76CA7D5}"/>
               </a:ext>
             </a:extLst>
           </p:cNvPr>
@@ -4225,7 +4225,7 @@
           <p:cNvPr id="14" name="evidence-THREE-source">
             <a:extLst xmlns:a="http://schemas.openxmlformats.org/drawingml/2006/main">
               <a:ext uri="{FF2B5EF4-FFF2-40B4-BE49-F238E27FC236}">
-                <a16:creationId xmlns:a16="http://schemas.microsoft.com/office/drawing/2014/main" id="{68857F4C-9A62-4E6C-BD5A-9B00DE820360}"/>
+                <a16:creationId xmlns:a16="http://schemas.microsoft.com/office/drawing/2014/main" id="{3EA0ACBF-A4FD-4517-AF57-94E80E2E8390}"/>
               </a:ext>
             </a:extLst>
           </p:cNvPr>
@@ -4274,10 +4274,10 @@
       </p:sp>
       <p:sp>
         <p:nvSpPr>
-          <p:cNvPr id="15" name="footer-wordmark-1.0.1">
-            <a:extLst xmlns:a="http://schemas.openxmlformats.org/drawingml/2006/main">
-              <a:ext uri="{FF2B5EF4-FFF2-40B4-BE49-F238E27FC236}">
-                <a16:creationId xmlns:a16="http://schemas.microsoft.com/office/drawing/2014/main" id="{BDA6E332-1AA3-4359-ADD7-0447B1A394FC}"/>
+          <p:cNvPr id="15" name="footer-wordmark-1.1.0">
+            <a:extLst xmlns:a="http://schemas.openxmlformats.org/drawingml/2006/main">
+              <a:ext uri="{FF2B5EF4-FFF2-40B4-BE49-F238E27FC236}">
+                <a16:creationId xmlns:a16="http://schemas.microsoft.com/office/drawing/2014/main" id="{4132AE4A-963C-47E3-9309-2545731A6270}"/>
               </a:ext>
             </a:extLst>
           </p:cNvPr>
@@ -4326,10 +4326,10 @@
       </p:sp>
       <p:sp>
         <p:nvSpPr>
-          <p:cNvPr id="16" name="footer-folio-1.0.1">
-            <a:extLst xmlns:a="http://schemas.openxmlformats.org/drawingml/2006/main">
-              <a:ext uri="{FF2B5EF4-FFF2-40B4-BE49-F238E27FC236}">
-                <a16:creationId xmlns:a16="http://schemas.microsoft.com/office/drawing/2014/main" id="{2B183F8D-5F06-474A-B0AE-FAAC9CCA745B}"/>
+          <p:cNvPr id="16" name="footer-folio-1.1.0">
+            <a:extLst xmlns:a="http://schemas.openxmlformats.org/drawingml/2006/main">
+              <a:ext uri="{FF2B5EF4-FFF2-40B4-BE49-F238E27FC236}">
+                <a16:creationId xmlns:a16="http://schemas.microsoft.com/office/drawing/2014/main" id="{9581229F-D711-410F-BF1E-9F953EDA375E}"/>
               </a:ext>
             </a:extLst>
           </p:cNvPr>
@@ -4371,7 +4371,7 @@
                 </a:solidFill>
                 <a:latin typeface="IBM Plex Mono"/>
               </a:rPr>
-              <a:t>MASLOW AI · 1.0.1</a:t>
+              <a:t>MASLOW AI · 1.1.0</a:t>
             </a:r>
           </a:p>
         </p:txBody>
@@ -4379,7 +4379,7 @@
     </p:spTree>
     <p:extLst>
       <p:ext uri="{BB962C8B-B14F-4D97-AF65-F5344CB8AC3E}">
-        <p14:creationId xmlns:p14="http://schemas.microsoft.com/office/powerpoint/2010/main" val="339765449"/>
+        <p14:creationId xmlns:p14="http://schemas.microsoft.com/office/powerpoint/2010/main" val="487022242"/>
       </p:ext>
     </p:extLst>
   </p:cSld>
@@ -4410,7 +4410,7 @@
           <p:cNvPr id="5" name="quote-mark">
             <a:extLst xmlns:a="http://schemas.openxmlformats.org/drawingml/2006/main">
               <a:ext uri="{FF2B5EF4-FFF2-40B4-BE49-F238E27FC236}">
-                <a16:creationId xmlns:a16="http://schemas.microsoft.com/office/drawing/2014/main" id="{A9B64012-2036-4857-A0E7-A754394A599C}"/>
+                <a16:creationId xmlns:a16="http://schemas.microsoft.com/office/drawing/2014/main" id="{C99F236E-4589-484C-A5DF-F91B648E10FA}"/>
               </a:ext>
             </a:extLst>
           </p:cNvPr>
@@ -4462,7 +4462,7 @@
           <p:cNvPr id="2" name="quote-text">
             <a:extLst xmlns:a="http://schemas.openxmlformats.org/drawingml/2006/main">
               <a:ext uri="{FF2B5EF4-FFF2-40B4-BE49-F238E27FC236}">
-                <a16:creationId xmlns:a16="http://schemas.microsoft.com/office/drawing/2014/main" id="{B6366759-B70B-4541-86A3-DC1C95D8A341}"/>
+                <a16:creationId xmlns:a16="http://schemas.microsoft.com/office/drawing/2014/main" id="{9F0CF28F-EBAD-4228-BB45-334597AC58A0}"/>
               </a:ext>
             </a:extLst>
           </p:cNvPr>
@@ -4514,7 +4514,7 @@
           <p:cNvPr id="3" name="quote-attribution">
             <a:extLst xmlns:a="http://schemas.openxmlformats.org/drawingml/2006/main">
               <a:ext uri="{FF2B5EF4-FFF2-40B4-BE49-F238E27FC236}">
-                <a16:creationId xmlns:a16="http://schemas.microsoft.com/office/drawing/2014/main" id="{80A3613B-9F2A-443F-B9C2-CCD831507F1E}"/>
+                <a16:creationId xmlns:a16="http://schemas.microsoft.com/office/drawing/2014/main" id="{147304B7-711C-4745-884D-E82836D0D691}"/>
               </a:ext>
             </a:extLst>
           </p:cNvPr>
@@ -4566,7 +4566,7 @@
           <p:cNvPr id="4" name="quote-source">
             <a:extLst xmlns:a="http://schemas.openxmlformats.org/drawingml/2006/main">
               <a:ext uri="{FF2B5EF4-FFF2-40B4-BE49-F238E27FC236}">
-                <a16:creationId xmlns:a16="http://schemas.microsoft.com/office/drawing/2014/main" id="{42299E4E-0083-4A4A-88BF-4798878E37E5}"/>
+                <a16:creationId xmlns:a16="http://schemas.microsoft.com/office/drawing/2014/main" id="{77C2DB1D-3DC8-4313-9C90-2407CCA36D7B}"/>
               </a:ext>
             </a:extLst>
           </p:cNvPr>
@@ -4616,7 +4616,7 @@
     </p:spTree>
     <p:extLst>
       <p:ext uri="{BB962C8B-B14F-4D97-AF65-F5344CB8AC3E}">
-        <p14:creationId xmlns:p14="http://schemas.microsoft.com/office/powerpoint/2010/main" val="2048449560"/>
+        <p14:creationId xmlns:p14="http://schemas.microsoft.com/office/powerpoint/2010/main" val="1197759139"/>
       </p:ext>
     </p:extLst>
   </p:cSld>
@@ -4651,7 +4651,7 @@
           <p:nvPr/>
         </p:nvPicPr>
         <p:blipFill>
-          <a:blip xmlns:r="http://schemas.openxmlformats.org/officeDocument/2006/relationships" xmlns:a="http://schemas.openxmlformats.org/drawingml/2006/main" r:embed="Re4d4575e7f404fe7"/>
+          <a:blip xmlns:r="http://schemas.openxmlformats.org/officeDocument/2006/relationships" xmlns:a="http://schemas.openxmlformats.org/drawingml/2006/main" r:embed="Rfba00062827846e2"/>
           <a:stretch xmlns:a="http://schemas.openxmlformats.org/drawingml/2006/main"/>
         </p:blipFill>
         <p:spPr>
@@ -4669,7 +4669,7 @@
           <p:cNvPr id="2" name="closing-heading">
             <a:extLst xmlns:a="http://schemas.openxmlformats.org/drawingml/2006/main">
               <a:ext uri="{FF2B5EF4-FFF2-40B4-BE49-F238E27FC236}">
-                <a16:creationId xmlns:a16="http://schemas.microsoft.com/office/drawing/2014/main" id="{1271DD22-2DB8-4828-9525-8920C3095679}"/>
+                <a16:creationId xmlns:a16="http://schemas.microsoft.com/office/drawing/2014/main" id="{AE857C88-C3CE-43C3-937E-3FB728418019}"/>
               </a:ext>
             </a:extLst>
           </p:cNvPr>
@@ -4721,7 +4721,7 @@
           <p:cNvPr id="3" name="closing-action">
             <a:extLst xmlns:a="http://schemas.openxmlformats.org/drawingml/2006/main">
               <a:ext uri="{FF2B5EF4-FFF2-40B4-BE49-F238E27FC236}">
-                <a16:creationId xmlns:a16="http://schemas.microsoft.com/office/drawing/2014/main" id="{F76119AB-0A0F-4ECC-93AC-AEFBC4B9D310}"/>
+                <a16:creationId xmlns:a16="http://schemas.microsoft.com/office/drawing/2014/main" id="{B341D537-9F36-4568-B34B-A2DD10C46F0F}"/>
               </a:ext>
             </a:extLst>
           </p:cNvPr>
@@ -4752,7 +4752,7 @@
           <p:cNvPr id="4" name="closing-action-label">
             <a:extLst xmlns:a="http://schemas.openxmlformats.org/drawingml/2006/main">
               <a:ext uri="{FF2B5EF4-FFF2-40B4-BE49-F238E27FC236}">
-                <a16:creationId xmlns:a16="http://schemas.microsoft.com/office/drawing/2014/main" id="{F00AEAFF-D271-44EB-ABD5-5ABC58F2BAB4}"/>
+                <a16:creationId xmlns:a16="http://schemas.microsoft.com/office/drawing/2014/main" id="{A68313CD-3A4A-40D4-9B20-514C3B80F0A9}"/>
               </a:ext>
             </a:extLst>
           </p:cNvPr>
@@ -4804,7 +4804,7 @@
           <p:cNvPr id="5" name="closing-action-signal">
             <a:extLst xmlns:a="http://schemas.openxmlformats.org/drawingml/2006/main">
               <a:ext uri="{FF2B5EF4-FFF2-40B4-BE49-F238E27FC236}">
-                <a16:creationId xmlns:a16="http://schemas.microsoft.com/office/drawing/2014/main" id="{244CEB53-52D7-4BDD-8955-302066B493E3}"/>
+                <a16:creationId xmlns:a16="http://schemas.microsoft.com/office/drawing/2014/main" id="{C5C84CEE-FF5C-44EC-B9E4-D3A818AE94B8}"/>
               </a:ext>
             </a:extLst>
           </p:cNvPr>
@@ -4835,7 +4835,7 @@
           <p:cNvPr id="6" name="closing-contact">
             <a:extLst xmlns:a="http://schemas.openxmlformats.org/drawingml/2006/main">
               <a:ext uri="{FF2B5EF4-FFF2-40B4-BE49-F238E27FC236}">
-                <a16:creationId xmlns:a16="http://schemas.microsoft.com/office/drawing/2014/main" id="{2FCD7C76-1067-4A41-AA64-5A3A1D9AC880}"/>
+                <a16:creationId xmlns:a16="http://schemas.microsoft.com/office/drawing/2014/main" id="{13E57951-8661-4F45-85FF-CC5F11416519}"/>
               </a:ext>
             </a:extLst>
           </p:cNvPr>
@@ -4884,10 +4884,10 @@
       </p:sp>
       <p:sp>
         <p:nvSpPr>
-          <p:cNvPr id="7" name="footer-wordmark-1.0.1">
-            <a:extLst xmlns:a="http://schemas.openxmlformats.org/drawingml/2006/main">
-              <a:ext uri="{FF2B5EF4-FFF2-40B4-BE49-F238E27FC236}">
-                <a16:creationId xmlns:a16="http://schemas.microsoft.com/office/drawing/2014/main" id="{F1052A9D-23A1-4F64-917E-F7FE289DEF69}"/>
+          <p:cNvPr id="7" name="footer-wordmark-1.1.0">
+            <a:extLst xmlns:a="http://schemas.openxmlformats.org/drawingml/2006/main">
+              <a:ext uri="{FF2B5EF4-FFF2-40B4-BE49-F238E27FC236}">
+                <a16:creationId xmlns:a16="http://schemas.microsoft.com/office/drawing/2014/main" id="{B29BD7D4-E216-41D1-8635-75150A122C3A}"/>
               </a:ext>
             </a:extLst>
           </p:cNvPr>
@@ -4936,10 +4936,10 @@
       </p:sp>
       <p:sp>
         <p:nvSpPr>
-          <p:cNvPr id="8" name="footer-folio-1.0.1">
-            <a:extLst xmlns:a="http://schemas.openxmlformats.org/drawingml/2006/main">
-              <a:ext uri="{FF2B5EF4-FFF2-40B4-BE49-F238E27FC236}">
-                <a16:creationId xmlns:a16="http://schemas.microsoft.com/office/drawing/2014/main" id="{6211CA7C-2C04-4ADF-87D7-3B77DA773A1F}"/>
+          <p:cNvPr id="8" name="footer-folio-1.1.0">
+            <a:extLst xmlns:a="http://schemas.openxmlformats.org/drawingml/2006/main">
+              <a:ext uri="{FF2B5EF4-FFF2-40B4-BE49-F238E27FC236}">
+                <a16:creationId xmlns:a16="http://schemas.microsoft.com/office/drawing/2014/main" id="{56B07807-4BA0-439E-B7D2-498139F6755E}"/>
               </a:ext>
             </a:extLst>
           </p:cNvPr>
@@ -4981,7 +4981,7 @@
                 </a:solidFill>
                 <a:latin typeface="IBM Plex Mono"/>
               </a:rPr>
-              <a:t>MASLOW AI · 1.0.1</a:t>
+              <a:t>MASLOW AI · 1.1.0</a:t>
             </a:r>
           </a:p>
         </p:txBody>
@@ -4989,7 +4989,7 @@
     </p:spTree>
     <p:extLst>
       <p:ext uri="{BB962C8B-B14F-4D97-AF65-F5344CB8AC3E}">
-        <p14:creationId xmlns:p14="http://schemas.microsoft.com/office/powerpoint/2010/main" val="296133631"/>
+        <p14:creationId xmlns:p14="http://schemas.microsoft.com/office/powerpoint/2010/main" val="212934573"/>
       </p:ext>
     </p:extLst>
   </p:cSld>
@@ -4999,7 +4999,7 @@
 <file path=ppt/theme/theme1.xml><?xml version="1.0" encoding="utf-8"?>
 <a:theme xmlns:a="http://schemas.openxmlformats.org/drawingml/2006/main" name="ChatGPT">
   <a:themeElements>
-    <a:clrScheme name="Maslow Brand OS 1.0.1">
+    <a:clrScheme name="Maslow Brand OS 1.1.0">
       <a:dk1>
         <a:srgbClr val="333333"/>
       </a:dk1>
@@ -5049,7 +5049,7 @@
         <a:cs typeface="Calibri"/>
       </a:minorFont>
     </a:fontScheme>
-    <a:fmtScheme name="Maslow Brand OS 1.0.1">
+    <a:fmtScheme name="Maslow Brand OS 1.1.0">
       <a:fillStyleLst>
         <a:solidFill>
           <a:schemeClr val="phClr"/>

</xml_diff>

<commit_message>
fix(release): make Brand OS artifacts reproducible
</commit_message>
<xml_diff>
--- a/artifacts/blind-build/maslow-workflow-brief.pptx
+++ b/artifacts/blind-build/maslow-workflow-brief.pptx
@@ -2,19 +2,19 @@
 <file path=ppt/presentation.xml><?xml version="1.0" encoding="utf-8"?>
 <p:presentation xmlns:p="http://schemas.openxmlformats.org/presentationml/2006/main">
   <p:sldMasterIdLst>
-    <p:sldMasterId xmlns:r="http://schemas.openxmlformats.org/officeDocument/2006/relationships" id="2147483648" r:id="R8d702a1fd4a547b3"/>
-    <p:sldMasterId xmlns:r="http://schemas.openxmlformats.org/officeDocument/2006/relationships" id="2147483650" r:id="R523a98e814fb4622"/>
+    <p:sldMasterId xmlns:r="http://schemas.openxmlformats.org/officeDocument/2006/relationships" id="2147483648" r:id="rId9"/>
+    <p:sldMasterId xmlns:r="http://schemas.openxmlformats.org/officeDocument/2006/relationships" id="2147483650" r:id="rId10"/>
   </p:sldMasterIdLst>
   <p:notesMasterIdLst>
-    <p:notesMasterId xmlns:r="http://schemas.openxmlformats.org/officeDocument/2006/relationships" r:id="Rd915006c725040ad"/>
+    <p:notesMasterId xmlns:r="http://schemas.openxmlformats.org/officeDocument/2006/relationships" r:id="rId1"/>
   </p:notesMasterIdLst>
   <p:sldIdLst>
-    <p:sldId xmlns:r="http://schemas.openxmlformats.org/officeDocument/2006/relationships" id="256" r:id="R7dcc0a5fd1064718"/>
-    <p:sldId xmlns:r="http://schemas.openxmlformats.org/officeDocument/2006/relationships" id="257" r:id="R676bbcbffcf04c22"/>
-    <p:sldId xmlns:r="http://schemas.openxmlformats.org/officeDocument/2006/relationships" id="258" r:id="Rbd528405bff74865"/>
-    <p:sldId xmlns:r="http://schemas.openxmlformats.org/officeDocument/2006/relationships" id="259" r:id="R6ca6a983e8954cbe"/>
-    <p:sldId xmlns:r="http://schemas.openxmlformats.org/officeDocument/2006/relationships" id="260" r:id="Rddfdeabb2f804fa0"/>
-    <p:sldId xmlns:r="http://schemas.openxmlformats.org/officeDocument/2006/relationships" id="261" r:id="Rb1c0f70ee2524a3d"/>
+    <p:sldId xmlns:r="http://schemas.openxmlformats.org/officeDocument/2006/relationships" id="256" r:id="rId3"/>
+    <p:sldId xmlns:r="http://schemas.openxmlformats.org/officeDocument/2006/relationships" id="257" r:id="rId4"/>
+    <p:sldId xmlns:r="http://schemas.openxmlformats.org/officeDocument/2006/relationships" id="258" r:id="rId5"/>
+    <p:sldId xmlns:r="http://schemas.openxmlformats.org/officeDocument/2006/relationships" id="259" r:id="rId6"/>
+    <p:sldId xmlns:r="http://schemas.openxmlformats.org/officeDocument/2006/relationships" id="260" r:id="rId7"/>
+    <p:sldId xmlns:r="http://schemas.openxmlformats.org/officeDocument/2006/relationships" id="261" r:id="rId8"/>
   </p:sldIdLst>
   <p:sldSz cx="12192000" cy="6858000"/>
   <p:notesSz cx="6858000" cy="9144000"/>
@@ -862,7 +862,7 @@
           <p:cNvPr id="2" name="01 Title background">
             <a:extLst xmlns:a="http://schemas.openxmlformats.org/drawingml/2006/main">
               <a:ext uri="{FF2B5EF4-FFF2-40B4-BE49-F238E27FC236}">
-                <a16:creationId xmlns:a16="http://schemas.microsoft.com/office/drawing/2014/main" id="{20DBBF28-D20D-4828-AD77-BA2B3A35E1C3}"/>
+                <a16:creationId xmlns:a16="http://schemas.microsoft.com/office/drawing/2014/main" id="{310190F3-A5DF-55A3-B6C0-43AC89EE7FF6}"/>
               </a:ext>
             </a:extLst>
           </p:cNvPr>
@@ -893,7 +893,7 @@
           <p:cNvPr id="3" name="01 Title title 0">
             <a:extLst xmlns:a="http://schemas.openxmlformats.org/drawingml/2006/main">
               <a:ext uri="{FF2B5EF4-FFF2-40B4-BE49-F238E27FC236}">
-                <a16:creationId xmlns:a16="http://schemas.microsoft.com/office/drawing/2014/main" id="{9F8EED44-119A-4B7A-8BB9-A126E9F359AD}"/>
+                <a16:creationId xmlns:a16="http://schemas.microsoft.com/office/drawing/2014/main" id="{BF3ECDF5-084E-5F6F-836E-EAA19091915D}"/>
               </a:ext>
             </a:extLst>
           </p:cNvPr>
@@ -925,7 +925,7 @@
           <p:cNvPr id="4" name="01 Title subtitle 0">
             <a:extLst xmlns:a="http://schemas.openxmlformats.org/drawingml/2006/main">
               <a:ext uri="{FF2B5EF4-FFF2-40B4-BE49-F238E27FC236}">
-                <a16:creationId xmlns:a16="http://schemas.microsoft.com/office/drawing/2014/main" id="{A4962A81-4D48-4EA7-AC1F-127FD6AF2FCB}"/>
+                <a16:creationId xmlns:a16="http://schemas.microsoft.com/office/drawing/2014/main" id="{9790C2EA-1A6D-5ADB-A006-DB6933ACC03E}"/>
               </a:ext>
             </a:extLst>
           </p:cNvPr>
@@ -974,7 +974,7 @@
           <p:cNvPr id="2" name="02 Section background">
             <a:extLst xmlns:a="http://schemas.openxmlformats.org/drawingml/2006/main">
               <a:ext uri="{FF2B5EF4-FFF2-40B4-BE49-F238E27FC236}">
-                <a16:creationId xmlns:a16="http://schemas.microsoft.com/office/drawing/2014/main" id="{AAA46565-7D66-4390-80A9-A17D86F96CFD}"/>
+                <a16:creationId xmlns:a16="http://schemas.microsoft.com/office/drawing/2014/main" id="{3E2C7BFB-1C52-56BF-B6DE-6D4D2A8F3357}"/>
               </a:ext>
             </a:extLst>
           </p:cNvPr>
@@ -1005,7 +1005,7 @@
           <p:cNvPr id="3" name="02 Section title 0">
             <a:extLst xmlns:a="http://schemas.openxmlformats.org/drawingml/2006/main">
               <a:ext uri="{FF2B5EF4-FFF2-40B4-BE49-F238E27FC236}">
-                <a16:creationId xmlns:a16="http://schemas.microsoft.com/office/drawing/2014/main" id="{B033E4C9-0E65-418F-842D-E1BBF1AD4638}"/>
+                <a16:creationId xmlns:a16="http://schemas.microsoft.com/office/drawing/2014/main" id="{95004533-AA10-5A36-8A0C-F418CF157EA6}"/>
               </a:ext>
             </a:extLst>
           </p:cNvPr>
@@ -1037,7 +1037,7 @@
           <p:cNvPr id="4" name="02 Section subtitle 0">
             <a:extLst xmlns:a="http://schemas.openxmlformats.org/drawingml/2006/main">
               <a:ext uri="{FF2B5EF4-FFF2-40B4-BE49-F238E27FC236}">
-                <a16:creationId xmlns:a16="http://schemas.microsoft.com/office/drawing/2014/main" id="{0FD5675B-9BD4-4CF8-9F8A-8870E32A3F03}"/>
+                <a16:creationId xmlns:a16="http://schemas.microsoft.com/office/drawing/2014/main" id="{66DAC599-2E9B-5E94-AD7D-6DF459FC0750}"/>
               </a:ext>
             </a:extLst>
           </p:cNvPr>
@@ -1086,7 +1086,7 @@
           <p:cNvPr id="2" name="03 Content background">
             <a:extLst xmlns:a="http://schemas.openxmlformats.org/drawingml/2006/main">
               <a:ext uri="{FF2B5EF4-FFF2-40B4-BE49-F238E27FC236}">
-                <a16:creationId xmlns:a16="http://schemas.microsoft.com/office/drawing/2014/main" id="{3FCA4B28-0A5D-4602-86A8-A3983AB5ED3A}"/>
+                <a16:creationId xmlns:a16="http://schemas.microsoft.com/office/drawing/2014/main" id="{D87BB0D0-8F4A-525D-A2AB-E1D33D509886}"/>
               </a:ext>
             </a:extLst>
           </p:cNvPr>
@@ -1117,7 +1117,7 @@
           <p:cNvPr id="3" name="03 Content title 0">
             <a:extLst xmlns:a="http://schemas.openxmlformats.org/drawingml/2006/main">
               <a:ext uri="{FF2B5EF4-FFF2-40B4-BE49-F238E27FC236}">
-                <a16:creationId xmlns:a16="http://schemas.microsoft.com/office/drawing/2014/main" id="{C0454D5B-E70E-48C5-A832-656ADC2B2F8F}"/>
+                <a16:creationId xmlns:a16="http://schemas.microsoft.com/office/drawing/2014/main" id="{ED38757D-C3CD-5DCE-871E-ACCF23CFA5C1}"/>
               </a:ext>
             </a:extLst>
           </p:cNvPr>
@@ -1149,7 +1149,7 @@
           <p:cNvPr id="4" name="03 Content body 0">
             <a:extLst xmlns:a="http://schemas.openxmlformats.org/drawingml/2006/main">
               <a:ext uri="{FF2B5EF4-FFF2-40B4-BE49-F238E27FC236}">
-                <a16:creationId xmlns:a16="http://schemas.microsoft.com/office/drawing/2014/main" id="{ABAA0750-67D1-4E43-A33A-0E1BA378B0B9}"/>
+                <a16:creationId xmlns:a16="http://schemas.microsoft.com/office/drawing/2014/main" id="{2BC6FFDF-9EB8-5016-893F-129CF56C0857}"/>
               </a:ext>
             </a:extLst>
           </p:cNvPr>
@@ -1198,7 +1198,7 @@
           <p:cNvPr id="2" name="04 Evidence background">
             <a:extLst xmlns:a="http://schemas.openxmlformats.org/drawingml/2006/main">
               <a:ext uri="{FF2B5EF4-FFF2-40B4-BE49-F238E27FC236}">
-                <a16:creationId xmlns:a16="http://schemas.microsoft.com/office/drawing/2014/main" id="{2AD15725-EDA9-4418-8568-C0304811D97F}"/>
+                <a16:creationId xmlns:a16="http://schemas.microsoft.com/office/drawing/2014/main" id="{7FD1B23C-9D80-5101-874D-7B6D1874093F}"/>
               </a:ext>
             </a:extLst>
           </p:cNvPr>
@@ -1229,7 +1229,7 @@
           <p:cNvPr id="3" name="04 Evidence title 0">
             <a:extLst xmlns:a="http://schemas.openxmlformats.org/drawingml/2006/main">
               <a:ext uri="{FF2B5EF4-FFF2-40B4-BE49-F238E27FC236}">
-                <a16:creationId xmlns:a16="http://schemas.microsoft.com/office/drawing/2014/main" id="{4221883D-3F27-4EA7-8944-B2261151B808}"/>
+                <a16:creationId xmlns:a16="http://schemas.microsoft.com/office/drawing/2014/main" id="{AC01EC95-7E27-5997-9017-60B8B43DC4EA}"/>
               </a:ext>
             </a:extLst>
           </p:cNvPr>
@@ -1261,7 +1261,7 @@
           <p:cNvPr id="4" name="04 Evidence body 0">
             <a:extLst xmlns:a="http://schemas.openxmlformats.org/drawingml/2006/main">
               <a:ext uri="{FF2B5EF4-FFF2-40B4-BE49-F238E27FC236}">
-                <a16:creationId xmlns:a16="http://schemas.microsoft.com/office/drawing/2014/main" id="{B9752C44-A4E9-4D40-BC67-3CF416456D86}"/>
+                <a16:creationId xmlns:a16="http://schemas.microsoft.com/office/drawing/2014/main" id="{718D0A01-D416-5145-BB47-B3087DCC0152}"/>
               </a:ext>
             </a:extLst>
           </p:cNvPr>
@@ -1310,7 +1310,7 @@
           <p:cNvPr id="2" name="05 Quote background">
             <a:extLst xmlns:a="http://schemas.openxmlformats.org/drawingml/2006/main">
               <a:ext uri="{FF2B5EF4-FFF2-40B4-BE49-F238E27FC236}">
-                <a16:creationId xmlns:a16="http://schemas.microsoft.com/office/drawing/2014/main" id="{BF335948-3450-412D-B5EC-14415DE26E6F}"/>
+                <a16:creationId xmlns:a16="http://schemas.microsoft.com/office/drawing/2014/main" id="{EA03A625-C576-50B9-8010-5A09FC9133B1}"/>
               </a:ext>
             </a:extLst>
           </p:cNvPr>
@@ -1341,7 +1341,7 @@
           <p:cNvPr id="3" name="05 Quote title 0">
             <a:extLst xmlns:a="http://schemas.openxmlformats.org/drawingml/2006/main">
               <a:ext uri="{FF2B5EF4-FFF2-40B4-BE49-F238E27FC236}">
-                <a16:creationId xmlns:a16="http://schemas.microsoft.com/office/drawing/2014/main" id="{7A24F30E-C28A-4018-8226-504196E5E370}"/>
+                <a16:creationId xmlns:a16="http://schemas.microsoft.com/office/drawing/2014/main" id="{02AE9DC2-2DBC-50F9-94A3-242DB207F66C}"/>
               </a:ext>
             </a:extLst>
           </p:cNvPr>
@@ -1373,7 +1373,7 @@
           <p:cNvPr id="4" name="05 Quote subtitle 0">
             <a:extLst xmlns:a="http://schemas.openxmlformats.org/drawingml/2006/main">
               <a:ext uri="{FF2B5EF4-FFF2-40B4-BE49-F238E27FC236}">
-                <a16:creationId xmlns:a16="http://schemas.microsoft.com/office/drawing/2014/main" id="{08CF1993-1501-45B7-9DF0-E9C07F39E0FF}"/>
+                <a16:creationId xmlns:a16="http://schemas.microsoft.com/office/drawing/2014/main" id="{5EA47EC0-2F7A-5850-81B7-707BBB286343}"/>
               </a:ext>
             </a:extLst>
           </p:cNvPr>
@@ -1422,7 +1422,7 @@
           <p:cNvPr id="2" name="06 Closing background">
             <a:extLst xmlns:a="http://schemas.openxmlformats.org/drawingml/2006/main">
               <a:ext uri="{FF2B5EF4-FFF2-40B4-BE49-F238E27FC236}">
-                <a16:creationId xmlns:a16="http://schemas.microsoft.com/office/drawing/2014/main" id="{8EC585C5-D010-4C20-80BA-48BB32D89644}"/>
+                <a16:creationId xmlns:a16="http://schemas.microsoft.com/office/drawing/2014/main" id="{EAD0AA3D-F242-5E86-9CAC-5B3BCEB5B2D3}"/>
               </a:ext>
             </a:extLst>
           </p:cNvPr>
@@ -1453,7 +1453,7 @@
           <p:cNvPr id="3" name="06 Closing title 0">
             <a:extLst xmlns:a="http://schemas.openxmlformats.org/drawingml/2006/main">
               <a:ext uri="{FF2B5EF4-FFF2-40B4-BE49-F238E27FC236}">
-                <a16:creationId xmlns:a16="http://schemas.microsoft.com/office/drawing/2014/main" id="{8621D023-12F4-40BF-AF43-9D57242BA28C}"/>
+                <a16:creationId xmlns:a16="http://schemas.microsoft.com/office/drawing/2014/main" id="{D5D0681F-10AE-52E1-AE2E-6204F99903F5}"/>
               </a:ext>
             </a:extLst>
           </p:cNvPr>
@@ -1485,7 +1485,7 @@
           <p:cNvPr id="4" name="06 Closing subtitle 0">
             <a:extLst xmlns:a="http://schemas.openxmlformats.org/drawingml/2006/main">
               <a:ext uri="{FF2B5EF4-FFF2-40B4-BE49-F238E27FC236}">
-                <a16:creationId xmlns:a16="http://schemas.microsoft.com/office/drawing/2014/main" id="{950B20E8-3CAD-429D-AC13-24E17CB8CC8D}"/>
+                <a16:creationId xmlns:a16="http://schemas.microsoft.com/office/drawing/2014/main" id="{885AD679-944C-568D-AFF3-6A3289FBC63C}"/>
               </a:ext>
             </a:extLst>
           </p:cNvPr>
@@ -1538,7 +1538,7 @@
   </p:cSld>
   <p:clrMap bg1="lt1" tx1="dk1" bg2="lt2" tx2="dk2" accent1="accent1" accent2="accent2" accent3="accent3" accent4="accent4" accent5="accent5" accent6="accent6" hlink="hlink" folHlink="folHlink"/>
   <p:sldLayoutIdLst>
-    <p:sldLayoutId xmlns:r="http://schemas.openxmlformats.org/officeDocument/2006/relationships" id="2147483649" r:id="R8d9edc4a2278453a"/>
+    <p:sldLayoutId xmlns:r="http://schemas.openxmlformats.org/officeDocument/2006/relationships" id="2147483649" r:id="rId1"/>
   </p:sldLayoutIdLst>
   <p:txStyles>
     <p:titleStyle>
@@ -1836,12 +1836,12 @@
   </p:cSld>
   <p:clrMap bg1="lt1" tx1="dk1" bg2="lt2" tx2="dk2" accent1="accent1" accent2="accent2" accent3="accent3" accent4="accent4" accent5="accent5" accent6="accent6" hlink="hlink" folHlink="folHlink"/>
   <p:sldLayoutIdLst>
-    <p:sldLayoutId xmlns:r="http://schemas.openxmlformats.org/officeDocument/2006/relationships" id="2147483651" r:id="R52cec01fb9e14b07"/>
-    <p:sldLayoutId xmlns:r="http://schemas.openxmlformats.org/officeDocument/2006/relationships" id="2147483652" r:id="R3e8aa733ece7470d"/>
-    <p:sldLayoutId xmlns:r="http://schemas.openxmlformats.org/officeDocument/2006/relationships" id="2147483653" r:id="R99b1d8eac67942bb"/>
-    <p:sldLayoutId xmlns:r="http://schemas.openxmlformats.org/officeDocument/2006/relationships" id="2147483654" r:id="Ra204d9c65ecc4a8e"/>
-    <p:sldLayoutId xmlns:r="http://schemas.openxmlformats.org/officeDocument/2006/relationships" id="2147483655" r:id="R1fbc9405f2144821"/>
-    <p:sldLayoutId xmlns:r="http://schemas.openxmlformats.org/officeDocument/2006/relationships" id="2147483656" r:id="R987f9a7a4f2d411d"/>
+    <p:sldLayoutId xmlns:r="http://schemas.openxmlformats.org/officeDocument/2006/relationships" id="2147483651" r:id="rId1"/>
+    <p:sldLayoutId xmlns:r="http://schemas.openxmlformats.org/officeDocument/2006/relationships" id="2147483652" r:id="rId2"/>
+    <p:sldLayoutId xmlns:r="http://schemas.openxmlformats.org/officeDocument/2006/relationships" id="2147483653" r:id="rId3"/>
+    <p:sldLayoutId xmlns:r="http://schemas.openxmlformats.org/officeDocument/2006/relationships" id="2147483654" r:id="rId4"/>
+    <p:sldLayoutId xmlns:r="http://schemas.openxmlformats.org/officeDocument/2006/relationships" id="2147483655" r:id="rId5"/>
+    <p:sldLayoutId xmlns:r="http://schemas.openxmlformats.org/officeDocument/2006/relationships" id="2147483656" r:id="rId6"/>
   </p:sldLayoutIdLst>
 </p:sldMaster>
 </file>
@@ -2364,7 +2364,7 @@
           <p:nvPr/>
         </p:nvPicPr>
         <p:blipFill>
-          <a:blip xmlns:r="http://schemas.openxmlformats.org/officeDocument/2006/relationships" xmlns:a="http://schemas.openxmlformats.org/drawingml/2006/main" r:embed="Rdd91a164216b40af"/>
+          <a:blip xmlns:r="http://schemas.openxmlformats.org/officeDocument/2006/relationships" xmlns:a="http://schemas.openxmlformats.org/drawingml/2006/main" r:embed="rId1"/>
           <a:stretch xmlns:a="http://schemas.openxmlformats.org/drawingml/2006/main"/>
         </p:blipFill>
         <p:spPr>
@@ -2382,7 +2382,7 @@
           <p:cNvPr id="2" name="title-eyebrow">
             <a:extLst xmlns:a="http://schemas.openxmlformats.org/drawingml/2006/main">
               <a:ext uri="{FF2B5EF4-FFF2-40B4-BE49-F238E27FC236}">
-                <a16:creationId xmlns:a16="http://schemas.microsoft.com/office/drawing/2014/main" id="{28C5E484-2624-49D0-A608-E16F4622B60F}"/>
+                <a16:creationId xmlns:a16="http://schemas.microsoft.com/office/drawing/2014/main" id="{EADA48C7-92E3-511D-8FB4-24D974404668}"/>
               </a:ext>
             </a:extLst>
           </p:cNvPr>
@@ -2434,7 +2434,7 @@
           <p:cNvPr id="3" name="title-heading">
             <a:extLst xmlns:a="http://schemas.openxmlformats.org/drawingml/2006/main">
               <a:ext uri="{FF2B5EF4-FFF2-40B4-BE49-F238E27FC236}">
-                <a16:creationId xmlns:a16="http://schemas.microsoft.com/office/drawing/2014/main" id="{4267B848-ED2F-4F85-AB6B-3B0E24C3BACA}"/>
+                <a16:creationId xmlns:a16="http://schemas.microsoft.com/office/drawing/2014/main" id="{D34DE48F-E1F3-5F41-8DB7-BC6DF56A67AD}"/>
               </a:ext>
             </a:extLst>
           </p:cNvPr>
@@ -2486,7 +2486,7 @@
           <p:cNvPr id="4" name="title-subtitle">
             <a:extLst xmlns:a="http://schemas.openxmlformats.org/drawingml/2006/main">
               <a:ext uri="{FF2B5EF4-FFF2-40B4-BE49-F238E27FC236}">
-                <a16:creationId xmlns:a16="http://schemas.microsoft.com/office/drawing/2014/main" id="{A2D06F13-EBD9-485F-82C3-53827BA092E2}"/>
+                <a16:creationId xmlns:a16="http://schemas.microsoft.com/office/drawing/2014/main" id="{BD1D932B-6ED0-533C-B450-F68AD75A6B25}"/>
               </a:ext>
             </a:extLst>
           </p:cNvPr>
@@ -2536,7 +2536,7 @@
     </p:spTree>
     <p:extLst>
       <p:ext uri="{BB962C8B-B14F-4D97-AF65-F5344CB8AC3E}">
-        <p14:creationId xmlns:p14="http://schemas.microsoft.com/office/powerpoint/2010/main" val="1466740697"/>
+        <p14:creationId xmlns:p14="http://schemas.microsoft.com/office/powerpoint/2010/main" val="1456997942"/>
       </p:ext>
     </p:extLst>
   </p:cSld>
@@ -2567,7 +2567,7 @@
           <p:cNvPr id="5" name="section-step-marker">
             <a:extLst xmlns:a="http://schemas.openxmlformats.org/drawingml/2006/main">
               <a:ext uri="{FF2B5EF4-FFF2-40B4-BE49-F238E27FC236}">
-                <a16:creationId xmlns:a16="http://schemas.microsoft.com/office/drawing/2014/main" id="{B97C9461-382D-41A7-856D-F2DD2E53CF32}"/>
+                <a16:creationId xmlns:a16="http://schemas.microsoft.com/office/drawing/2014/main" id="{6A5B9837-AFB3-5A02-BECC-FA0DADC6F3AE}"/>
               </a:ext>
             </a:extLst>
           </p:cNvPr>
@@ -2619,7 +2619,7 @@
           <p:cNvPr id="2" name="section-eyebrow">
             <a:extLst xmlns:a="http://schemas.openxmlformats.org/drawingml/2006/main">
               <a:ext uri="{FF2B5EF4-FFF2-40B4-BE49-F238E27FC236}">
-                <a16:creationId xmlns:a16="http://schemas.microsoft.com/office/drawing/2014/main" id="{60077336-914C-4438-873D-AFE5D91D57FB}"/>
+                <a16:creationId xmlns:a16="http://schemas.microsoft.com/office/drawing/2014/main" id="{E2BD8628-9B18-58EE-8A36-F197DC6E405E}"/>
               </a:ext>
             </a:extLst>
           </p:cNvPr>
@@ -2671,7 +2671,7 @@
           <p:cNvPr id="3" name="section-heading">
             <a:extLst xmlns:a="http://schemas.openxmlformats.org/drawingml/2006/main">
               <a:ext uri="{FF2B5EF4-FFF2-40B4-BE49-F238E27FC236}">
-                <a16:creationId xmlns:a16="http://schemas.microsoft.com/office/drawing/2014/main" id="{8CFA4026-969F-4BC1-A485-10FC165334C5}"/>
+                <a16:creationId xmlns:a16="http://schemas.microsoft.com/office/drawing/2014/main" id="{63351BBF-6896-588A-B67F-E01E50DB21E2}"/>
               </a:ext>
             </a:extLst>
           </p:cNvPr>
@@ -2723,7 +2723,7 @@
           <p:cNvPr id="4" name="section-signal">
             <a:extLst xmlns:a="http://schemas.openxmlformats.org/drawingml/2006/main">
               <a:ext uri="{FF2B5EF4-FFF2-40B4-BE49-F238E27FC236}">
-                <a16:creationId xmlns:a16="http://schemas.microsoft.com/office/drawing/2014/main" id="{8044DC6F-20E4-44CD-AB29-609E20C4861B}"/>
+                <a16:creationId xmlns:a16="http://schemas.microsoft.com/office/drawing/2014/main" id="{CF629152-9524-59FC-8BD0-DF4258959489}"/>
               </a:ext>
             </a:extLst>
           </p:cNvPr>
@@ -2752,7 +2752,7 @@
     </p:spTree>
     <p:extLst>
       <p:ext uri="{BB962C8B-B14F-4D97-AF65-F5344CB8AC3E}">
-        <p14:creationId xmlns:p14="http://schemas.microsoft.com/office/powerpoint/2010/main" val="1202553436"/>
+        <p14:creationId xmlns:p14="http://schemas.microsoft.com/office/powerpoint/2010/main" val="1352405784"/>
       </p:ext>
     </p:extLst>
   </p:cSld>
@@ -2783,7 +2783,7 @@
           <p:cNvPr id="18" name="content-eyebrow">
             <a:extLst xmlns:a="http://schemas.openxmlformats.org/drawingml/2006/main">
               <a:ext uri="{FF2B5EF4-FFF2-40B4-BE49-F238E27FC236}">
-                <a16:creationId xmlns:a16="http://schemas.microsoft.com/office/drawing/2014/main" id="{5A114BE4-522C-4B04-A921-623FFB34F747}"/>
+                <a16:creationId xmlns:a16="http://schemas.microsoft.com/office/drawing/2014/main" id="{49F4F1FB-1527-560E-9E0C-2D0431413614}"/>
               </a:ext>
             </a:extLst>
           </p:cNvPr>
@@ -2835,7 +2835,7 @@
           <p:cNvPr id="2" name="content-heading">
             <a:extLst xmlns:a="http://schemas.openxmlformats.org/drawingml/2006/main">
               <a:ext uri="{FF2B5EF4-FFF2-40B4-BE49-F238E27FC236}">
-                <a16:creationId xmlns:a16="http://schemas.microsoft.com/office/drawing/2014/main" id="{A4562018-218B-4361-BF71-96A2B94460EA}"/>
+                <a16:creationId xmlns:a16="http://schemas.microsoft.com/office/drawing/2014/main" id="{BDA54B1A-B0E7-5197-BA05-AF20B60D8B78}"/>
               </a:ext>
             </a:extLst>
           </p:cNvPr>
@@ -2887,7 +2887,7 @@
           <p:cNvPr id="3" name="content-top-rule">
             <a:extLst xmlns:a="http://schemas.openxmlformats.org/drawingml/2006/main">
               <a:ext uri="{FF2B5EF4-FFF2-40B4-BE49-F238E27FC236}">
-                <a16:creationId xmlns:a16="http://schemas.microsoft.com/office/drawing/2014/main" id="{80D6BD7B-6BB1-495F-A199-F00566A74882}"/>
+                <a16:creationId xmlns:a16="http://schemas.microsoft.com/office/drawing/2014/main" id="{689CAA47-CF3E-5B0E-B6FD-D49EDC325E86}"/>
               </a:ext>
             </a:extLst>
           </p:cNvPr>
@@ -2918,7 +2918,7 @@
           <p:cNvPr id="4" name="content-row-01-number">
             <a:extLst xmlns:a="http://schemas.openxmlformats.org/drawingml/2006/main">
               <a:ext uri="{FF2B5EF4-FFF2-40B4-BE49-F238E27FC236}">
-                <a16:creationId xmlns:a16="http://schemas.microsoft.com/office/drawing/2014/main" id="{104D30CF-1A91-48F0-AE07-69032D4AC8FF}"/>
+                <a16:creationId xmlns:a16="http://schemas.microsoft.com/office/drawing/2014/main" id="{50F66AD4-41A8-55FA-8292-7DA342807CA5}"/>
               </a:ext>
             </a:extLst>
           </p:cNvPr>
@@ -2970,7 +2970,7 @@
           <p:cNvPr id="5" name="content-row-01-heading">
             <a:extLst xmlns:a="http://schemas.openxmlformats.org/drawingml/2006/main">
               <a:ext uri="{FF2B5EF4-FFF2-40B4-BE49-F238E27FC236}">
-                <a16:creationId xmlns:a16="http://schemas.microsoft.com/office/drawing/2014/main" id="{00C11F03-2263-4AC5-A163-634E023F2D65}"/>
+                <a16:creationId xmlns:a16="http://schemas.microsoft.com/office/drawing/2014/main" id="{ED5EC6B2-03BA-561B-867F-4BCD52A79C0A}"/>
               </a:ext>
             </a:extLst>
           </p:cNvPr>
@@ -3022,7 +3022,7 @@
           <p:cNvPr id="6" name="content-row-01-body">
             <a:extLst xmlns:a="http://schemas.openxmlformats.org/drawingml/2006/main">
               <a:ext uri="{FF2B5EF4-FFF2-40B4-BE49-F238E27FC236}">
-                <a16:creationId xmlns:a16="http://schemas.microsoft.com/office/drawing/2014/main" id="{F3CC7234-4193-496B-842F-E8FF52286FB8}"/>
+                <a16:creationId xmlns:a16="http://schemas.microsoft.com/office/drawing/2014/main" id="{70003C15-970A-57A7-BFFD-B4B3E1B7554C}"/>
               </a:ext>
             </a:extLst>
           </p:cNvPr>
@@ -3074,7 +3074,7 @@
           <p:cNvPr id="7" name="content-row-01-rule">
             <a:extLst xmlns:a="http://schemas.openxmlformats.org/drawingml/2006/main">
               <a:ext uri="{FF2B5EF4-FFF2-40B4-BE49-F238E27FC236}">
-                <a16:creationId xmlns:a16="http://schemas.microsoft.com/office/drawing/2014/main" id="{155E0860-B333-458F-9A8D-792DEE5D051E}"/>
+                <a16:creationId xmlns:a16="http://schemas.microsoft.com/office/drawing/2014/main" id="{9B23E3EF-8142-5EA5-A9C7-1712BB23A0E6}"/>
               </a:ext>
             </a:extLst>
           </p:cNvPr>
@@ -3105,7 +3105,7 @@
           <p:cNvPr id="8" name="content-row-02-number">
             <a:extLst xmlns:a="http://schemas.openxmlformats.org/drawingml/2006/main">
               <a:ext uri="{FF2B5EF4-FFF2-40B4-BE49-F238E27FC236}">
-                <a16:creationId xmlns:a16="http://schemas.microsoft.com/office/drawing/2014/main" id="{7463D89E-0195-4008-9916-79E5ACAA563E}"/>
+                <a16:creationId xmlns:a16="http://schemas.microsoft.com/office/drawing/2014/main" id="{351FAB7C-C5DE-5B70-A98B-F41BE8369EFC}"/>
               </a:ext>
             </a:extLst>
           </p:cNvPr>
@@ -3157,7 +3157,7 @@
           <p:cNvPr id="9" name="content-row-02-heading">
             <a:extLst xmlns:a="http://schemas.openxmlformats.org/drawingml/2006/main">
               <a:ext uri="{FF2B5EF4-FFF2-40B4-BE49-F238E27FC236}">
-                <a16:creationId xmlns:a16="http://schemas.microsoft.com/office/drawing/2014/main" id="{11595770-DB9A-4A90-9C87-1C3E9401D809}"/>
+                <a16:creationId xmlns:a16="http://schemas.microsoft.com/office/drawing/2014/main" id="{02D9D106-C56A-587D-A36A-586AE9C12115}"/>
               </a:ext>
             </a:extLst>
           </p:cNvPr>
@@ -3209,7 +3209,7 @@
           <p:cNvPr id="10" name="content-row-02-body">
             <a:extLst xmlns:a="http://schemas.openxmlformats.org/drawingml/2006/main">
               <a:ext uri="{FF2B5EF4-FFF2-40B4-BE49-F238E27FC236}">
-                <a16:creationId xmlns:a16="http://schemas.microsoft.com/office/drawing/2014/main" id="{E85C713B-E023-4787-B516-386331CC46B1}"/>
+                <a16:creationId xmlns:a16="http://schemas.microsoft.com/office/drawing/2014/main" id="{A39D6866-48EF-5287-BD2E-25F3F2DCEC2F}"/>
               </a:ext>
             </a:extLst>
           </p:cNvPr>
@@ -3261,7 +3261,7 @@
           <p:cNvPr id="11" name="content-row-02-rule">
             <a:extLst xmlns:a="http://schemas.openxmlformats.org/drawingml/2006/main">
               <a:ext uri="{FF2B5EF4-FFF2-40B4-BE49-F238E27FC236}">
-                <a16:creationId xmlns:a16="http://schemas.microsoft.com/office/drawing/2014/main" id="{82E5551B-BFA7-496A-AD59-C10B00662563}"/>
+                <a16:creationId xmlns:a16="http://schemas.microsoft.com/office/drawing/2014/main" id="{6C302D8E-7C90-51A3-8310-FB8C7A09D774}"/>
               </a:ext>
             </a:extLst>
           </p:cNvPr>
@@ -3292,7 +3292,7 @@
           <p:cNvPr id="12" name="content-row-03-number">
             <a:extLst xmlns:a="http://schemas.openxmlformats.org/drawingml/2006/main">
               <a:ext uri="{FF2B5EF4-FFF2-40B4-BE49-F238E27FC236}">
-                <a16:creationId xmlns:a16="http://schemas.microsoft.com/office/drawing/2014/main" id="{348658CB-99BF-4797-A326-E4BCEA9EEDE4}"/>
+                <a16:creationId xmlns:a16="http://schemas.microsoft.com/office/drawing/2014/main" id="{641345D4-1399-5DC3-81E8-10B89799D099}"/>
               </a:ext>
             </a:extLst>
           </p:cNvPr>
@@ -3344,7 +3344,7 @@
           <p:cNvPr id="13" name="content-row-03-heading">
             <a:extLst xmlns:a="http://schemas.openxmlformats.org/drawingml/2006/main">
               <a:ext uri="{FF2B5EF4-FFF2-40B4-BE49-F238E27FC236}">
-                <a16:creationId xmlns:a16="http://schemas.microsoft.com/office/drawing/2014/main" id="{A13C7562-CE2A-4673-A488-38E2D30AE781}"/>
+                <a16:creationId xmlns:a16="http://schemas.microsoft.com/office/drawing/2014/main" id="{A0F6DAE0-AD1C-5849-9028-42973277C4F9}"/>
               </a:ext>
             </a:extLst>
           </p:cNvPr>
@@ -3396,7 +3396,7 @@
           <p:cNvPr id="14" name="content-row-03-body">
             <a:extLst xmlns:a="http://schemas.openxmlformats.org/drawingml/2006/main">
               <a:ext uri="{FF2B5EF4-FFF2-40B4-BE49-F238E27FC236}">
-                <a16:creationId xmlns:a16="http://schemas.microsoft.com/office/drawing/2014/main" id="{99FB5377-17E3-47E7-8D30-F86FB3480DBB}"/>
+                <a16:creationId xmlns:a16="http://schemas.microsoft.com/office/drawing/2014/main" id="{54048FFA-6381-539D-9B18-8A502ED664AB}"/>
               </a:ext>
             </a:extLst>
           </p:cNvPr>
@@ -3448,7 +3448,7 @@
           <p:cNvPr id="15" name="content-row-03-rule">
             <a:extLst xmlns:a="http://schemas.openxmlformats.org/drawingml/2006/main">
               <a:ext uri="{FF2B5EF4-FFF2-40B4-BE49-F238E27FC236}">
-                <a16:creationId xmlns:a16="http://schemas.microsoft.com/office/drawing/2014/main" id="{DC1D08F1-EC15-48D4-B2AC-E900D02009D2}"/>
+                <a16:creationId xmlns:a16="http://schemas.microsoft.com/office/drawing/2014/main" id="{A853A0F3-F792-5A73-AA51-DD083073C84A}"/>
               </a:ext>
             </a:extLst>
           </p:cNvPr>
@@ -3479,7 +3479,7 @@
           <p:cNvPr id="16" name="footer-wordmark-1.1.0">
             <a:extLst xmlns:a="http://schemas.openxmlformats.org/drawingml/2006/main">
               <a:ext uri="{FF2B5EF4-FFF2-40B4-BE49-F238E27FC236}">
-                <a16:creationId xmlns:a16="http://schemas.microsoft.com/office/drawing/2014/main" id="{615820CD-F39D-4ACE-8501-7E37C148F5AD}"/>
+                <a16:creationId xmlns:a16="http://schemas.microsoft.com/office/drawing/2014/main" id="{1799B566-9399-54B5-84BD-D7F6BAD97093}"/>
               </a:ext>
             </a:extLst>
           </p:cNvPr>
@@ -3531,7 +3531,7 @@
           <p:cNvPr id="17" name="footer-folio-1.1.0">
             <a:extLst xmlns:a="http://schemas.openxmlformats.org/drawingml/2006/main">
               <a:ext uri="{FF2B5EF4-FFF2-40B4-BE49-F238E27FC236}">
-                <a16:creationId xmlns:a16="http://schemas.microsoft.com/office/drawing/2014/main" id="{D1236267-7228-428D-8E33-7FE08570682A}"/>
+                <a16:creationId xmlns:a16="http://schemas.microsoft.com/office/drawing/2014/main" id="{B12836D9-877E-5A4E-A9C0-1B0D8220CFC5}"/>
               </a:ext>
             </a:extLst>
           </p:cNvPr>
@@ -3581,7 +3581,7 @@
     </p:spTree>
     <p:extLst>
       <p:ext uri="{BB962C8B-B14F-4D97-AF65-F5344CB8AC3E}">
-        <p14:creationId xmlns:p14="http://schemas.microsoft.com/office/powerpoint/2010/main" val="194358582"/>
+        <p14:creationId xmlns:p14="http://schemas.microsoft.com/office/powerpoint/2010/main" val="1583880013"/>
       </p:ext>
     </p:extLst>
   </p:cSld>
@@ -3612,7 +3612,7 @@
           <p:cNvPr id="17" name="evidence-eyebrow">
             <a:extLst xmlns:a="http://schemas.openxmlformats.org/drawingml/2006/main">
               <a:ext uri="{FF2B5EF4-FFF2-40B4-BE49-F238E27FC236}">
-                <a16:creationId xmlns:a16="http://schemas.microsoft.com/office/drawing/2014/main" id="{2F2FED08-E6AB-40DE-BB29-5AC54ABDC5D2}"/>
+                <a16:creationId xmlns:a16="http://schemas.microsoft.com/office/drawing/2014/main" id="{E35C445F-6442-5B0B-9591-45D894EE8B25}"/>
               </a:ext>
             </a:extLst>
           </p:cNvPr>
@@ -3664,7 +3664,7 @@
           <p:cNvPr id="2" name="evidence-heading">
             <a:extLst xmlns:a="http://schemas.openxmlformats.org/drawingml/2006/main">
               <a:ext uri="{FF2B5EF4-FFF2-40B4-BE49-F238E27FC236}">
-                <a16:creationId xmlns:a16="http://schemas.microsoft.com/office/drawing/2014/main" id="{08121910-777B-4BEE-9DF0-2D5BB9BAEA5B}"/>
+                <a16:creationId xmlns:a16="http://schemas.microsoft.com/office/drawing/2014/main" id="{0FE16208-7B54-5CD1-AB6A-276670DFE6D1}"/>
               </a:ext>
             </a:extLst>
           </p:cNvPr>
@@ -3716,7 +3716,7 @@
           <p:cNvPr id="3" name="evidence-ONE-rule">
             <a:extLst xmlns:a="http://schemas.openxmlformats.org/drawingml/2006/main">
               <a:ext uri="{FF2B5EF4-FFF2-40B4-BE49-F238E27FC236}">
-                <a16:creationId xmlns:a16="http://schemas.microsoft.com/office/drawing/2014/main" id="{37AA1BC2-971B-4E9B-8C21-C42E0B4CA1EB}"/>
+                <a16:creationId xmlns:a16="http://schemas.microsoft.com/office/drawing/2014/main" id="{DA46C44D-9189-5B0C-8900-CF0B3BE78902}"/>
               </a:ext>
             </a:extLst>
           </p:cNvPr>
@@ -3747,7 +3747,7 @@
           <p:cNvPr id="4" name="evidence-ONE-value">
             <a:extLst xmlns:a="http://schemas.openxmlformats.org/drawingml/2006/main">
               <a:ext uri="{FF2B5EF4-FFF2-40B4-BE49-F238E27FC236}">
-                <a16:creationId xmlns:a16="http://schemas.microsoft.com/office/drawing/2014/main" id="{462736D9-DB46-48DE-A332-1A30942002E0}"/>
+                <a16:creationId xmlns:a16="http://schemas.microsoft.com/office/drawing/2014/main" id="{AA19070C-37D5-5B71-B577-E011168C6629}"/>
               </a:ext>
             </a:extLst>
           </p:cNvPr>
@@ -3799,7 +3799,7 @@
           <p:cNvPr id="5" name="evidence-ONE-claim">
             <a:extLst xmlns:a="http://schemas.openxmlformats.org/drawingml/2006/main">
               <a:ext uri="{FF2B5EF4-FFF2-40B4-BE49-F238E27FC236}">
-                <a16:creationId xmlns:a16="http://schemas.microsoft.com/office/drawing/2014/main" id="{AFB0F8F4-C816-4609-9613-B0C807A4CC2C}"/>
+                <a16:creationId xmlns:a16="http://schemas.microsoft.com/office/drawing/2014/main" id="{58AB29AC-96A7-584A-976C-C15BC8C4F229}"/>
               </a:ext>
             </a:extLst>
           </p:cNvPr>
@@ -3851,7 +3851,7 @@
           <p:cNvPr id="6" name="evidence-ONE-source">
             <a:extLst xmlns:a="http://schemas.openxmlformats.org/drawingml/2006/main">
               <a:ext uri="{FF2B5EF4-FFF2-40B4-BE49-F238E27FC236}">
-                <a16:creationId xmlns:a16="http://schemas.microsoft.com/office/drawing/2014/main" id="{4898A57A-D172-4357-A63E-5E8291925591}"/>
+                <a16:creationId xmlns:a16="http://schemas.microsoft.com/office/drawing/2014/main" id="{4C181F75-9E91-5A66-8B93-ABC10690D5F7}"/>
               </a:ext>
             </a:extLst>
           </p:cNvPr>
@@ -3903,7 +3903,7 @@
           <p:cNvPr id="7" name="evidence-TWO-rule">
             <a:extLst xmlns:a="http://schemas.openxmlformats.org/drawingml/2006/main">
               <a:ext uri="{FF2B5EF4-FFF2-40B4-BE49-F238E27FC236}">
-                <a16:creationId xmlns:a16="http://schemas.microsoft.com/office/drawing/2014/main" id="{96489E28-6915-4B32-962A-E1DD0FCC1983}"/>
+                <a16:creationId xmlns:a16="http://schemas.microsoft.com/office/drawing/2014/main" id="{52AF0577-26C1-5F13-9B93-164CDC166F1D}"/>
               </a:ext>
             </a:extLst>
           </p:cNvPr>
@@ -3934,7 +3934,7 @@
           <p:cNvPr id="8" name="evidence-TWO-value">
             <a:extLst xmlns:a="http://schemas.openxmlformats.org/drawingml/2006/main">
               <a:ext uri="{FF2B5EF4-FFF2-40B4-BE49-F238E27FC236}">
-                <a16:creationId xmlns:a16="http://schemas.microsoft.com/office/drawing/2014/main" id="{2F4D918C-DBB2-4E20-853C-0DBE6BE31E0C}"/>
+                <a16:creationId xmlns:a16="http://schemas.microsoft.com/office/drawing/2014/main" id="{FEF79354-7449-5DA9-B45B-AFA8B066A943}"/>
               </a:ext>
             </a:extLst>
           </p:cNvPr>
@@ -3986,7 +3986,7 @@
           <p:cNvPr id="9" name="evidence-TWO-claim">
             <a:extLst xmlns:a="http://schemas.openxmlformats.org/drawingml/2006/main">
               <a:ext uri="{FF2B5EF4-FFF2-40B4-BE49-F238E27FC236}">
-                <a16:creationId xmlns:a16="http://schemas.microsoft.com/office/drawing/2014/main" id="{2BA544E3-0D44-4730-B523-668CC4598547}"/>
+                <a16:creationId xmlns:a16="http://schemas.microsoft.com/office/drawing/2014/main" id="{9CBEB932-1493-54AD-857D-D1D64FDE22B5}"/>
               </a:ext>
             </a:extLst>
           </p:cNvPr>
@@ -4038,7 +4038,7 @@
           <p:cNvPr id="10" name="evidence-TWO-source">
             <a:extLst xmlns:a="http://schemas.openxmlformats.org/drawingml/2006/main">
               <a:ext uri="{FF2B5EF4-FFF2-40B4-BE49-F238E27FC236}">
-                <a16:creationId xmlns:a16="http://schemas.microsoft.com/office/drawing/2014/main" id="{FB86C9E9-76F7-486D-A4DB-BE6E96E516B5}"/>
+                <a16:creationId xmlns:a16="http://schemas.microsoft.com/office/drawing/2014/main" id="{E8B636AF-75EE-5709-AE08-6FDF1143A108}"/>
               </a:ext>
             </a:extLst>
           </p:cNvPr>
@@ -4090,7 +4090,7 @@
           <p:cNvPr id="11" name="evidence-THREE-rule">
             <a:extLst xmlns:a="http://schemas.openxmlformats.org/drawingml/2006/main">
               <a:ext uri="{FF2B5EF4-FFF2-40B4-BE49-F238E27FC236}">
-                <a16:creationId xmlns:a16="http://schemas.microsoft.com/office/drawing/2014/main" id="{8B0BA5E6-C7CD-407C-A1B9-F35CBE9A62E8}"/>
+                <a16:creationId xmlns:a16="http://schemas.microsoft.com/office/drawing/2014/main" id="{6AE56476-D154-5DF7-9E76-8FDBFFD3B855}"/>
               </a:ext>
             </a:extLst>
           </p:cNvPr>
@@ -4121,7 +4121,7 @@
           <p:cNvPr id="12" name="evidence-THREE-value">
             <a:extLst xmlns:a="http://schemas.openxmlformats.org/drawingml/2006/main">
               <a:ext uri="{FF2B5EF4-FFF2-40B4-BE49-F238E27FC236}">
-                <a16:creationId xmlns:a16="http://schemas.microsoft.com/office/drawing/2014/main" id="{B7C721C7-47E4-4EC5-821E-C3115FC4571D}"/>
+                <a16:creationId xmlns:a16="http://schemas.microsoft.com/office/drawing/2014/main" id="{4D7DE544-D56D-5FFD-A3BA-97666A35FB4A}"/>
               </a:ext>
             </a:extLst>
           </p:cNvPr>
@@ -4173,7 +4173,7 @@
           <p:cNvPr id="13" name="evidence-THREE-claim">
             <a:extLst xmlns:a="http://schemas.openxmlformats.org/drawingml/2006/main">
               <a:ext uri="{FF2B5EF4-FFF2-40B4-BE49-F238E27FC236}">
-                <a16:creationId xmlns:a16="http://schemas.microsoft.com/office/drawing/2014/main" id="{B015E4A7-ECA5-4935-AD06-2683B76CA7D5}"/>
+                <a16:creationId xmlns:a16="http://schemas.microsoft.com/office/drawing/2014/main" id="{91561FFF-A078-5026-8CC3-783BDC1B5829}"/>
               </a:ext>
             </a:extLst>
           </p:cNvPr>
@@ -4225,7 +4225,7 @@
           <p:cNvPr id="14" name="evidence-THREE-source">
             <a:extLst xmlns:a="http://schemas.openxmlformats.org/drawingml/2006/main">
               <a:ext uri="{FF2B5EF4-FFF2-40B4-BE49-F238E27FC236}">
-                <a16:creationId xmlns:a16="http://schemas.microsoft.com/office/drawing/2014/main" id="{3EA0ACBF-A4FD-4517-AF57-94E80E2E8390}"/>
+                <a16:creationId xmlns:a16="http://schemas.microsoft.com/office/drawing/2014/main" id="{CDB2B932-21CB-50A5-ACF8-99BB96A786D9}"/>
               </a:ext>
             </a:extLst>
           </p:cNvPr>
@@ -4277,7 +4277,7 @@
           <p:cNvPr id="15" name="footer-wordmark-1.1.0">
             <a:extLst xmlns:a="http://schemas.openxmlformats.org/drawingml/2006/main">
               <a:ext uri="{FF2B5EF4-FFF2-40B4-BE49-F238E27FC236}">
-                <a16:creationId xmlns:a16="http://schemas.microsoft.com/office/drawing/2014/main" id="{4132AE4A-963C-47E3-9309-2545731A6270}"/>
+                <a16:creationId xmlns:a16="http://schemas.microsoft.com/office/drawing/2014/main" id="{38A128B0-3040-5C28-8628-ACAF1B08836F}"/>
               </a:ext>
             </a:extLst>
           </p:cNvPr>
@@ -4329,7 +4329,7 @@
           <p:cNvPr id="16" name="footer-folio-1.1.0">
             <a:extLst xmlns:a="http://schemas.openxmlformats.org/drawingml/2006/main">
               <a:ext uri="{FF2B5EF4-FFF2-40B4-BE49-F238E27FC236}">
-                <a16:creationId xmlns:a16="http://schemas.microsoft.com/office/drawing/2014/main" id="{9581229F-D711-410F-BF1E-9F953EDA375E}"/>
+                <a16:creationId xmlns:a16="http://schemas.microsoft.com/office/drawing/2014/main" id="{A1FE5AF1-F69A-5EEA-A86F-0BD55DC52B5F}"/>
               </a:ext>
             </a:extLst>
           </p:cNvPr>
@@ -4379,7 +4379,7 @@
     </p:spTree>
     <p:extLst>
       <p:ext uri="{BB962C8B-B14F-4D97-AF65-F5344CB8AC3E}">
-        <p14:creationId xmlns:p14="http://schemas.microsoft.com/office/powerpoint/2010/main" val="487022242"/>
+        <p14:creationId xmlns:p14="http://schemas.microsoft.com/office/powerpoint/2010/main" val="1468067762"/>
       </p:ext>
     </p:extLst>
   </p:cSld>
@@ -4410,7 +4410,7 @@
           <p:cNvPr id="5" name="quote-mark">
             <a:extLst xmlns:a="http://schemas.openxmlformats.org/drawingml/2006/main">
               <a:ext uri="{FF2B5EF4-FFF2-40B4-BE49-F238E27FC236}">
-                <a16:creationId xmlns:a16="http://schemas.microsoft.com/office/drawing/2014/main" id="{C99F236E-4589-484C-A5DF-F91B648E10FA}"/>
+                <a16:creationId xmlns:a16="http://schemas.microsoft.com/office/drawing/2014/main" id="{C76803E3-23A3-5A7E-8531-43AD9595663A}"/>
               </a:ext>
             </a:extLst>
           </p:cNvPr>
@@ -4462,7 +4462,7 @@
           <p:cNvPr id="2" name="quote-text">
             <a:extLst xmlns:a="http://schemas.openxmlformats.org/drawingml/2006/main">
               <a:ext uri="{FF2B5EF4-FFF2-40B4-BE49-F238E27FC236}">
-                <a16:creationId xmlns:a16="http://schemas.microsoft.com/office/drawing/2014/main" id="{9F0CF28F-EBAD-4228-BB45-334597AC58A0}"/>
+                <a16:creationId xmlns:a16="http://schemas.microsoft.com/office/drawing/2014/main" id="{999A823E-FC6C-504E-A213-B4AD38CF3E8C}"/>
               </a:ext>
             </a:extLst>
           </p:cNvPr>
@@ -4514,7 +4514,7 @@
           <p:cNvPr id="3" name="quote-attribution">
             <a:extLst xmlns:a="http://schemas.openxmlformats.org/drawingml/2006/main">
               <a:ext uri="{FF2B5EF4-FFF2-40B4-BE49-F238E27FC236}">
-                <a16:creationId xmlns:a16="http://schemas.microsoft.com/office/drawing/2014/main" id="{147304B7-711C-4745-884D-E82836D0D691}"/>
+                <a16:creationId xmlns:a16="http://schemas.microsoft.com/office/drawing/2014/main" id="{F651A96E-597E-5724-BBF9-F32B85F34463}"/>
               </a:ext>
             </a:extLst>
           </p:cNvPr>
@@ -4566,7 +4566,7 @@
           <p:cNvPr id="4" name="quote-source">
             <a:extLst xmlns:a="http://schemas.openxmlformats.org/drawingml/2006/main">
               <a:ext uri="{FF2B5EF4-FFF2-40B4-BE49-F238E27FC236}">
-                <a16:creationId xmlns:a16="http://schemas.microsoft.com/office/drawing/2014/main" id="{77C2DB1D-3DC8-4313-9C90-2407CCA36D7B}"/>
+                <a16:creationId xmlns:a16="http://schemas.microsoft.com/office/drawing/2014/main" id="{6F6CC0E8-4ED3-531D-B87A-3B206667C3A4}"/>
               </a:ext>
             </a:extLst>
           </p:cNvPr>
@@ -4616,7 +4616,7 @@
     </p:spTree>
     <p:extLst>
       <p:ext uri="{BB962C8B-B14F-4D97-AF65-F5344CB8AC3E}">
-        <p14:creationId xmlns:p14="http://schemas.microsoft.com/office/powerpoint/2010/main" val="1197759139"/>
+        <p14:creationId xmlns:p14="http://schemas.microsoft.com/office/powerpoint/2010/main" val="628303973"/>
       </p:ext>
     </p:extLst>
   </p:cSld>
@@ -4651,7 +4651,7 @@
           <p:nvPr/>
         </p:nvPicPr>
         <p:blipFill>
-          <a:blip xmlns:r="http://schemas.openxmlformats.org/officeDocument/2006/relationships" xmlns:a="http://schemas.openxmlformats.org/drawingml/2006/main" r:embed="Rfba00062827846e2"/>
+          <a:blip xmlns:r="http://schemas.openxmlformats.org/officeDocument/2006/relationships" xmlns:a="http://schemas.openxmlformats.org/drawingml/2006/main" r:embed="rId1"/>
           <a:stretch xmlns:a="http://schemas.openxmlformats.org/drawingml/2006/main"/>
         </p:blipFill>
         <p:spPr>
@@ -4669,7 +4669,7 @@
           <p:cNvPr id="2" name="closing-heading">
             <a:extLst xmlns:a="http://schemas.openxmlformats.org/drawingml/2006/main">
               <a:ext uri="{FF2B5EF4-FFF2-40B4-BE49-F238E27FC236}">
-                <a16:creationId xmlns:a16="http://schemas.microsoft.com/office/drawing/2014/main" id="{AE857C88-C3CE-43C3-937E-3FB728418019}"/>
+                <a16:creationId xmlns:a16="http://schemas.microsoft.com/office/drawing/2014/main" id="{2E36E15A-7002-5558-B6C3-80324026504F}"/>
               </a:ext>
             </a:extLst>
           </p:cNvPr>
@@ -4721,7 +4721,7 @@
           <p:cNvPr id="3" name="closing-action">
             <a:extLst xmlns:a="http://schemas.openxmlformats.org/drawingml/2006/main">
               <a:ext uri="{FF2B5EF4-FFF2-40B4-BE49-F238E27FC236}">
-                <a16:creationId xmlns:a16="http://schemas.microsoft.com/office/drawing/2014/main" id="{B341D537-9F36-4568-B34B-A2DD10C46F0F}"/>
+                <a16:creationId xmlns:a16="http://schemas.microsoft.com/office/drawing/2014/main" id="{2FC8B57D-D05A-5724-AB90-4789829F2C09}"/>
               </a:ext>
             </a:extLst>
           </p:cNvPr>
@@ -4752,7 +4752,7 @@
           <p:cNvPr id="4" name="closing-action-label">
             <a:extLst xmlns:a="http://schemas.openxmlformats.org/drawingml/2006/main">
               <a:ext uri="{FF2B5EF4-FFF2-40B4-BE49-F238E27FC236}">
-                <a16:creationId xmlns:a16="http://schemas.microsoft.com/office/drawing/2014/main" id="{A68313CD-3A4A-40D4-9B20-514C3B80F0A9}"/>
+                <a16:creationId xmlns:a16="http://schemas.microsoft.com/office/drawing/2014/main" id="{AC7C8004-4394-54A5-A0A7-03145DAEDACB}"/>
               </a:ext>
             </a:extLst>
           </p:cNvPr>
@@ -4804,7 +4804,7 @@
           <p:cNvPr id="5" name="closing-action-signal">
             <a:extLst xmlns:a="http://schemas.openxmlformats.org/drawingml/2006/main">
               <a:ext uri="{FF2B5EF4-FFF2-40B4-BE49-F238E27FC236}">
-                <a16:creationId xmlns:a16="http://schemas.microsoft.com/office/drawing/2014/main" id="{C5C84CEE-FF5C-44EC-B9E4-D3A818AE94B8}"/>
+                <a16:creationId xmlns:a16="http://schemas.microsoft.com/office/drawing/2014/main" id="{4EED0E5E-60A7-5329-9FDF-2A8F989E6798}"/>
               </a:ext>
             </a:extLst>
           </p:cNvPr>
@@ -4835,7 +4835,7 @@
           <p:cNvPr id="6" name="closing-contact">
             <a:extLst xmlns:a="http://schemas.openxmlformats.org/drawingml/2006/main">
               <a:ext uri="{FF2B5EF4-FFF2-40B4-BE49-F238E27FC236}">
-                <a16:creationId xmlns:a16="http://schemas.microsoft.com/office/drawing/2014/main" id="{13E57951-8661-4F45-85FF-CC5F11416519}"/>
+                <a16:creationId xmlns:a16="http://schemas.microsoft.com/office/drawing/2014/main" id="{3443E47E-6AE9-58D5-9E87-F47073A07749}"/>
               </a:ext>
             </a:extLst>
           </p:cNvPr>
@@ -4887,7 +4887,7 @@
           <p:cNvPr id="7" name="footer-wordmark-1.1.0">
             <a:extLst xmlns:a="http://schemas.openxmlformats.org/drawingml/2006/main">
               <a:ext uri="{FF2B5EF4-FFF2-40B4-BE49-F238E27FC236}">
-                <a16:creationId xmlns:a16="http://schemas.microsoft.com/office/drawing/2014/main" id="{B29BD7D4-E216-41D1-8635-75150A122C3A}"/>
+                <a16:creationId xmlns:a16="http://schemas.microsoft.com/office/drawing/2014/main" id="{4A99FAD8-F221-5346-8B17-15D98EA05B93}"/>
               </a:ext>
             </a:extLst>
           </p:cNvPr>
@@ -4939,7 +4939,7 @@
           <p:cNvPr id="8" name="footer-folio-1.1.0">
             <a:extLst xmlns:a="http://schemas.openxmlformats.org/drawingml/2006/main">
               <a:ext uri="{FF2B5EF4-FFF2-40B4-BE49-F238E27FC236}">
-                <a16:creationId xmlns:a16="http://schemas.microsoft.com/office/drawing/2014/main" id="{56B07807-4BA0-439E-B7D2-498139F6755E}"/>
+                <a16:creationId xmlns:a16="http://schemas.microsoft.com/office/drawing/2014/main" id="{C34121BC-EFE0-5BE5-A957-6845D2541FA9}"/>
               </a:ext>
             </a:extLst>
           </p:cNvPr>
@@ -4989,7 +4989,7 @@
     </p:spTree>
     <p:extLst>
       <p:ext uri="{BB962C8B-B14F-4D97-AF65-F5344CB8AC3E}">
-        <p14:creationId xmlns:p14="http://schemas.microsoft.com/office/powerpoint/2010/main" val="212934573"/>
+        <p14:creationId xmlns:p14="http://schemas.microsoft.com/office/powerpoint/2010/main" val="2091892746"/>
       </p:ext>
     </p:extLst>
   </p:cSld>

</xml_diff>